<commit_message>
docs(stocks): slide 8 points to the live Qollab demo (no screenshot), slide 9 is a thank-you slide
The mesh comparison is removed from the deck and from the build script; no placeholder is left on the slides.

Co-Authored-By: Claude Opus 5.5 <noreply@anthropic.com>
</commit_message>
<xml_diff>
--- a/slides/stocks_ZollerQu.pptx
+++ b/slides/stocks_ZollerQu.pptx
@@ -933,7 +933,7 @@
           <a:lstStyle/>
           <a:p>
             <a:r>
-              <a:t>Does it scale? In noiseless simulation up to twenty-nine qubits the circuit stays far above random guessing, but classical heuristics win: they find the best portfolio in 61 percent of runs, the circuit in 7 percent. And our circuit first needed about 4,900 training circuits. We claim no quantum advantage.</a:t>
+              <a:t>In noiseless simulation up to twenty-nine qubits the circuit stays far above random guessing, but classical heuristics win: they find the best portfolio in 61 percent of runs, the circuit in 7 percent. And our circuit first needed about 4,900 training circuits. We claim no quantum advantage.</a:t>
             </a:r>
           </a:p>
         </p:txBody>
@@ -1003,7 +1003,7 @@
           <a:lstStyle/>
           <a:p>
             <a:r>
-              <a:t>[CUT TO LIVE QOLLAB DEMO] On Qollab, press Run, select the IonQ Forte 1 noise model, and one job returns the counts and the plots. [BACK TO SLIDE] Our limits: a noisy simulator, one job, and strong classical baselines. Next: the other selected circuits, shorter circuits, and twenty-nine assets. Thank you. This effort is supported by Qollab and IonQ.</a:t>
+              <a:t>[CUT TO LIVE QOLLAB DEMO] Here is the project on Qollab, with the code in main.py. We press Run, select the IonQ Forte 1 noise model, and one job returns counts and plots. [BACK TO SLIDE] Our limits: a noisy simulator, one job, and strong classical baselines. Next: the other selected circuits, shorter circuits, and twenty-nine assets.</a:t>
             </a:r>
           </a:p>
         </p:txBody>
@@ -1073,7 +1073,7 @@
           <a:lstStyle/>
           <a:p>
             <a:r>
-              <a:t>Backup slide, not spoken. The same pipeline (graph, Ising energy, circuits trained offline, one IonQ job, grading against the exact optimum) was used for both ZollerQu projects.</a:t>
+              <a:t>Thank you for your attention. This effort is supported by Qollab and IonQ.</a:t>
             </a:r>
           </a:p>
         </p:txBody>
@@ -10049,19 +10049,18 @@
         <p:spPr>
           <a:xfrm>
             <a:off x="548640" y="1554480"/>
-            <a:ext cx="5120640" cy="2651760"/>
+            <a:ext cx="5120640" cy="3794760"/>
           </a:xfrm>
           <a:prstGeom prst="roundRect">
             <a:avLst>
-              <a:gd name="adj" fmla="val 4137"/>
+              <a:gd name="adj" fmla="val 2891"/>
             </a:avLst>
           </a:prstGeom>
-          <a:noFill/>
-          <a:ln w="19050">
-            <a:solidFill>
-              <a:srgbClr val="D9791A"/>
-            </a:solidFill>
-            <a:prstDash val="dash"/>
+          <a:solidFill>
+            <a:srgbClr val="131B2E"/>
+          </a:solidFill>
+          <a:ln>
+            <a:noFill/>
           </a:ln>
           <a:effectLst/>
         </p:spPr>
@@ -10095,8 +10094,8 @@
         </p:nvSpPr>
         <p:spPr>
           <a:xfrm>
-            <a:off x="548640" y="2331720"/>
-            <a:ext cx="5120640" cy="993648"/>
+            <a:off x="822960" y="1783080"/>
+            <a:ext cx="4572000" cy="365760"/>
           </a:xfrm>
           <a:prstGeom prst="rect">
             <a:avLst/>
@@ -10109,244 +10108,39 @@
           </a:bodyPr>
           <a:lstStyle/>
           <a:p>
-            <a:pPr algn="ctr">
-              <a:lnSpc>
-                <a:spcPts val="2640"/>
-              </a:lnSpc>
-              <a:spcBef>
-                <a:spcPts val="0"/>
-              </a:spcBef>
-              <a:spcAft>
-                <a:spcPts val="0"/>
-              </a:spcAft>
-            </a:pPr>
-            <a:r>
-              <a:rPr sz="2200" b="1">
-                <a:solidFill>
-                  <a:srgbClr val="D9791A"/>
-                </a:solidFill>
-                <a:latin typeface="Arial"/>
-              </a:rPr>
-              <a:t>[pending] screenshot</a:t>
-            </a:r>
-          </a:p>
-          <a:p>
-            <a:pPr algn="ctr">
-              <a:lnSpc>
-                <a:spcPts val="2160"/>
-              </a:lnSpc>
-              <a:spcBef>
-                <a:spcPts val="432"/>
-              </a:spcBef>
-              <a:spcAft>
-                <a:spcPts val="0"/>
-              </a:spcAft>
-            </a:pPr>
-            <a:r>
-              <a:rPr sz="1800" b="0">
-                <a:solidFill>
-                  <a:srgbClr val="A9B4C6"/>
-                </a:solidFill>
-                <a:latin typeface="Arial"/>
-              </a:rPr>
-              <a:t>Qollab → Run → Select QPU →</a:t>
-            </a:r>
-          </a:p>
-          <a:p>
-            <a:pPr algn="ctr">
-              <a:lnSpc>
-                <a:spcPts val="2160"/>
-              </a:lnSpc>
-              <a:spcBef>
-                <a:spcPts val="432"/>
-              </a:spcBef>
-              <a:spcAft>
-                <a:spcPts val="0"/>
-              </a:spcAft>
-            </a:pPr>
-            <a:r>
-              <a:rPr sz="1800" b="0">
-                <a:solidFill>
-                  <a:srgbClr val="A9B4C6"/>
-                </a:solidFill>
-                <a:latin typeface="Arial"/>
-              </a:rPr>
-              <a:t>IonQ Forte 1 (29q) noise model</a:t>
-            </a:r>
-          </a:p>
-        </p:txBody>
-      </p:sp>
-      <p:sp>
-        <p:nvSpPr>
-          <p:cNvPr id="5" name="TextBox 4"/>
-          <p:cNvSpPr txBox="1"/>
-          <p:nvPr/>
-        </p:nvSpPr>
-        <p:spPr>
-          <a:xfrm>
-            <a:off x="548640" y="4389120"/>
-            <a:ext cx="5120640" cy="822960"/>
-          </a:xfrm>
-          <a:prstGeom prst="rect">
-            <a:avLst/>
-          </a:prstGeom>
-          <a:noFill/>
-        </p:spPr>
-        <p:txBody>
-          <a:bodyPr wrap="square" lIns="0" rIns="0" tIns="0" bIns="0" anchor="t">
-            <a:noAutofit/>
-          </a:bodyPr>
-          <a:lstStyle/>
-          <a:p>
             <a:pPr algn="l">
               <a:lnSpc>
-                <a:spcPts val="2160"/>
-              </a:lnSpc>
-              <a:spcBef>
-                <a:spcPts val="0"/>
-              </a:spcBef>
-              <a:spcAft>
-                <a:spcPts val="0"/>
-              </a:spcAft>
-            </a:pPr>
-            <a:r>
-              <a:rPr sz="1800" b="1">
+                <a:spcPts val="2879"/>
+              </a:lnSpc>
+              <a:spcBef>
+                <a:spcPts val="0"/>
+              </a:spcBef>
+              <a:spcAft>
+                <a:spcPts val="0"/>
+              </a:spcAft>
+            </a:pPr>
+            <a:r>
+              <a:rPr sz="2400" b="1">
                 <a:solidFill>
                   <a:srgbClr val="FFFFFF"/>
                 </a:solidFill>
                 <a:latin typeface="Arial"/>
               </a:rPr>
-              <a:t>Qollab project:  </a:t>
-            </a:r>
-            <a:r>
-              <a:rPr sz="1800" b="0">
-                <a:solidFill>
-                  <a:srgbClr val="D9791A"/>
-                </a:solidFill>
-                <a:latin typeface="Arial"/>
-              </a:rPr>
-              <a:t>[pending]</a:t>
-            </a:r>
-          </a:p>
-          <a:p>
-            <a:pPr algn="l">
-              <a:lnSpc>
-                <a:spcPts val="2160"/>
-              </a:lnSpc>
-              <a:spcBef>
-                <a:spcPts val="0"/>
-              </a:spcBef>
-              <a:spcAft>
-                <a:spcPts val="0"/>
-              </a:spcAft>
-            </a:pPr>
-            <a:r>
-              <a:rPr sz="1800" b="1">
-                <a:solidFill>
-                  <a:srgbClr val="FFFFFF"/>
-                </a:solidFill>
-                <a:latin typeface="Arial"/>
-              </a:rPr>
-              <a:t>GitHub:  </a:t>
-            </a:r>
-            <a:r>
-              <a:rPr sz="1800" b="0">
-                <a:solidFill>
-                  <a:srgbClr val="D9791A"/>
-                </a:solidFill>
-                <a:latin typeface="Arial"/>
-              </a:rPr>
-              <a:t>[pending]</a:t>
-            </a:r>
-          </a:p>
-          <a:p>
-            <a:pPr algn="l">
-              <a:lnSpc>
-                <a:spcPts val="2160"/>
-              </a:lnSpc>
-              <a:spcBef>
-                <a:spcPts val="0"/>
-              </a:spcBef>
-              <a:spcAft>
-                <a:spcPts val="0"/>
-              </a:spcAft>
-            </a:pPr>
-            <a:r>
-              <a:rPr sz="1800" b="1">
-                <a:solidFill>
-                  <a:srgbClr val="FFFFFF"/>
-                </a:solidFill>
-                <a:latin typeface="Arial"/>
-              </a:rPr>
-              <a:t>Video:  </a:t>
-            </a:r>
-            <a:r>
-              <a:rPr sz="1800" b="0">
-                <a:solidFill>
-                  <a:srgbClr val="D9791A"/>
-                </a:solidFill>
-                <a:latin typeface="Arial"/>
-              </a:rPr>
-              <a:t>[pending]</a:t>
-            </a:r>
-          </a:p>
-        </p:txBody>
-      </p:sp>
-      <p:sp>
-        <p:nvSpPr>
-          <p:cNvPr id="6" name="TextBox 5"/>
-          <p:cNvSpPr txBox="1"/>
-          <p:nvPr/>
-        </p:nvSpPr>
-        <p:spPr>
-          <a:xfrm>
-            <a:off x="6172200" y="1554480"/>
-            <a:ext cx="5468112" cy="335280"/>
-          </a:xfrm>
-          <a:prstGeom prst="rect">
-            <a:avLst/>
-          </a:prstGeom>
-          <a:noFill/>
-        </p:spPr>
-        <p:txBody>
-          <a:bodyPr wrap="square" lIns="0" rIns="0" tIns="0" bIns="0" anchor="t">
-            <a:noAutofit/>
-          </a:bodyPr>
-          <a:lstStyle/>
-          <a:p>
-            <a:pPr algn="l">
-              <a:lnSpc>
-                <a:spcPts val="2640"/>
-              </a:lnSpc>
-              <a:spcBef>
-                <a:spcPts val="0"/>
-              </a:spcBef>
-              <a:spcAft>
-                <a:spcPts val="0"/>
-              </a:spcAft>
-            </a:pPr>
-            <a:r>
-              <a:rPr sz="2200" b="1">
-                <a:solidFill>
-                  <a:srgbClr val="FFFFFF"/>
-                </a:solidFill>
-                <a:latin typeface="Arial"/>
-              </a:rPr>
-              <a:t>Honest limits</a:t>
-            </a:r>
-          </a:p>
-        </p:txBody>
-      </p:sp>
-      <p:sp>
-        <p:nvSpPr>
-          <p:cNvPr id="7" name="Oval 6"/>
+              <a:t>Live demo on Qollab</a:t>
+            </a:r>
+          </a:p>
+        </p:txBody>
+      </p:sp>
+      <p:sp>
+        <p:nvSpPr>
+          <p:cNvPr id="5" name="Oval 4"/>
           <p:cNvSpPr/>
           <p:nvPr/>
         </p:nvSpPr>
         <p:spPr>
           <a:xfrm>
-            <a:off x="6172200" y="2122932"/>
-            <a:ext cx="100584" cy="100584"/>
+            <a:off x="822960" y="2523744"/>
+            <a:ext cx="457200" cy="457200"/>
           </a:xfrm>
           <a:prstGeom prst="ellipse">
             <a:avLst/>
@@ -10383,14 +10177,14 @@
       </p:sp>
       <p:sp>
         <p:nvSpPr>
-          <p:cNvPr id="8" name="TextBox 7"/>
+          <p:cNvPr id="6" name="TextBox 5"/>
           <p:cNvSpPr txBox="1"/>
           <p:nvPr/>
         </p:nvSpPr>
         <p:spPr>
           <a:xfrm>
-            <a:off x="6446520" y="2036064"/>
-            <a:ext cx="5193792" cy="274320"/>
+            <a:off x="822960" y="2606040"/>
+            <a:ext cx="457200" cy="274320"/>
           </a:xfrm>
           <a:prstGeom prst="rect">
             <a:avLst/>
@@ -10403,39 +10197,106 @@
           </a:bodyPr>
           <a:lstStyle/>
           <a:p>
+            <a:pPr algn="ctr">
+              <a:lnSpc>
+                <a:spcPts val="2160"/>
+              </a:lnSpc>
+              <a:spcBef>
+                <a:spcPts val="0"/>
+              </a:spcBef>
+              <a:spcAft>
+                <a:spcPts val="0"/>
+              </a:spcAft>
+            </a:pPr>
+            <a:r>
+              <a:rPr sz="1800" b="1">
+                <a:solidFill>
+                  <a:srgbClr val="FFFFFF"/>
+                </a:solidFill>
+                <a:latin typeface="Arial"/>
+              </a:rPr>
+              <a:t>1</a:t>
+            </a:r>
+          </a:p>
+        </p:txBody>
+      </p:sp>
+      <p:sp>
+        <p:nvSpPr>
+          <p:cNvPr id="7" name="TextBox 6"/>
+          <p:cNvSpPr txBox="1"/>
+          <p:nvPr/>
+        </p:nvSpPr>
+        <p:spPr>
+          <a:xfrm>
+            <a:off x="1508760" y="2441448"/>
+            <a:ext cx="4023360" cy="609600"/>
+          </a:xfrm>
+          <a:prstGeom prst="rect">
+            <a:avLst/>
+          </a:prstGeom>
+          <a:noFill/>
+        </p:spPr>
+        <p:txBody>
+          <a:bodyPr wrap="square" lIns="0" rIns="0" tIns="0" bIns="0" anchor="t">
+            <a:noAutofit/>
+          </a:bodyPr>
+          <a:lstStyle/>
+          <a:p>
             <a:pPr algn="l">
               <a:lnSpc>
-                <a:spcPts val="2160"/>
-              </a:lnSpc>
-              <a:spcBef>
-                <a:spcPts val="0"/>
-              </a:spcBef>
-              <a:spcAft>
-                <a:spcPts val="0"/>
-              </a:spcAft>
-            </a:pPr>
-            <a:r>
-              <a:rPr sz="1800" b="0">
+                <a:spcPts val="2400"/>
+              </a:lnSpc>
+              <a:spcBef>
+                <a:spcPts val="0"/>
+              </a:spcBef>
+              <a:spcAft>
+                <a:spcPts val="0"/>
+              </a:spcAft>
+            </a:pPr>
+            <a:r>
+              <a:rPr sz="2000" b="0">
                 <a:solidFill>
                   <a:srgbClr val="FFFFFF"/>
                 </a:solidFill>
                 <a:latin typeface="Arial"/>
               </a:rPr>
-              <a:t>A noisy simulator: one job of 1,000 shots</a:t>
-            </a:r>
-          </a:p>
-        </p:txBody>
-      </p:sp>
-      <p:sp>
-        <p:nvSpPr>
-          <p:cNvPr id="9" name="Oval 8"/>
+              <a:t>Open the project:</a:t>
+            </a:r>
+          </a:p>
+          <a:p>
+            <a:pPr algn="l">
+              <a:lnSpc>
+                <a:spcPts val="2400"/>
+              </a:lnSpc>
+              <a:spcBef>
+                <a:spcPts val="0"/>
+              </a:spcBef>
+              <a:spcAft>
+                <a:spcPts val="0"/>
+              </a:spcAft>
+            </a:pPr>
+            <a:r>
+              <a:rPr sz="2000" b="0">
+                <a:solidFill>
+                  <a:srgbClr val="FFFFFF"/>
+                </a:solidFill>
+                <a:latin typeface="Arial"/>
+              </a:rPr>
+              <a:t>the code is in main.py</a:t>
+            </a:r>
+          </a:p>
+        </p:txBody>
+      </p:sp>
+      <p:sp>
+        <p:nvSpPr>
+          <p:cNvPr id="8" name="Oval 7"/>
           <p:cNvSpPr/>
           <p:nvPr/>
         </p:nvSpPr>
         <p:spPr>
           <a:xfrm>
-            <a:off x="6172200" y="2525268"/>
-            <a:ext cx="100584" cy="100584"/>
+            <a:off x="822960" y="3499104"/>
+            <a:ext cx="457200" cy="457200"/>
           </a:xfrm>
           <a:prstGeom prst="ellipse">
             <a:avLst/>
@@ -10472,14 +10333,14 @@
       </p:sp>
       <p:sp>
         <p:nvSpPr>
-          <p:cNvPr id="10" name="TextBox 9"/>
+          <p:cNvPr id="9" name="TextBox 8"/>
           <p:cNvSpPr txBox="1"/>
           <p:nvPr/>
         </p:nvSpPr>
         <p:spPr>
           <a:xfrm>
-            <a:off x="6446520" y="2438400"/>
-            <a:ext cx="5193792" cy="274320"/>
+            <a:off x="822960" y="3581400"/>
+            <a:ext cx="457200" cy="274320"/>
           </a:xfrm>
           <a:prstGeom prst="rect">
             <a:avLst/>
@@ -10492,25 +10353,92 @@
           </a:bodyPr>
           <a:lstStyle/>
           <a:p>
+            <a:pPr algn="ctr">
+              <a:lnSpc>
+                <a:spcPts val="2160"/>
+              </a:lnSpc>
+              <a:spcBef>
+                <a:spcPts val="0"/>
+              </a:spcBef>
+              <a:spcAft>
+                <a:spcPts val="0"/>
+              </a:spcAft>
+            </a:pPr>
+            <a:r>
+              <a:rPr sz="1800" b="1">
+                <a:solidFill>
+                  <a:srgbClr val="FFFFFF"/>
+                </a:solidFill>
+                <a:latin typeface="Arial"/>
+              </a:rPr>
+              <a:t>2</a:t>
+            </a:r>
+          </a:p>
+        </p:txBody>
+      </p:sp>
+      <p:sp>
+        <p:nvSpPr>
+          <p:cNvPr id="10" name="TextBox 9"/>
+          <p:cNvSpPr txBox="1"/>
+          <p:nvPr/>
+        </p:nvSpPr>
+        <p:spPr>
+          <a:xfrm>
+            <a:off x="1508760" y="3416808"/>
+            <a:ext cx="4023360" cy="609600"/>
+          </a:xfrm>
+          <a:prstGeom prst="rect">
+            <a:avLst/>
+          </a:prstGeom>
+          <a:noFill/>
+        </p:spPr>
+        <p:txBody>
+          <a:bodyPr wrap="square" lIns="0" rIns="0" tIns="0" bIns="0" anchor="t">
+            <a:noAutofit/>
+          </a:bodyPr>
+          <a:lstStyle/>
+          <a:p>
             <a:pPr algn="l">
               <a:lnSpc>
-                <a:spcPts val="2160"/>
-              </a:lnSpc>
-              <a:spcBef>
-                <a:spcPts val="0"/>
-              </a:spcBef>
-              <a:spcAft>
-                <a:spcPts val="0"/>
-              </a:spcAft>
-            </a:pPr>
-            <a:r>
-              <a:rPr sz="1800" b="0">
+                <a:spcPts val="2400"/>
+              </a:lnSpc>
+              <a:spcBef>
+                <a:spcPts val="0"/>
+              </a:spcBef>
+              <a:spcAft>
+                <a:spcPts val="0"/>
+              </a:spcAft>
+            </a:pPr>
+            <a:r>
+              <a:rPr sz="2000" b="0">
                 <a:solidFill>
                   <a:srgbClr val="FFFFFF"/>
                 </a:solidFill>
                 <a:latin typeface="Arial"/>
               </a:rPr>
-              <a:t>Noise cuts the hits from 58 to 7 per 1,000</a:t>
+              <a:t>Run → Select QPU →</a:t>
+            </a:r>
+          </a:p>
+          <a:p>
+            <a:pPr algn="l">
+              <a:lnSpc>
+                <a:spcPts val="2400"/>
+              </a:lnSpc>
+              <a:spcBef>
+                <a:spcPts val="0"/>
+              </a:spcBef>
+              <a:spcAft>
+                <a:spcPts val="0"/>
+              </a:spcAft>
+            </a:pPr>
+            <a:r>
+              <a:rPr sz="2000" b="0">
+                <a:solidFill>
+                  <a:srgbClr val="FFFFFF"/>
+                </a:solidFill>
+                <a:latin typeface="Arial"/>
+              </a:rPr>
+              <a:t>IonQ Forte 1 (29q) noise model</a:t>
             </a:r>
           </a:p>
         </p:txBody>
@@ -10523,8 +10451,8 @@
         </p:nvSpPr>
         <p:spPr>
           <a:xfrm>
-            <a:off x="6172200" y="2927604"/>
-            <a:ext cx="100584" cy="100584"/>
+            <a:off x="822960" y="4474464"/>
+            <a:ext cx="457200" cy="457200"/>
           </a:xfrm>
           <a:prstGeom prst="ellipse">
             <a:avLst/>
@@ -10567,8 +10495,8 @@
         </p:nvSpPr>
         <p:spPr>
           <a:xfrm>
-            <a:off x="6446520" y="2840736"/>
-            <a:ext cx="5193792" cy="274320"/>
+            <a:off x="822960" y="4556760"/>
+            <a:ext cx="457200" cy="274320"/>
           </a:xfrm>
           <a:prstGeom prst="rect">
             <a:avLst/>
@@ -10581,7 +10509,7 @@
           </a:bodyPr>
           <a:lstStyle/>
           <a:p>
-            <a:pPr algn="l">
+            <a:pPr algn="ctr">
               <a:lnSpc>
                 <a:spcPts val="2160"/>
               </a:lnSpc>
@@ -10593,13 +10521,13 @@
               </a:spcAft>
             </a:pPr>
             <a:r>
-              <a:rPr sz="1800" b="0">
+              <a:rPr sz="1800" b="1">
                 <a:solidFill>
                   <a:srgbClr val="FFFFFF"/>
                 </a:solidFill>
                 <a:latin typeface="Arial"/>
               </a:rPr>
-              <a:t>Classical heuristics match or beat it</a:t>
+              <a:t>3</a:t>
             </a:r>
           </a:p>
         </p:txBody>
@@ -10612,8 +10540,8 @@
         </p:nvSpPr>
         <p:spPr>
           <a:xfrm>
-            <a:off x="6172200" y="3499104"/>
-            <a:ext cx="5468112" cy="335280"/>
+            <a:off x="1508760" y="4392168"/>
+            <a:ext cx="4023360" cy="609600"/>
           </a:xfrm>
           <a:prstGeom prst="rect">
             <a:avLst/>
@@ -10628,6 +10556,73 @@
           <a:p>
             <a:pPr algn="l">
               <a:lnSpc>
+                <a:spcPts val="2400"/>
+              </a:lnSpc>
+              <a:spcBef>
+                <a:spcPts val="0"/>
+              </a:spcBef>
+              <a:spcAft>
+                <a:spcPts val="0"/>
+              </a:spcAft>
+            </a:pPr>
+            <a:r>
+              <a:rPr sz="2000" b="0">
+                <a:solidFill>
+                  <a:srgbClr val="FFFFFF"/>
+                </a:solidFill>
+                <a:latin typeface="Arial"/>
+              </a:rPr>
+              <a:t>One job returns the counts,</a:t>
+            </a:r>
+          </a:p>
+          <a:p>
+            <a:pPr algn="l">
+              <a:lnSpc>
+                <a:spcPts val="2400"/>
+              </a:lnSpc>
+              <a:spcBef>
+                <a:spcPts val="0"/>
+              </a:spcBef>
+              <a:spcAft>
+                <a:spcPts val="0"/>
+              </a:spcAft>
+            </a:pPr>
+            <a:r>
+              <a:rPr sz="2000" b="0">
+                <a:solidFill>
+                  <a:srgbClr val="FFFFFF"/>
+                </a:solidFill>
+                <a:latin typeface="Arial"/>
+              </a:rPr>
+              <a:t>the table and the plots</a:t>
+            </a:r>
+          </a:p>
+        </p:txBody>
+      </p:sp>
+      <p:sp>
+        <p:nvSpPr>
+          <p:cNvPr id="14" name="TextBox 13"/>
+          <p:cNvSpPr txBox="1"/>
+          <p:nvPr/>
+        </p:nvSpPr>
+        <p:spPr>
+          <a:xfrm>
+            <a:off x="6172200" y="1554480"/>
+            <a:ext cx="5468112" cy="335280"/>
+          </a:xfrm>
+          <a:prstGeom prst="rect">
+            <a:avLst/>
+          </a:prstGeom>
+          <a:noFill/>
+        </p:spPr>
+        <p:txBody>
+          <a:bodyPr wrap="square" lIns="0" rIns="0" tIns="0" bIns="0" anchor="t">
+            <a:noAutofit/>
+          </a:bodyPr>
+          <a:lstStyle/>
+          <a:p>
+            <a:pPr algn="l">
+              <a:lnSpc>
                 <a:spcPts val="2640"/>
               </a:lnSpc>
               <a:spcBef>
@@ -10644,20 +10639,20 @@
                 </a:solidFill>
                 <a:latin typeface="Arial"/>
               </a:rPr>
-              <a:t>Next steps</a:t>
-            </a:r>
-          </a:p>
-        </p:txBody>
-      </p:sp>
-      <p:sp>
-        <p:nvSpPr>
-          <p:cNvPr id="14" name="Oval 13"/>
+              <a:t>Honest limits</a:t>
+            </a:r>
+          </a:p>
+        </p:txBody>
+      </p:sp>
+      <p:sp>
+        <p:nvSpPr>
+          <p:cNvPr id="15" name="Oval 14"/>
           <p:cNvSpPr/>
           <p:nvPr/>
         </p:nvSpPr>
         <p:spPr>
           <a:xfrm>
-            <a:off x="6172200" y="4067556"/>
+            <a:off x="6172200" y="2122932"/>
             <a:ext cx="100584" cy="100584"/>
           </a:xfrm>
           <a:prstGeom prst="ellipse">
@@ -10695,13 +10690,13 @@
       </p:sp>
       <p:sp>
         <p:nvSpPr>
-          <p:cNvPr id="15" name="TextBox 14"/>
+          <p:cNvPr id="16" name="TextBox 15"/>
           <p:cNvSpPr txBox="1"/>
           <p:nvPr/>
         </p:nvSpPr>
         <p:spPr>
           <a:xfrm>
-            <a:off x="6446520" y="3980688"/>
+            <a:off x="6446520" y="2036064"/>
             <a:ext cx="5193792" cy="274320"/>
           </a:xfrm>
           <a:prstGeom prst="rect">
@@ -10733,20 +10728,20 @@
                 </a:solidFill>
                 <a:latin typeface="Arial"/>
               </a:rPr>
-              <a:t>Run the other 4 selected circuits</a:t>
-            </a:r>
-          </a:p>
-        </p:txBody>
-      </p:sp>
-      <p:sp>
-        <p:nvSpPr>
-          <p:cNvPr id="16" name="Oval 15"/>
+              <a:t>A noisy simulator: one job of 1,000 shots</a:t>
+            </a:r>
+          </a:p>
+        </p:txBody>
+      </p:sp>
+      <p:sp>
+        <p:nvSpPr>
+          <p:cNvPr id="17" name="Oval 16"/>
           <p:cNvSpPr/>
           <p:nvPr/>
         </p:nvSpPr>
         <p:spPr>
           <a:xfrm>
-            <a:off x="6172200" y="4469892"/>
+            <a:off x="6172200" y="2525268"/>
             <a:ext cx="100584" cy="100584"/>
           </a:xfrm>
           <a:prstGeom prst="ellipse">
@@ -10784,13 +10779,13 @@
       </p:sp>
       <p:sp>
         <p:nvSpPr>
-          <p:cNvPr id="17" name="TextBox 16"/>
+          <p:cNvPr id="18" name="TextBox 17"/>
           <p:cNvSpPr txBox="1"/>
           <p:nvPr/>
         </p:nvSpPr>
         <p:spPr>
           <a:xfrm>
-            <a:off x="6446520" y="4383024"/>
+            <a:off x="6446520" y="2438400"/>
             <a:ext cx="5193792" cy="274320"/>
           </a:xfrm>
           <a:prstGeom prst="rect">
@@ -10822,20 +10817,20 @@
                 </a:solidFill>
                 <a:latin typeface="Arial"/>
               </a:rPr>
-              <a:t>Shorter circuits: 66 instead of 198 gates</a:t>
-            </a:r>
-          </a:p>
-        </p:txBody>
-      </p:sp>
-      <p:sp>
-        <p:nvSpPr>
-          <p:cNvPr id="18" name="Oval 17"/>
+              <a:t>Noise cuts the hits from 58 to 7 per 1,000</a:t>
+            </a:r>
+          </a:p>
+        </p:txBody>
+      </p:sp>
+      <p:sp>
+        <p:nvSpPr>
+          <p:cNvPr id="19" name="Oval 18"/>
           <p:cNvSpPr/>
           <p:nvPr/>
         </p:nvSpPr>
         <p:spPr>
           <a:xfrm>
-            <a:off x="6172200" y="4872228"/>
+            <a:off x="6172200" y="2927604"/>
             <a:ext cx="100584" cy="100584"/>
           </a:xfrm>
           <a:prstGeom prst="ellipse">
@@ -10873,13 +10868,13 @@
       </p:sp>
       <p:sp>
         <p:nvSpPr>
-          <p:cNvPr id="19" name="TextBox 18"/>
+          <p:cNvPr id="20" name="TextBox 19"/>
           <p:cNvSpPr txBox="1"/>
           <p:nvPr/>
         </p:nvSpPr>
         <p:spPr>
           <a:xfrm>
-            <a:off x="6446520" y="4785360"/>
+            <a:off x="6446520" y="2840736"/>
             <a:ext cx="5193792" cy="274320"/>
           </a:xfrm>
           <a:prstGeom prst="rect">
@@ -10911,34 +10906,75 @@
                 </a:solidFill>
                 <a:latin typeface="Arial"/>
               </a:rPr>
-              <a:t>29 assets on the IonQ Forte 1 noise model</a:t>
-            </a:r>
-          </a:p>
-        </p:txBody>
-      </p:sp>
-      <p:sp>
-        <p:nvSpPr>
-          <p:cNvPr id="20" name="Rounded Rectangle 19"/>
+              <a:t>Classical heuristics match or beat it</a:t>
+            </a:r>
+          </a:p>
+        </p:txBody>
+      </p:sp>
+      <p:sp>
+        <p:nvSpPr>
+          <p:cNvPr id="21" name="TextBox 20"/>
+          <p:cNvSpPr txBox="1"/>
+          <p:nvPr/>
+        </p:nvSpPr>
+        <p:spPr>
+          <a:xfrm>
+            <a:off x="6172200" y="3499104"/>
+            <a:ext cx="5468112" cy="335280"/>
+          </a:xfrm>
+          <a:prstGeom prst="rect">
+            <a:avLst/>
+          </a:prstGeom>
+          <a:noFill/>
+        </p:spPr>
+        <p:txBody>
+          <a:bodyPr wrap="square" lIns="0" rIns="0" tIns="0" bIns="0" anchor="t">
+            <a:noAutofit/>
+          </a:bodyPr>
+          <a:lstStyle/>
+          <a:p>
+            <a:pPr algn="l">
+              <a:lnSpc>
+                <a:spcPts val="2640"/>
+              </a:lnSpc>
+              <a:spcBef>
+                <a:spcPts val="0"/>
+              </a:spcBef>
+              <a:spcAft>
+                <a:spcPts val="0"/>
+              </a:spcAft>
+            </a:pPr>
+            <a:r>
+              <a:rPr sz="2200" b="1">
+                <a:solidFill>
+                  <a:srgbClr val="FFFFFF"/>
+                </a:solidFill>
+                <a:latin typeface="Arial"/>
+              </a:rPr>
+              <a:t>Next steps</a:t>
+            </a:r>
+          </a:p>
+        </p:txBody>
+      </p:sp>
+      <p:sp>
+        <p:nvSpPr>
+          <p:cNvPr id="22" name="Oval 21"/>
           <p:cNvSpPr/>
           <p:nvPr/>
         </p:nvSpPr>
         <p:spPr>
           <a:xfrm>
-            <a:off x="548640" y="5468112"/>
-            <a:ext cx="5120640" cy="566928"/>
-          </a:xfrm>
-          <a:prstGeom prst="roundRect">
-            <a:avLst>
-              <a:gd name="adj" fmla="val 50000"/>
-            </a:avLst>
+            <a:off x="6172200" y="4067556"/>
+            <a:ext cx="100584" cy="100584"/>
+          </a:xfrm>
+          <a:prstGeom prst="ellipse">
+            <a:avLst/>
           </a:prstGeom>
           <a:solidFill>
-            <a:srgbClr val="131B2E"/>
+            <a:srgbClr val="17A2B8"/>
           </a:solidFill>
-          <a:ln w="15875">
-            <a:solidFill>
-              <a:srgbClr val="17A2B8"/>
-            </a:solidFill>
+          <a:ln>
+            <a:noFill/>
           </a:ln>
           <a:effectLst/>
         </p:spPr>
@@ -10966,14 +11002,14 @@
       </p:sp>
       <p:sp>
         <p:nvSpPr>
-          <p:cNvPr id="21" name="TextBox 20"/>
+          <p:cNvPr id="23" name="TextBox 22"/>
           <p:cNvSpPr txBox="1"/>
           <p:nvPr/>
         </p:nvSpPr>
         <p:spPr>
           <a:xfrm>
-            <a:off x="548640" y="5590032"/>
-            <a:ext cx="5120640" cy="304800"/>
+            <a:off x="6446520" y="3980688"/>
+            <a:ext cx="5193792" cy="274320"/>
           </a:xfrm>
           <a:prstGeom prst="rect">
             <a:avLst/>
@@ -10986,39 +11022,83 @@
           </a:bodyPr>
           <a:lstStyle/>
           <a:p>
-            <a:pPr algn="ctr">
-              <a:lnSpc>
-                <a:spcPts val="2400"/>
-              </a:lnSpc>
-              <a:spcBef>
-                <a:spcPts val="0"/>
-              </a:spcBef>
-              <a:spcAft>
-                <a:spcPts val="0"/>
-              </a:spcAft>
-            </a:pPr>
-            <a:r>
-              <a:rPr sz="2000" b="0">
+            <a:pPr algn="l">
+              <a:lnSpc>
+                <a:spcPts val="2160"/>
+              </a:lnSpc>
+              <a:spcBef>
+                <a:spcPts val="0"/>
+              </a:spcBef>
+              <a:spcAft>
+                <a:spcPts val="0"/>
+              </a:spcAft>
+            </a:pPr>
+            <a:r>
+              <a:rPr sz="1800" b="0">
                 <a:solidFill>
                   <a:srgbClr val="FFFFFF"/>
                 </a:solidFill>
                 <a:latin typeface="Arial"/>
               </a:rPr>
-              <a:t>This effort is supported by Qollab &amp; IonQ</a:t>
-            </a:r>
-          </a:p>
-        </p:txBody>
-      </p:sp>
-      <p:sp>
-        <p:nvSpPr>
-          <p:cNvPr id="22" name="TextBox 21"/>
+              <a:t>Run the other 4 selected circuits</a:t>
+            </a:r>
+          </a:p>
+        </p:txBody>
+      </p:sp>
+      <p:sp>
+        <p:nvSpPr>
+          <p:cNvPr id="24" name="Oval 23"/>
+          <p:cNvSpPr/>
+          <p:nvPr/>
+        </p:nvSpPr>
+        <p:spPr>
+          <a:xfrm>
+            <a:off x="6172200" y="4469892"/>
+            <a:ext cx="100584" cy="100584"/>
+          </a:xfrm>
+          <a:prstGeom prst="ellipse">
+            <a:avLst/>
+          </a:prstGeom>
+          <a:solidFill>
+            <a:srgbClr val="17A2B8"/>
+          </a:solidFill>
+          <a:ln>
+            <a:noFill/>
+          </a:ln>
+          <a:effectLst/>
+        </p:spPr>
+        <p:style>
+          <a:lnRef idx="1">
+            <a:schemeClr val="accent1"/>
+          </a:lnRef>
+          <a:fillRef idx="3">
+            <a:schemeClr val="accent1"/>
+          </a:fillRef>
+          <a:effectRef idx="2">
+            <a:schemeClr val="accent1"/>
+          </a:effectRef>
+          <a:fontRef idx="minor">
+            <a:schemeClr val="lt1"/>
+          </a:fontRef>
+        </p:style>
+        <p:txBody>
+          <a:bodyPr rtlCol="0" anchor="ctr"/>
+          <a:lstStyle/>
+          <a:p>
+            <a:pPr algn="ctr"/>
+          </a:p>
+        </p:txBody>
+      </p:sp>
+      <p:sp>
+        <p:nvSpPr>
+          <p:cNvPr id="25" name="TextBox 24"/>
           <p:cNvSpPr txBox="1"/>
           <p:nvPr/>
         </p:nvSpPr>
         <p:spPr>
           <a:xfrm>
-            <a:off x="548640" y="384048"/>
-            <a:ext cx="11094415" cy="274320"/>
+            <a:off x="6446520" y="4383024"/>
+            <a:ext cx="5193792" cy="274320"/>
           </a:xfrm>
           <a:prstGeom prst="rect">
             <a:avLst/>
@@ -11043,27 +11123,71 @@
               </a:spcAft>
             </a:pPr>
             <a:r>
-              <a:rPr sz="1800" b="1">
-                <a:solidFill>
-                  <a:srgbClr val="17A2B8"/>
-                </a:solidFill>
-                <a:latin typeface="Arial"/>
-              </a:rPr>
-              <a:t>DEMO, LIMITS, NEXT STEPS</a:t>
-            </a:r>
-          </a:p>
-        </p:txBody>
-      </p:sp>
-      <p:sp>
-        <p:nvSpPr>
-          <p:cNvPr id="23" name="TextBox 22"/>
+              <a:rPr sz="1800" b="0">
+                <a:solidFill>
+                  <a:srgbClr val="FFFFFF"/>
+                </a:solidFill>
+                <a:latin typeface="Arial"/>
+              </a:rPr>
+              <a:t>Shorter circuits: 66 instead of 198 gates</a:t>
+            </a:r>
+          </a:p>
+        </p:txBody>
+      </p:sp>
+      <p:sp>
+        <p:nvSpPr>
+          <p:cNvPr id="26" name="Oval 25"/>
+          <p:cNvSpPr/>
+          <p:nvPr/>
+        </p:nvSpPr>
+        <p:spPr>
+          <a:xfrm>
+            <a:off x="6172200" y="4872228"/>
+            <a:ext cx="100584" cy="100584"/>
+          </a:xfrm>
+          <a:prstGeom prst="ellipse">
+            <a:avLst/>
+          </a:prstGeom>
+          <a:solidFill>
+            <a:srgbClr val="17A2B8"/>
+          </a:solidFill>
+          <a:ln>
+            <a:noFill/>
+          </a:ln>
+          <a:effectLst/>
+        </p:spPr>
+        <p:style>
+          <a:lnRef idx="1">
+            <a:schemeClr val="accent1"/>
+          </a:lnRef>
+          <a:fillRef idx="3">
+            <a:schemeClr val="accent1"/>
+          </a:fillRef>
+          <a:effectRef idx="2">
+            <a:schemeClr val="accent1"/>
+          </a:effectRef>
+          <a:fontRef idx="minor">
+            <a:schemeClr val="lt1"/>
+          </a:fontRef>
+        </p:style>
+        <p:txBody>
+          <a:bodyPr rtlCol="0" anchor="ctr"/>
+          <a:lstStyle/>
+          <a:p>
+            <a:pPr algn="ctr"/>
+          </a:p>
+        </p:txBody>
+      </p:sp>
+      <p:sp>
+        <p:nvSpPr>
+          <p:cNvPr id="27" name="TextBox 26"/>
           <p:cNvSpPr txBox="1"/>
           <p:nvPr/>
         </p:nvSpPr>
         <p:spPr>
           <a:xfrm>
-            <a:off x="548640" y="6327648"/>
-            <a:ext cx="7315200" cy="274320"/>
+            <a:off x="6446520" y="4785360"/>
+            <a:ext cx="5193792" cy="274320"/>
           </a:xfrm>
           <a:prstGeom prst="rect">
             <a:avLst/>
@@ -11090,6 +11214,96 @@
             <a:r>
               <a:rPr sz="1800" b="0">
                 <a:solidFill>
+                  <a:srgbClr val="FFFFFF"/>
+                </a:solidFill>
+                <a:latin typeface="Arial"/>
+              </a:rPr>
+              <a:t>29 assets on the IonQ Forte 1 noise model</a:t>
+            </a:r>
+          </a:p>
+        </p:txBody>
+      </p:sp>
+      <p:sp>
+        <p:nvSpPr>
+          <p:cNvPr id="28" name="TextBox 27"/>
+          <p:cNvSpPr txBox="1"/>
+          <p:nvPr/>
+        </p:nvSpPr>
+        <p:spPr>
+          <a:xfrm>
+            <a:off x="548640" y="384048"/>
+            <a:ext cx="11094415" cy="274320"/>
+          </a:xfrm>
+          <a:prstGeom prst="rect">
+            <a:avLst/>
+          </a:prstGeom>
+          <a:noFill/>
+        </p:spPr>
+        <p:txBody>
+          <a:bodyPr wrap="square" lIns="0" rIns="0" tIns="0" bIns="0" anchor="t">
+            <a:noAutofit/>
+          </a:bodyPr>
+          <a:lstStyle/>
+          <a:p>
+            <a:pPr algn="l">
+              <a:lnSpc>
+                <a:spcPts val="2160"/>
+              </a:lnSpc>
+              <a:spcBef>
+                <a:spcPts val="0"/>
+              </a:spcBef>
+              <a:spcAft>
+                <a:spcPts val="0"/>
+              </a:spcAft>
+            </a:pPr>
+            <a:r>
+              <a:rPr sz="1800" b="1">
+                <a:solidFill>
+                  <a:srgbClr val="17A2B8"/>
+                </a:solidFill>
+                <a:latin typeface="Arial"/>
+              </a:rPr>
+              <a:t>DEMO, LIMITS, NEXT STEPS</a:t>
+            </a:r>
+          </a:p>
+        </p:txBody>
+      </p:sp>
+      <p:sp>
+        <p:nvSpPr>
+          <p:cNvPr id="29" name="TextBox 28"/>
+          <p:cNvSpPr txBox="1"/>
+          <p:nvPr/>
+        </p:nvSpPr>
+        <p:spPr>
+          <a:xfrm>
+            <a:off x="548640" y="6327648"/>
+            <a:ext cx="7315200" cy="274320"/>
+          </a:xfrm>
+          <a:prstGeom prst="rect">
+            <a:avLst/>
+          </a:prstGeom>
+          <a:noFill/>
+        </p:spPr>
+        <p:txBody>
+          <a:bodyPr wrap="square" lIns="0" rIns="0" tIns="0" bIns="0" anchor="t">
+            <a:noAutofit/>
+          </a:bodyPr>
+          <a:lstStyle/>
+          <a:p>
+            <a:pPr algn="l">
+              <a:lnSpc>
+                <a:spcPts val="2160"/>
+              </a:lnSpc>
+              <a:spcBef>
+                <a:spcPts val="0"/>
+              </a:spcBef>
+              <a:spcAft>
+                <a:spcPts val="0"/>
+              </a:spcAft>
+            </a:pPr>
+            <a:r>
+              <a:rPr sz="1800" b="0">
+                <a:solidFill>
                   <a:srgbClr val="A9B4C6"/>
                 </a:solidFill>
                 <a:latin typeface="Arial"/>
@@ -11101,7 +11315,7 @@
       </p:sp>
       <p:sp>
         <p:nvSpPr>
-          <p:cNvPr id="24" name="TextBox 23"/>
+          <p:cNvPr id="30" name="TextBox 29"/>
           <p:cNvSpPr txBox="1"/>
           <p:nvPr/>
         </p:nvSpPr>
@@ -11182,8 +11396,8 @@
         </p:nvSpPr>
         <p:spPr>
           <a:xfrm>
-            <a:off x="548640" y="731520"/>
-            <a:ext cx="11094415" cy="467360"/>
+            <a:off x="548640" y="1572768"/>
+            <a:ext cx="6309360" cy="1518920"/>
           </a:xfrm>
         </p:spPr>
         <p:txBody>
@@ -11194,48 +11408,162 @@
           <a:p>
             <a:pPr algn="l">
               <a:lnSpc>
-                <a:spcPts val="3679"/>
-              </a:lnSpc>
-              <a:spcBef>
-                <a:spcPts val="0"/>
-              </a:spcBef>
-              <a:spcAft>
-                <a:spcPts val="0"/>
-              </a:spcAft>
-            </a:pPr>
-            <a:r>
-              <a:rPr sz="3200" b="1">
+                <a:spcPts val="5980"/>
+              </a:lnSpc>
+              <a:spcBef>
+                <a:spcPts val="0"/>
+              </a:spcBef>
+              <a:spcAft>
+                <a:spcPts val="0"/>
+              </a:spcAft>
+            </a:pPr>
+            <a:r>
+              <a:rPr sz="5200" b="1">
                 <a:solidFill>
                   <a:srgbClr val="FFFFFF"/>
                 </a:solidFill>
                 <a:latin typeface="Arial"/>
               </a:rPr>
-              <a:t>One engine, two problems</a:t>
-            </a:r>
-          </a:p>
-        </p:txBody>
-      </p:sp>
-      <p:sp>
-        <p:nvSpPr>
-          <p:cNvPr id="3" name="Rounded Rectangle 2"/>
+              <a:t>Thank you for</a:t>
+            </a:r>
+          </a:p>
+          <a:p>
+            <a:pPr algn="l">
+              <a:lnSpc>
+                <a:spcPts val="5980"/>
+              </a:lnSpc>
+              <a:spcBef>
+                <a:spcPts val="0"/>
+              </a:spcBef>
+              <a:spcAft>
+                <a:spcPts val="0"/>
+              </a:spcAft>
+            </a:pPr>
+            <a:r>
+              <a:rPr sz="5200" b="1">
+                <a:solidFill>
+                  <a:srgbClr val="FFFFFF"/>
+                </a:solidFill>
+                <a:latin typeface="Arial"/>
+              </a:rPr>
+              <a:t>your attention</a:t>
+            </a:r>
+          </a:p>
+        </p:txBody>
+      </p:sp>
+      <p:sp>
+        <p:nvSpPr>
+          <p:cNvPr id="3" name="TextBox 2"/>
+          <p:cNvSpPr txBox="1"/>
+          <p:nvPr/>
+        </p:nvSpPr>
+        <p:spPr>
+          <a:xfrm>
+            <a:off x="548640" y="3611880"/>
+            <a:ext cx="6309360" cy="335280"/>
+          </a:xfrm>
+          <a:prstGeom prst="rect">
+            <a:avLst/>
+          </a:prstGeom>
+          <a:noFill/>
+        </p:spPr>
+        <p:txBody>
+          <a:bodyPr wrap="square" lIns="0" rIns="0" tIns="0" bIns="0" anchor="t">
+            <a:noAutofit/>
+          </a:bodyPr>
+          <a:lstStyle/>
+          <a:p>
+            <a:pPr algn="l">
+              <a:lnSpc>
+                <a:spcPts val="2640"/>
+              </a:lnSpc>
+              <a:spcBef>
+                <a:spcPts val="0"/>
+              </a:spcBef>
+              <a:spcAft>
+                <a:spcPts val="0"/>
+              </a:spcAft>
+            </a:pPr>
+            <a:r>
+              <a:rPr sz="2200" b="1">
+                <a:solidFill>
+                  <a:srgbClr val="FFFFFF"/>
+                </a:solidFill>
+                <a:latin typeface="Arial"/>
+              </a:rPr>
+              <a:t>Oussama Turki  ·  Tushar Pandey</a:t>
+            </a:r>
+          </a:p>
+        </p:txBody>
+      </p:sp>
+      <p:sp>
+        <p:nvSpPr>
+          <p:cNvPr id="4" name="TextBox 3"/>
+          <p:cNvSpPr txBox="1"/>
+          <p:nvPr/>
+        </p:nvSpPr>
+        <p:spPr>
+          <a:xfrm>
+            <a:off x="548640" y="4130040"/>
+            <a:ext cx="6309360" cy="304800"/>
+          </a:xfrm>
+          <a:prstGeom prst="rect">
+            <a:avLst/>
+          </a:prstGeom>
+          <a:noFill/>
+        </p:spPr>
+        <p:txBody>
+          <a:bodyPr wrap="square" lIns="0" rIns="0" tIns="0" bIns="0" anchor="t">
+            <a:noAutofit/>
+          </a:bodyPr>
+          <a:lstStyle/>
+          <a:p>
+            <a:pPr algn="l">
+              <a:lnSpc>
+                <a:spcPts val="2400"/>
+              </a:lnSpc>
+              <a:spcBef>
+                <a:spcPts val="0"/>
+              </a:spcBef>
+              <a:spcAft>
+                <a:spcPts val="0"/>
+              </a:spcAft>
+            </a:pPr>
+            <a:r>
+              <a:rPr sz="2000" b="0">
+                <a:solidFill>
+                  <a:srgbClr val="A9B4C6"/>
+                </a:solidFill>
+                <a:latin typeface="Arial"/>
+              </a:rPr>
+              <a:t>Portfolio Selection with QAOA</a:t>
+            </a:r>
+          </a:p>
+        </p:txBody>
+      </p:sp>
+      <p:sp>
+        <p:nvSpPr>
+          <p:cNvPr id="5" name="Rounded Rectangle 4"/>
           <p:cNvSpPr/>
           <p:nvPr/>
         </p:nvSpPr>
         <p:spPr>
           <a:xfrm>
-            <a:off x="548640" y="1572768"/>
-            <a:ext cx="11094415" cy="420624"/>
+            <a:off x="548640" y="5257800"/>
+            <a:ext cx="5120640" cy="566928"/>
           </a:xfrm>
           <a:prstGeom prst="roundRect">
             <a:avLst>
-              <a:gd name="adj" fmla="val 17391"/>
+              <a:gd name="adj" fmla="val 50000"/>
             </a:avLst>
           </a:prstGeom>
           <a:solidFill>
-            <a:srgbClr val="0F2A3A"/>
+            <a:srgbClr val="131B2E"/>
           </a:solidFill>
-          <a:ln>
-            <a:noFill/>
+          <a:ln w="15875">
+            <a:solidFill>
+              <a:srgbClr val="17A2B8"/>
+            </a:solidFill>
           </a:ln>
           <a:effectLst/>
         </p:spPr>
@@ -11263,14 +11591,14 @@
       </p:sp>
       <p:sp>
         <p:nvSpPr>
-          <p:cNvPr id="4" name="TextBox 3"/>
+          <p:cNvPr id="6" name="TextBox 5"/>
           <p:cNvSpPr txBox="1"/>
           <p:nvPr/>
         </p:nvSpPr>
         <p:spPr>
           <a:xfrm>
-            <a:off x="749808" y="1636776"/>
-            <a:ext cx="3749040" cy="274320"/>
+            <a:off x="548640" y="5379720"/>
+            <a:ext cx="5120640" cy="304800"/>
           </a:xfrm>
           <a:prstGeom prst="rect">
             <a:avLst/>
@@ -11283,39 +11611,63 @@
           </a:bodyPr>
           <a:lstStyle/>
           <a:p>
-            <a:pPr algn="l">
-              <a:lnSpc>
-                <a:spcPts val="2160"/>
-              </a:lnSpc>
-              <a:spcBef>
-                <a:spcPts val="0"/>
-              </a:spcBef>
-              <a:spcAft>
-                <a:spcPts val="0"/>
-              </a:spcAft>
-            </a:pPr>
-            <a:r>
-              <a:rPr sz="1800" b="1">
+            <a:pPr algn="ctr">
+              <a:lnSpc>
+                <a:spcPts val="2400"/>
+              </a:lnSpc>
+              <a:spcBef>
+                <a:spcPts val="0"/>
+              </a:spcBef>
+              <a:spcAft>
+                <a:spcPts val="0"/>
+              </a:spcAft>
+            </a:pPr>
+            <a:r>
+              <a:rPr sz="2000" b="0">
                 <a:solidFill>
                   <a:srgbClr val="FFFFFF"/>
                 </a:solidFill>
                 <a:latin typeface="Arial"/>
               </a:rPr>
-              <a:t/>
-            </a:r>
-          </a:p>
-        </p:txBody>
-      </p:sp>
-      <p:sp>
-        <p:nvSpPr>
-          <p:cNvPr id="5" name="TextBox 4"/>
+              <a:t>This effort is supported by Qollab &amp; IonQ</a:t>
+            </a:r>
+          </a:p>
+        </p:txBody>
+      </p:sp>
+      <p:pic>
+        <p:nvPicPr>
+          <p:cNvPr id="7" name="Picture 6" descr="The network picture of the 12 assets from the title slide: 12 dots on a circle, every pair joined by a line."/>
+          <p:cNvPicPr>
+            <a:picLocks noChangeAspect="1"/>
+          </p:cNvPicPr>
+          <p:nvPr/>
+        </p:nvPicPr>
+        <p:blipFill>
+          <a:blip r:embed="rId2"/>
+          <a:stretch>
+            <a:fillRect/>
+          </a:stretch>
+        </p:blipFill>
+        <p:spPr>
+          <a:xfrm>
+            <a:off x="6903720" y="914400"/>
+            <a:ext cx="4754880" cy="4754880"/>
+          </a:xfrm>
+          <a:prstGeom prst="rect">
+            <a:avLst/>
+          </a:prstGeom>
+        </p:spPr>
+      </p:pic>
+      <p:sp>
+        <p:nvSpPr>
+          <p:cNvPr id="8" name="TextBox 7"/>
           <p:cNvSpPr txBox="1"/>
           <p:nvPr/>
         </p:nvSpPr>
         <p:spPr>
           <a:xfrm>
-            <a:off x="4773168" y="1636776"/>
-            <a:ext cx="3264408" cy="274320"/>
+            <a:off x="548640" y="1188720"/>
+            <a:ext cx="11094415" cy="274320"/>
           </a:xfrm>
           <a:prstGeom prst="rect">
             <a:avLst/>
@@ -11342,25 +11694,25 @@
             <a:r>
               <a:rPr sz="1800" b="1">
                 <a:solidFill>
-                  <a:srgbClr val="FFFFFF"/>
-                </a:solidFill>
-                <a:latin typeface="Arial"/>
-              </a:rPr>
-              <a:t>Stocks: portfolio selection</a:t>
-            </a:r>
-          </a:p>
-        </p:txBody>
-      </p:sp>
-      <p:sp>
-        <p:nvSpPr>
-          <p:cNvPr id="6" name="TextBox 5"/>
+                  <a:srgbClr val="17A2B8"/>
+                </a:solidFill>
+                <a:latin typeface="Arial"/>
+              </a:rPr>
+              <a:t>TEAM ZOLLERQU</a:t>
+            </a:r>
+          </a:p>
+        </p:txBody>
+      </p:sp>
+      <p:sp>
+        <p:nvSpPr>
+          <p:cNvPr id="9" name="TextBox 8"/>
           <p:cNvSpPr txBox="1"/>
           <p:nvPr/>
         </p:nvSpPr>
         <p:spPr>
           <a:xfrm>
-            <a:off x="8311896" y="1636776"/>
-            <a:ext cx="3255264" cy="274320"/>
+            <a:off x="548640" y="6327648"/>
+            <a:ext cx="7315200" cy="274320"/>
           </a:xfrm>
           <a:prstGeom prst="rect">
             <a:avLst/>
@@ -11385,149 +11737,13 @@
               </a:spcAft>
             </a:pPr>
             <a:r>
-              <a:rPr sz="1800" b="1">
-                <a:solidFill>
-                  <a:srgbClr val="FFFFFF"/>
-                </a:solidFill>
-                <a:latin typeface="Arial"/>
-              </a:rPr>
-              <a:t>Mesh: split for 2 devices</a:t>
-            </a:r>
-          </a:p>
-        </p:txBody>
-      </p:sp>
-      <p:sp>
-        <p:nvSpPr>
-          <p:cNvPr id="7" name="Rounded Rectangle 6"/>
-          <p:cNvSpPr/>
-          <p:nvPr/>
-        </p:nvSpPr>
-        <p:spPr>
-          <a:xfrm>
-            <a:off x="548640" y="2039112"/>
-            <a:ext cx="11094415" cy="420624"/>
-          </a:xfrm>
-          <a:prstGeom prst="roundRect">
-            <a:avLst>
-              <a:gd name="adj" fmla="val 17391"/>
-            </a:avLst>
-          </a:prstGeom>
-          <a:solidFill>
-            <a:srgbClr val="131B2E"/>
-          </a:solidFill>
-          <a:ln>
-            <a:noFill/>
-          </a:ln>
-          <a:effectLst/>
-        </p:spPr>
-        <p:style>
-          <a:lnRef idx="1">
-            <a:schemeClr val="accent1"/>
-          </a:lnRef>
-          <a:fillRef idx="3">
-            <a:schemeClr val="accent1"/>
-          </a:fillRef>
-          <a:effectRef idx="2">
-            <a:schemeClr val="accent1"/>
-          </a:effectRef>
-          <a:fontRef idx="minor">
-            <a:schemeClr val="lt1"/>
-          </a:fontRef>
-        </p:style>
-        <p:txBody>
-          <a:bodyPr rtlCol="0" anchor="ctr"/>
-          <a:lstStyle/>
-          <a:p>
-            <a:pPr algn="ctr"/>
-          </a:p>
-        </p:txBody>
-      </p:sp>
-      <p:sp>
-        <p:nvSpPr>
-          <p:cNvPr id="8" name="TextBox 7"/>
-          <p:cNvSpPr txBox="1"/>
-          <p:nvPr/>
-        </p:nvSpPr>
-        <p:spPr>
-          <a:xfrm>
-            <a:off x="749808" y="2103120"/>
-            <a:ext cx="3749040" cy="274320"/>
-          </a:xfrm>
-          <a:prstGeom prst="rect">
-            <a:avLst/>
-          </a:prstGeom>
-          <a:noFill/>
-        </p:spPr>
-        <p:txBody>
-          <a:bodyPr wrap="square" lIns="0" rIns="0" tIns="0" bIns="0" anchor="t">
-            <a:noAutofit/>
-          </a:bodyPr>
-          <a:lstStyle/>
-          <a:p>
-            <a:pPr algn="l">
-              <a:lnSpc>
-                <a:spcPts val="2160"/>
-              </a:lnSpc>
-              <a:spcBef>
-                <a:spcPts val="0"/>
-              </a:spcBef>
-              <a:spcAft>
-                <a:spcPts val="0"/>
-              </a:spcAft>
-            </a:pPr>
-            <a:r>
               <a:rPr sz="1800" b="0">
                 <a:solidFill>
                   <a:srgbClr val="A9B4C6"/>
                 </a:solidFill>
                 <a:latin typeface="Arial"/>
               </a:rPr>
-              <a:t>Qubits</a:t>
-            </a:r>
-          </a:p>
-        </p:txBody>
-      </p:sp>
-      <p:sp>
-        <p:nvSpPr>
-          <p:cNvPr id="9" name="TextBox 8"/>
-          <p:cNvSpPr txBox="1"/>
-          <p:nvPr/>
-        </p:nvSpPr>
-        <p:spPr>
-          <a:xfrm>
-            <a:off x="4773168" y="2103120"/>
-            <a:ext cx="3264408" cy="274320"/>
-          </a:xfrm>
-          <a:prstGeom prst="rect">
-            <a:avLst/>
-          </a:prstGeom>
-          <a:noFill/>
-        </p:spPr>
-        <p:txBody>
-          <a:bodyPr wrap="square" lIns="0" rIns="0" tIns="0" bIns="0" anchor="t">
-            <a:noAutofit/>
-          </a:bodyPr>
-          <a:lstStyle/>
-          <a:p>
-            <a:pPr algn="l">
-              <a:lnSpc>
-                <a:spcPts val="2160"/>
-              </a:lnSpc>
-              <a:spcBef>
-                <a:spcPts val="0"/>
-              </a:spcBef>
-              <a:spcAft>
-                <a:spcPts val="0"/>
-              </a:spcAft>
-            </a:pPr>
-            <a:r>
-              <a:rPr sz="1800" b="1">
-                <a:solidFill>
-                  <a:srgbClr val="FFFFFF"/>
-                </a:solidFill>
-                <a:latin typeface="Arial"/>
-              </a:rPr>
-              <a:t>12</a:t>
+              <a:t>ZollerQu - Qollab x IonQ Hackathon 2026</a:t>
             </a:r>
           </a:p>
         </p:txBody>
@@ -11535,1158 +11751,6 @@
       <p:sp>
         <p:nvSpPr>
           <p:cNvPr id="10" name="TextBox 9"/>
-          <p:cNvSpPr txBox="1"/>
-          <p:nvPr/>
-        </p:nvSpPr>
-        <p:spPr>
-          <a:xfrm>
-            <a:off x="8311896" y="2103120"/>
-            <a:ext cx="3255264" cy="274320"/>
-          </a:xfrm>
-          <a:prstGeom prst="rect">
-            <a:avLst/>
-          </a:prstGeom>
-          <a:noFill/>
-        </p:spPr>
-        <p:txBody>
-          <a:bodyPr wrap="square" lIns="0" rIns="0" tIns="0" bIns="0" anchor="t">
-            <a:noAutofit/>
-          </a:bodyPr>
-          <a:lstStyle/>
-          <a:p>
-            <a:pPr algn="l">
-              <a:lnSpc>
-                <a:spcPts val="2160"/>
-              </a:lnSpc>
-              <a:spcBef>
-                <a:spcPts val="0"/>
-              </a:spcBef>
-              <a:spcAft>
-                <a:spcPts val="0"/>
-              </a:spcAft>
-            </a:pPr>
-            <a:r>
-              <a:rPr sz="1800" b="1">
-                <a:solidFill>
-                  <a:srgbClr val="FFFFFF"/>
-                </a:solidFill>
-                <a:latin typeface="Arial"/>
-              </a:rPr>
-              <a:t>12</a:t>
-            </a:r>
-          </a:p>
-        </p:txBody>
-      </p:sp>
-      <p:sp>
-        <p:nvSpPr>
-          <p:cNvPr id="11" name="Rounded Rectangle 10"/>
-          <p:cNvSpPr/>
-          <p:nvPr/>
-        </p:nvSpPr>
-        <p:spPr>
-          <a:xfrm>
-            <a:off x="548640" y="2505456"/>
-            <a:ext cx="11094415" cy="420624"/>
-          </a:xfrm>
-          <a:prstGeom prst="roundRect">
-            <a:avLst>
-              <a:gd name="adj" fmla="val 17391"/>
-            </a:avLst>
-          </a:prstGeom>
-          <a:solidFill>
-            <a:srgbClr val="131B2E"/>
-          </a:solidFill>
-          <a:ln>
-            <a:noFill/>
-          </a:ln>
-          <a:effectLst/>
-        </p:spPr>
-        <p:style>
-          <a:lnRef idx="1">
-            <a:schemeClr val="accent1"/>
-          </a:lnRef>
-          <a:fillRef idx="3">
-            <a:schemeClr val="accent1"/>
-          </a:fillRef>
-          <a:effectRef idx="2">
-            <a:schemeClr val="accent1"/>
-          </a:effectRef>
-          <a:fontRef idx="minor">
-            <a:schemeClr val="lt1"/>
-          </a:fontRef>
-        </p:style>
-        <p:txBody>
-          <a:bodyPr rtlCol="0" anchor="ctr"/>
-          <a:lstStyle/>
-          <a:p>
-            <a:pPr algn="ctr"/>
-          </a:p>
-        </p:txBody>
-      </p:sp>
-      <p:sp>
-        <p:nvSpPr>
-          <p:cNvPr id="12" name="TextBox 11"/>
-          <p:cNvSpPr txBox="1"/>
-          <p:nvPr/>
-        </p:nvSpPr>
-        <p:spPr>
-          <a:xfrm>
-            <a:off x="749808" y="2569464"/>
-            <a:ext cx="3749040" cy="274320"/>
-          </a:xfrm>
-          <a:prstGeom prst="rect">
-            <a:avLst/>
-          </a:prstGeom>
-          <a:noFill/>
-        </p:spPr>
-        <p:txBody>
-          <a:bodyPr wrap="square" lIns="0" rIns="0" tIns="0" bIns="0" anchor="t">
-            <a:noAutofit/>
-          </a:bodyPr>
-          <a:lstStyle/>
-          <a:p>
-            <a:pPr algn="l">
-              <a:lnSpc>
-                <a:spcPts val="2160"/>
-              </a:lnSpc>
-              <a:spcBef>
-                <a:spcPts val="0"/>
-              </a:spcBef>
-              <a:spcAft>
-                <a:spcPts val="0"/>
-              </a:spcAft>
-            </a:pPr>
-            <a:r>
-              <a:rPr sz="1800" b="0">
-                <a:solidFill>
-                  <a:srgbClr val="A9B4C6"/>
-                </a:solidFill>
-                <a:latin typeface="Arial"/>
-              </a:rPr>
-              <a:t>Circuit sent to IonQ</a:t>
-            </a:r>
-          </a:p>
-        </p:txBody>
-      </p:sp>
-      <p:sp>
-        <p:nvSpPr>
-          <p:cNvPr id="13" name="TextBox 12"/>
-          <p:cNvSpPr txBox="1"/>
-          <p:nvPr/>
-        </p:nvSpPr>
-        <p:spPr>
-          <a:xfrm>
-            <a:off x="4773168" y="2569464"/>
-            <a:ext cx="3264408" cy="274320"/>
-          </a:xfrm>
-          <a:prstGeom prst="rect">
-            <a:avLst/>
-          </a:prstGeom>
-          <a:noFill/>
-        </p:spPr>
-        <p:txBody>
-          <a:bodyPr wrap="square" lIns="0" rIns="0" tIns="0" bIns="0" anchor="t">
-            <a:noAutofit/>
-          </a:bodyPr>
-          <a:lstStyle/>
-          <a:p>
-            <a:pPr algn="l">
-              <a:lnSpc>
-                <a:spcPts val="2160"/>
-              </a:lnSpc>
-              <a:spcBef>
-                <a:spcPts val="0"/>
-              </a:spcBef>
-              <a:spcAft>
-                <a:spcPts val="0"/>
-              </a:spcAft>
-            </a:pPr>
-            <a:r>
-              <a:rPr sz="1800" b="1">
-                <a:solidFill>
-                  <a:srgbClr val="FFFFFF"/>
-                </a:solidFill>
-                <a:latin typeface="Arial"/>
-              </a:rPr>
-              <a:t>CVaR-QAOA, 198 gates</a:t>
-            </a:r>
-          </a:p>
-        </p:txBody>
-      </p:sp>
-      <p:sp>
-        <p:nvSpPr>
-          <p:cNvPr id="14" name="TextBox 13"/>
-          <p:cNvSpPr txBox="1"/>
-          <p:nvPr/>
-        </p:nvSpPr>
-        <p:spPr>
-          <a:xfrm>
-            <a:off x="8311896" y="2569464"/>
-            <a:ext cx="3255264" cy="274320"/>
-          </a:xfrm>
-          <a:prstGeom prst="rect">
-            <a:avLst/>
-          </a:prstGeom>
-          <a:noFill/>
-        </p:spPr>
-        <p:txBody>
-          <a:bodyPr wrap="square" lIns="0" rIns="0" tIns="0" bIns="0" anchor="t">
-            <a:noAutofit/>
-          </a:bodyPr>
-          <a:lstStyle/>
-          <a:p>
-            <a:pPr algn="l">
-              <a:lnSpc>
-                <a:spcPts val="2160"/>
-              </a:lnSpc>
-              <a:spcBef>
-                <a:spcPts val="0"/>
-              </a:spcBef>
-              <a:spcAft>
-                <a:spcPts val="0"/>
-              </a:spcAft>
-            </a:pPr>
-            <a:r>
-              <a:rPr sz="1800" b="1">
-                <a:solidFill>
-                  <a:srgbClr val="FFFFFF"/>
-                </a:solidFill>
-                <a:latin typeface="Arial"/>
-              </a:rPr>
-              <a:t>varQITE ZY, 66 gates</a:t>
-            </a:r>
-          </a:p>
-        </p:txBody>
-      </p:sp>
-      <p:sp>
-        <p:nvSpPr>
-          <p:cNvPr id="15" name="Rounded Rectangle 14"/>
-          <p:cNvSpPr/>
-          <p:nvPr/>
-        </p:nvSpPr>
-        <p:spPr>
-          <a:xfrm>
-            <a:off x="548640" y="2971800"/>
-            <a:ext cx="11094415" cy="420624"/>
-          </a:xfrm>
-          <a:prstGeom prst="roundRect">
-            <a:avLst>
-              <a:gd name="adj" fmla="val 17391"/>
-            </a:avLst>
-          </a:prstGeom>
-          <a:solidFill>
-            <a:srgbClr val="131B2E"/>
-          </a:solidFill>
-          <a:ln>
-            <a:noFill/>
-          </a:ln>
-          <a:effectLst/>
-        </p:spPr>
-        <p:style>
-          <a:lnRef idx="1">
-            <a:schemeClr val="accent1"/>
-          </a:lnRef>
-          <a:fillRef idx="3">
-            <a:schemeClr val="accent1"/>
-          </a:fillRef>
-          <a:effectRef idx="2">
-            <a:schemeClr val="accent1"/>
-          </a:effectRef>
-          <a:fontRef idx="minor">
-            <a:schemeClr val="lt1"/>
-          </a:fontRef>
-        </p:style>
-        <p:txBody>
-          <a:bodyPr rtlCol="0" anchor="ctr"/>
-          <a:lstStyle/>
-          <a:p>
-            <a:pPr algn="ctr"/>
-          </a:p>
-        </p:txBody>
-      </p:sp>
-      <p:sp>
-        <p:nvSpPr>
-          <p:cNvPr id="16" name="TextBox 15"/>
-          <p:cNvSpPr txBox="1"/>
-          <p:nvPr/>
-        </p:nvSpPr>
-        <p:spPr>
-          <a:xfrm>
-            <a:off x="749808" y="3035808"/>
-            <a:ext cx="3749040" cy="274320"/>
-          </a:xfrm>
-          <a:prstGeom prst="rect">
-            <a:avLst/>
-          </a:prstGeom>
-          <a:noFill/>
-        </p:spPr>
-        <p:txBody>
-          <a:bodyPr wrap="square" lIns="0" rIns="0" tIns="0" bIns="0" anchor="t">
-            <a:noAutofit/>
-          </a:bodyPr>
-          <a:lstStyle/>
-          <a:p>
-            <a:pPr algn="l">
-              <a:lnSpc>
-                <a:spcPts val="2160"/>
-              </a:lnSpc>
-              <a:spcBef>
-                <a:spcPts val="0"/>
-              </a:spcBef>
-              <a:spcAft>
-                <a:spcPts val="0"/>
-              </a:spcAft>
-            </a:pPr>
-            <a:r>
-              <a:rPr sz="1800" b="0">
-                <a:solidFill>
-                  <a:srgbClr val="A9B4C6"/>
-                </a:solidFill>
-                <a:latin typeface="Arial"/>
-              </a:rPr>
-              <a:t>Best answer, noise model</a:t>
-            </a:r>
-          </a:p>
-        </p:txBody>
-      </p:sp>
-      <p:sp>
-        <p:nvSpPr>
-          <p:cNvPr id="17" name="TextBox 16"/>
-          <p:cNvSpPr txBox="1"/>
-          <p:nvPr/>
-        </p:nvSpPr>
-        <p:spPr>
-          <a:xfrm>
-            <a:off x="4773168" y="3035808"/>
-            <a:ext cx="3264408" cy="274320"/>
-          </a:xfrm>
-          <a:prstGeom prst="rect">
-            <a:avLst/>
-          </a:prstGeom>
-          <a:noFill/>
-        </p:spPr>
-        <p:txBody>
-          <a:bodyPr wrap="square" lIns="0" rIns="0" tIns="0" bIns="0" anchor="t">
-            <a:noAutofit/>
-          </a:bodyPr>
-          <a:lstStyle/>
-          <a:p>
-            <a:pPr algn="l">
-              <a:lnSpc>
-                <a:spcPts val="2160"/>
-              </a:lnSpc>
-              <a:spcBef>
-                <a:spcPts val="0"/>
-              </a:spcBef>
-              <a:spcAft>
-                <a:spcPts val="0"/>
-              </a:spcAft>
-            </a:pPr>
-            <a:r>
-              <a:rPr sz="1800" b="1">
-                <a:solidFill>
-                  <a:srgbClr val="D9791A"/>
-                </a:solidFill>
-                <a:latin typeface="Arial"/>
-              </a:rPr>
-              <a:t>7 / 1,000 shots</a:t>
-            </a:r>
-          </a:p>
-        </p:txBody>
-      </p:sp>
-      <p:sp>
-        <p:nvSpPr>
-          <p:cNvPr id="18" name="TextBox 17"/>
-          <p:cNvSpPr txBox="1"/>
-          <p:nvPr/>
-        </p:nvSpPr>
-        <p:spPr>
-          <a:xfrm>
-            <a:off x="8311896" y="3035808"/>
-            <a:ext cx="3255264" cy="274320"/>
-          </a:xfrm>
-          <a:prstGeom prst="rect">
-            <a:avLst/>
-          </a:prstGeom>
-          <a:noFill/>
-        </p:spPr>
-        <p:txBody>
-          <a:bodyPr wrap="square" lIns="0" rIns="0" tIns="0" bIns="0" anchor="t">
-            <a:noAutofit/>
-          </a:bodyPr>
-          <a:lstStyle/>
-          <a:p>
-            <a:pPr algn="l">
-              <a:lnSpc>
-                <a:spcPts val="2160"/>
-              </a:lnSpc>
-              <a:spcBef>
-                <a:spcPts val="0"/>
-              </a:spcBef>
-              <a:spcAft>
-                <a:spcPts val="0"/>
-              </a:spcAft>
-            </a:pPr>
-            <a:r>
-              <a:rPr sz="1800" b="1">
-                <a:solidFill>
-                  <a:srgbClr val="D9791A"/>
-                </a:solidFill>
-                <a:latin typeface="Arial"/>
-              </a:rPr>
-              <a:t>278 / 1,000 shots</a:t>
-            </a:r>
-          </a:p>
-        </p:txBody>
-      </p:sp>
-      <p:sp>
-        <p:nvSpPr>
-          <p:cNvPr id="19" name="Rounded Rectangle 18"/>
-          <p:cNvSpPr/>
-          <p:nvPr/>
-        </p:nvSpPr>
-        <p:spPr>
-          <a:xfrm>
-            <a:off x="548640" y="3438144"/>
-            <a:ext cx="11094415" cy="420624"/>
-          </a:xfrm>
-          <a:prstGeom prst="roundRect">
-            <a:avLst>
-              <a:gd name="adj" fmla="val 17391"/>
-            </a:avLst>
-          </a:prstGeom>
-          <a:solidFill>
-            <a:srgbClr val="131B2E"/>
-          </a:solidFill>
-          <a:ln>
-            <a:noFill/>
-          </a:ln>
-          <a:effectLst/>
-        </p:spPr>
-        <p:style>
-          <a:lnRef idx="1">
-            <a:schemeClr val="accent1"/>
-          </a:lnRef>
-          <a:fillRef idx="3">
-            <a:schemeClr val="accent1"/>
-          </a:fillRef>
-          <a:effectRef idx="2">
-            <a:schemeClr val="accent1"/>
-          </a:effectRef>
-          <a:fontRef idx="minor">
-            <a:schemeClr val="lt1"/>
-          </a:fontRef>
-        </p:style>
-        <p:txBody>
-          <a:bodyPr rtlCol="0" anchor="ctr"/>
-          <a:lstStyle/>
-          <a:p>
-            <a:pPr algn="ctr"/>
-          </a:p>
-        </p:txBody>
-      </p:sp>
-      <p:sp>
-        <p:nvSpPr>
-          <p:cNvPr id="20" name="TextBox 19"/>
-          <p:cNvSpPr txBox="1"/>
-          <p:nvPr/>
-        </p:nvSpPr>
-        <p:spPr>
-          <a:xfrm>
-            <a:off x="749808" y="3502152"/>
-            <a:ext cx="3749040" cy="274320"/>
-          </a:xfrm>
-          <a:prstGeom prst="rect">
-            <a:avLst/>
-          </a:prstGeom>
-          <a:noFill/>
-        </p:spPr>
-        <p:txBody>
-          <a:bodyPr wrap="square" lIns="0" rIns="0" tIns="0" bIns="0" anchor="t">
-            <a:noAutofit/>
-          </a:bodyPr>
-          <a:lstStyle/>
-          <a:p>
-            <a:pPr algn="l">
-              <a:lnSpc>
-                <a:spcPts val="2160"/>
-              </a:lnSpc>
-              <a:spcBef>
-                <a:spcPts val="0"/>
-              </a:spcBef>
-              <a:spcAft>
-                <a:spcPts val="0"/>
-              </a:spcAft>
-            </a:pPr>
-            <a:r>
-              <a:rPr sz="1800" b="0">
-                <a:solidFill>
-                  <a:srgbClr val="A9B4C6"/>
-                </a:solidFill>
-                <a:latin typeface="Arial"/>
-              </a:rPr>
-              <a:t>Random guessing</a:t>
-            </a:r>
-          </a:p>
-        </p:txBody>
-      </p:sp>
-      <p:sp>
-        <p:nvSpPr>
-          <p:cNvPr id="21" name="TextBox 20"/>
-          <p:cNvSpPr txBox="1"/>
-          <p:nvPr/>
-        </p:nvSpPr>
-        <p:spPr>
-          <a:xfrm>
-            <a:off x="4773168" y="3502152"/>
-            <a:ext cx="3264408" cy="274320"/>
-          </a:xfrm>
-          <a:prstGeom prst="rect">
-            <a:avLst/>
-          </a:prstGeom>
-          <a:noFill/>
-        </p:spPr>
-        <p:txBody>
-          <a:bodyPr wrap="square" lIns="0" rIns="0" tIns="0" bIns="0" anchor="t">
-            <a:noAutofit/>
-          </a:bodyPr>
-          <a:lstStyle/>
-          <a:p>
-            <a:pPr algn="l">
-              <a:lnSpc>
-                <a:spcPts val="2160"/>
-              </a:lnSpc>
-              <a:spcBef>
-                <a:spcPts val="0"/>
-              </a:spcBef>
-              <a:spcAft>
-                <a:spcPts val="0"/>
-              </a:spcAft>
-            </a:pPr>
-            <a:r>
-              <a:rPr sz="1800" b="1">
-                <a:solidFill>
-                  <a:srgbClr val="FFFFFF"/>
-                </a:solidFill>
-                <a:latin typeface="Arial"/>
-              </a:rPr>
-              <a:t>0.24 / 1,000</a:t>
-            </a:r>
-          </a:p>
-        </p:txBody>
-      </p:sp>
-      <p:sp>
-        <p:nvSpPr>
-          <p:cNvPr id="22" name="TextBox 21"/>
-          <p:cNvSpPr txBox="1"/>
-          <p:nvPr/>
-        </p:nvSpPr>
-        <p:spPr>
-          <a:xfrm>
-            <a:off x="8311896" y="3502152"/>
-            <a:ext cx="3255264" cy="274320"/>
-          </a:xfrm>
-          <a:prstGeom prst="rect">
-            <a:avLst/>
-          </a:prstGeom>
-          <a:noFill/>
-        </p:spPr>
-        <p:txBody>
-          <a:bodyPr wrap="square" lIns="0" rIns="0" tIns="0" bIns="0" anchor="t">
-            <a:noAutofit/>
-          </a:bodyPr>
-          <a:lstStyle/>
-          <a:p>
-            <a:pPr algn="l">
-              <a:lnSpc>
-                <a:spcPts val="2160"/>
-              </a:lnSpc>
-              <a:spcBef>
-                <a:spcPts val="0"/>
-              </a:spcBef>
-              <a:spcAft>
-                <a:spcPts val="0"/>
-              </a:spcAft>
-            </a:pPr>
-            <a:r>
-              <a:rPr sz="1800" b="1">
-                <a:solidFill>
-                  <a:srgbClr val="FFFFFF"/>
-                </a:solidFill>
-                <a:latin typeface="Arial"/>
-              </a:rPr>
-              <a:t>0.49 / 1,000</a:t>
-            </a:r>
-          </a:p>
-        </p:txBody>
-      </p:sp>
-      <p:sp>
-        <p:nvSpPr>
-          <p:cNvPr id="23" name="Rounded Rectangle 22"/>
-          <p:cNvSpPr/>
-          <p:nvPr/>
-        </p:nvSpPr>
-        <p:spPr>
-          <a:xfrm>
-            <a:off x="548640" y="3904488"/>
-            <a:ext cx="11094415" cy="420624"/>
-          </a:xfrm>
-          <a:prstGeom prst="roundRect">
-            <a:avLst>
-              <a:gd name="adj" fmla="val 17391"/>
-            </a:avLst>
-          </a:prstGeom>
-          <a:solidFill>
-            <a:srgbClr val="131B2E"/>
-          </a:solidFill>
-          <a:ln>
-            <a:noFill/>
-          </a:ln>
-          <a:effectLst/>
-        </p:spPr>
-        <p:style>
-          <a:lnRef idx="1">
-            <a:schemeClr val="accent1"/>
-          </a:lnRef>
-          <a:fillRef idx="3">
-            <a:schemeClr val="accent1"/>
-          </a:fillRef>
-          <a:effectRef idx="2">
-            <a:schemeClr val="accent1"/>
-          </a:effectRef>
-          <a:fontRef idx="minor">
-            <a:schemeClr val="lt1"/>
-          </a:fontRef>
-        </p:style>
-        <p:txBody>
-          <a:bodyPr rtlCol="0" anchor="ctr"/>
-          <a:lstStyle/>
-          <a:p>
-            <a:pPr algn="ctr"/>
-          </a:p>
-        </p:txBody>
-      </p:sp>
-      <p:sp>
-        <p:nvSpPr>
-          <p:cNvPr id="24" name="TextBox 23"/>
-          <p:cNvSpPr txBox="1"/>
-          <p:nvPr/>
-        </p:nvSpPr>
-        <p:spPr>
-          <a:xfrm>
-            <a:off x="749808" y="3968496"/>
-            <a:ext cx="3749040" cy="274320"/>
-          </a:xfrm>
-          <a:prstGeom prst="rect">
-            <a:avLst/>
-          </a:prstGeom>
-          <a:noFill/>
-        </p:spPr>
-        <p:txBody>
-          <a:bodyPr wrap="square" lIns="0" rIns="0" tIns="0" bIns="0" anchor="t">
-            <a:noAutofit/>
-          </a:bodyPr>
-          <a:lstStyle/>
-          <a:p>
-            <a:pPr algn="l">
-              <a:lnSpc>
-                <a:spcPts val="2160"/>
-              </a:lnSpc>
-              <a:spcBef>
-                <a:spcPts val="0"/>
-              </a:spcBef>
-              <a:spcAft>
-                <a:spcPts val="0"/>
-              </a:spcAft>
-            </a:pPr>
-            <a:r>
-              <a:rPr sz="1800" b="0">
-                <a:solidFill>
-                  <a:srgbClr val="A9B4C6"/>
-                </a:solidFill>
-                <a:latin typeface="Arial"/>
-              </a:rPr>
-              <a:t>Gain over random guessing</a:t>
-            </a:r>
-          </a:p>
-        </p:txBody>
-      </p:sp>
-      <p:sp>
-        <p:nvSpPr>
-          <p:cNvPr id="25" name="TextBox 24"/>
-          <p:cNvSpPr txBox="1"/>
-          <p:nvPr/>
-        </p:nvSpPr>
-        <p:spPr>
-          <a:xfrm>
-            <a:off x="4773168" y="3968496"/>
-            <a:ext cx="3264408" cy="274320"/>
-          </a:xfrm>
-          <a:prstGeom prst="rect">
-            <a:avLst/>
-          </a:prstGeom>
-          <a:noFill/>
-        </p:spPr>
-        <p:txBody>
-          <a:bodyPr wrap="square" lIns="0" rIns="0" tIns="0" bIns="0" anchor="t">
-            <a:noAutofit/>
-          </a:bodyPr>
-          <a:lstStyle/>
-          <a:p>
-            <a:pPr algn="l">
-              <a:lnSpc>
-                <a:spcPts val="2160"/>
-              </a:lnSpc>
-              <a:spcBef>
-                <a:spcPts val="0"/>
-              </a:spcBef>
-              <a:spcAft>
-                <a:spcPts val="0"/>
-              </a:spcAft>
-            </a:pPr>
-            <a:r>
-              <a:rPr sz="1800" b="1">
-                <a:solidFill>
-                  <a:srgbClr val="FFFFFF"/>
-                </a:solidFill>
-                <a:latin typeface="Arial"/>
-              </a:rPr>
-              <a:t>29×</a:t>
-            </a:r>
-          </a:p>
-        </p:txBody>
-      </p:sp>
-      <p:sp>
-        <p:nvSpPr>
-          <p:cNvPr id="26" name="TextBox 25"/>
-          <p:cNvSpPr txBox="1"/>
-          <p:nvPr/>
-        </p:nvSpPr>
-        <p:spPr>
-          <a:xfrm>
-            <a:off x="8311896" y="3968496"/>
-            <a:ext cx="3255264" cy="274320"/>
-          </a:xfrm>
-          <a:prstGeom prst="rect">
-            <a:avLst/>
-          </a:prstGeom>
-          <a:noFill/>
-        </p:spPr>
-        <p:txBody>
-          <a:bodyPr wrap="square" lIns="0" rIns="0" tIns="0" bIns="0" anchor="t">
-            <a:noAutofit/>
-          </a:bodyPr>
-          <a:lstStyle/>
-          <a:p>
-            <a:pPr algn="l">
-              <a:lnSpc>
-                <a:spcPts val="2160"/>
-              </a:lnSpc>
-              <a:spcBef>
-                <a:spcPts val="0"/>
-              </a:spcBef>
-              <a:spcAft>
-                <a:spcPts val="0"/>
-              </a:spcAft>
-            </a:pPr>
-            <a:r>
-              <a:rPr sz="1800" b="1">
-                <a:solidFill>
-                  <a:srgbClr val="FFFFFF"/>
-                </a:solidFill>
-                <a:latin typeface="Arial"/>
-              </a:rPr>
-              <a:t>569×</a:t>
-            </a:r>
-          </a:p>
-        </p:txBody>
-      </p:sp>
-      <p:sp>
-        <p:nvSpPr>
-          <p:cNvPr id="27" name="Rounded Rectangle 26"/>
-          <p:cNvSpPr/>
-          <p:nvPr/>
-        </p:nvSpPr>
-        <p:spPr>
-          <a:xfrm>
-            <a:off x="548640" y="4370832"/>
-            <a:ext cx="11094415" cy="420624"/>
-          </a:xfrm>
-          <a:prstGeom prst="roundRect">
-            <a:avLst>
-              <a:gd name="adj" fmla="val 17391"/>
-            </a:avLst>
-          </a:prstGeom>
-          <a:solidFill>
-            <a:srgbClr val="131B2E"/>
-          </a:solidFill>
-          <a:ln>
-            <a:noFill/>
-          </a:ln>
-          <a:effectLst/>
-        </p:spPr>
-        <p:style>
-          <a:lnRef idx="1">
-            <a:schemeClr val="accent1"/>
-          </a:lnRef>
-          <a:fillRef idx="3">
-            <a:schemeClr val="accent1"/>
-          </a:fillRef>
-          <a:effectRef idx="2">
-            <a:schemeClr val="accent1"/>
-          </a:effectRef>
-          <a:fontRef idx="minor">
-            <a:schemeClr val="lt1"/>
-          </a:fontRef>
-        </p:style>
-        <p:txBody>
-          <a:bodyPr rtlCol="0" anchor="ctr"/>
-          <a:lstStyle/>
-          <a:p>
-            <a:pPr algn="ctr"/>
-          </a:p>
-        </p:txBody>
-      </p:sp>
-      <p:sp>
-        <p:nvSpPr>
-          <p:cNvPr id="28" name="TextBox 27"/>
-          <p:cNvSpPr txBox="1"/>
-          <p:nvPr/>
-        </p:nvSpPr>
-        <p:spPr>
-          <a:xfrm>
-            <a:off x="749808" y="4434840"/>
-            <a:ext cx="3749040" cy="274320"/>
-          </a:xfrm>
-          <a:prstGeom prst="rect">
-            <a:avLst/>
-          </a:prstGeom>
-          <a:noFill/>
-        </p:spPr>
-        <p:txBody>
-          <a:bodyPr wrap="square" lIns="0" rIns="0" tIns="0" bIns="0" anchor="t">
-            <a:noAutofit/>
-          </a:bodyPr>
-          <a:lstStyle/>
-          <a:p>
-            <a:pPr algn="l">
-              <a:lnSpc>
-                <a:spcPts val="2160"/>
-              </a:lnSpc>
-              <a:spcBef>
-                <a:spcPts val="0"/>
-              </a:spcBef>
-              <a:spcAft>
-                <a:spcPts val="0"/>
-              </a:spcAft>
-            </a:pPr>
-            <a:r>
-              <a:rPr sz="1800" b="0">
-                <a:solidFill>
-                  <a:srgbClr val="A9B4C6"/>
-                </a:solidFill>
-                <a:latin typeface="Arial"/>
-              </a:rPr>
-              <a:t>Noiseless simulation</a:t>
-            </a:r>
-          </a:p>
-        </p:txBody>
-      </p:sp>
-      <p:sp>
-        <p:nvSpPr>
-          <p:cNvPr id="29" name="TextBox 28"/>
-          <p:cNvSpPr txBox="1"/>
-          <p:nvPr/>
-        </p:nvSpPr>
-        <p:spPr>
-          <a:xfrm>
-            <a:off x="4773168" y="4434840"/>
-            <a:ext cx="3264408" cy="274320"/>
-          </a:xfrm>
-          <a:prstGeom prst="rect">
-            <a:avLst/>
-          </a:prstGeom>
-          <a:noFill/>
-        </p:spPr>
-        <p:txBody>
-          <a:bodyPr wrap="square" lIns="0" rIns="0" tIns="0" bIns="0" anchor="t">
-            <a:noAutofit/>
-          </a:bodyPr>
-          <a:lstStyle/>
-          <a:p>
-            <a:pPr algn="l">
-              <a:lnSpc>
-                <a:spcPts val="2160"/>
-              </a:lnSpc>
-              <a:spcBef>
-                <a:spcPts val="0"/>
-              </a:spcBef>
-              <a:spcAft>
-                <a:spcPts val="0"/>
-              </a:spcAft>
-            </a:pPr>
-            <a:r>
-              <a:rPr sz="1800" b="1">
-                <a:solidFill>
-                  <a:srgbClr val="FFFFFF"/>
-                </a:solidFill>
-                <a:latin typeface="Arial"/>
-              </a:rPr>
-              <a:t>58 / 1,000</a:t>
-            </a:r>
-          </a:p>
-        </p:txBody>
-      </p:sp>
-      <p:sp>
-        <p:nvSpPr>
-          <p:cNvPr id="30" name="TextBox 29"/>
-          <p:cNvSpPr txBox="1"/>
-          <p:nvPr/>
-        </p:nvSpPr>
-        <p:spPr>
-          <a:xfrm>
-            <a:off x="8311896" y="4434840"/>
-            <a:ext cx="3255264" cy="274320"/>
-          </a:xfrm>
-          <a:prstGeom prst="rect">
-            <a:avLst/>
-          </a:prstGeom>
-          <a:noFill/>
-        </p:spPr>
-        <p:txBody>
-          <a:bodyPr wrap="square" lIns="0" rIns="0" tIns="0" bIns="0" anchor="t">
-            <a:noAutofit/>
-          </a:bodyPr>
-          <a:lstStyle/>
-          <a:p>
-            <a:pPr algn="l">
-              <a:lnSpc>
-                <a:spcPts val="2160"/>
-              </a:lnSpc>
-              <a:spcBef>
-                <a:spcPts val="0"/>
-              </a:spcBef>
-              <a:spcAft>
-                <a:spcPts val="0"/>
-              </a:spcAft>
-            </a:pPr>
-            <a:r>
-              <a:rPr sz="1800" b="1">
-                <a:solidFill>
-                  <a:srgbClr val="FFFFFF"/>
-                </a:solidFill>
-                <a:latin typeface="Arial"/>
-              </a:rPr>
-              <a:t>750 / 1,000</a:t>
-            </a:r>
-          </a:p>
-        </p:txBody>
-      </p:sp>
-      <p:sp>
-        <p:nvSpPr>
-          <p:cNvPr id="31" name="TextBox 30"/>
-          <p:cNvSpPr txBox="1"/>
-          <p:nvPr/>
-        </p:nvSpPr>
-        <p:spPr>
-          <a:xfrm>
-            <a:off x="548640" y="4956048"/>
-            <a:ext cx="11094415" cy="274320"/>
-          </a:xfrm>
-          <a:prstGeom prst="rect">
-            <a:avLst/>
-          </a:prstGeom>
-          <a:noFill/>
-        </p:spPr>
-        <p:txBody>
-          <a:bodyPr wrap="square" lIns="0" rIns="0" tIns="0" bIns="0" anchor="t">
-            <a:noAutofit/>
-          </a:bodyPr>
-          <a:lstStyle/>
-          <a:p>
-            <a:pPr algn="l">
-              <a:lnSpc>
-                <a:spcPts val="2160"/>
-              </a:lnSpc>
-              <a:spcBef>
-                <a:spcPts val="0"/>
-              </a:spcBef>
-              <a:spcAft>
-                <a:spcPts val="0"/>
-              </a:spcAft>
-            </a:pPr>
-            <a:r>
-              <a:rPr sz="1800" b="0">
-                <a:solidFill>
-                  <a:srgbClr val="FFFFFF"/>
-                </a:solidFill>
-                <a:latin typeface="Arial"/>
-              </a:rPr>
-              <a:t>This effort is supported by Qollab &amp; IonQ</a:t>
-            </a:r>
-          </a:p>
-        </p:txBody>
-      </p:sp>
-      <p:sp>
-        <p:nvSpPr>
-          <p:cNvPr id="32" name="TextBox 31"/>
-          <p:cNvSpPr txBox="1"/>
-          <p:nvPr/>
-        </p:nvSpPr>
-        <p:spPr>
-          <a:xfrm>
-            <a:off x="548640" y="384048"/>
-            <a:ext cx="11094415" cy="274320"/>
-          </a:xfrm>
-          <a:prstGeom prst="rect">
-            <a:avLst/>
-          </a:prstGeom>
-          <a:noFill/>
-        </p:spPr>
-        <p:txBody>
-          <a:bodyPr wrap="square" lIns="0" rIns="0" tIns="0" bIns="0" anchor="t">
-            <a:noAutofit/>
-          </a:bodyPr>
-          <a:lstStyle/>
-          <a:p>
-            <a:pPr algn="l">
-              <a:lnSpc>
-                <a:spcPts val="2160"/>
-              </a:lnSpc>
-              <a:spcBef>
-                <a:spcPts val="0"/>
-              </a:spcBef>
-              <a:spcAft>
-                <a:spcPts val="0"/>
-              </a:spcAft>
-            </a:pPr>
-            <a:r>
-              <a:rPr sz="1800" b="1">
-                <a:solidFill>
-                  <a:srgbClr val="17A2B8"/>
-                </a:solidFill>
-                <a:latin typeface="Arial"/>
-              </a:rPr>
-              <a:t>APPENDIX</a:t>
-            </a:r>
-          </a:p>
-        </p:txBody>
-      </p:sp>
-      <p:sp>
-        <p:nvSpPr>
-          <p:cNvPr id="33" name="TextBox 32"/>
-          <p:cNvSpPr txBox="1"/>
-          <p:nvPr/>
-        </p:nvSpPr>
-        <p:spPr>
-          <a:xfrm>
-            <a:off x="548640" y="5513832"/>
-            <a:ext cx="11094415" cy="548640"/>
-          </a:xfrm>
-          <a:prstGeom prst="rect">
-            <a:avLst/>
-          </a:prstGeom>
-          <a:noFill/>
-        </p:spPr>
-        <p:txBody>
-          <a:bodyPr wrap="square" lIns="0" rIns="0" tIns="0" bIns="0" anchor="t">
-            <a:noAutofit/>
-          </a:bodyPr>
-          <a:lstStyle/>
-          <a:p>
-            <a:pPr algn="l">
-              <a:lnSpc>
-                <a:spcPts val="2160"/>
-              </a:lnSpc>
-              <a:spcBef>
-                <a:spcPts val="0"/>
-              </a:spcBef>
-              <a:spcAft>
-                <a:spcPts val="0"/>
-              </a:spcAft>
-            </a:pPr>
-            <a:r>
-              <a:rPr sz="1800" b="0">
-                <a:solidFill>
-                  <a:srgbClr val="A9B4C6"/>
-                </a:solidFill>
-                <a:latin typeface="Arial"/>
-              </a:rPr>
-              <a:t>IonQ Forte 1 noise model (Qollab): one 1,000-shot job per project, 11 Oct 2026 · noiseless: simulation</a:t>
-            </a:r>
-          </a:p>
-          <a:p>
-            <a:pPr algn="l">
-              <a:lnSpc>
-                <a:spcPts val="2160"/>
-              </a:lnSpc>
-              <a:spcBef>
-                <a:spcPts val="0"/>
-              </a:spcBef>
-              <a:spcAft>
-                <a:spcPts val="0"/>
-              </a:spcAft>
-            </a:pPr>
-            <a:r>
-              <a:rPr sz="1800" b="0">
-                <a:solidFill>
-                  <a:srgbClr val="A9B4C6"/>
-                </a:solidFill>
-                <a:latin typeface="Arial"/>
-              </a:rPr>
-              <a:t>Stocks: results/ionq_B_cvar_p3_*.json · Mesh: mesh/qollab/results_ionq/*.json on the mesh branch</a:t>
-            </a:r>
-          </a:p>
-        </p:txBody>
-      </p:sp>
-      <p:sp>
-        <p:nvSpPr>
-          <p:cNvPr id="34" name="TextBox 33"/>
-          <p:cNvSpPr txBox="1"/>
-          <p:nvPr/>
-        </p:nvSpPr>
-        <p:spPr>
-          <a:xfrm>
-            <a:off x="548640" y="6327648"/>
-            <a:ext cx="7315200" cy="274320"/>
-          </a:xfrm>
-          <a:prstGeom prst="rect">
-            <a:avLst/>
-          </a:prstGeom>
-          <a:noFill/>
-        </p:spPr>
-        <p:txBody>
-          <a:bodyPr wrap="square" lIns="0" rIns="0" tIns="0" bIns="0" anchor="t">
-            <a:noAutofit/>
-          </a:bodyPr>
-          <a:lstStyle/>
-          <a:p>
-            <a:pPr algn="l">
-              <a:lnSpc>
-                <a:spcPts val="2160"/>
-              </a:lnSpc>
-              <a:spcBef>
-                <a:spcPts val="0"/>
-              </a:spcBef>
-              <a:spcAft>
-                <a:spcPts val="0"/>
-              </a:spcAft>
-            </a:pPr>
-            <a:r>
-              <a:rPr sz="1800" b="0">
-                <a:solidFill>
-                  <a:srgbClr val="A9B4C6"/>
-                </a:solidFill>
-                <a:latin typeface="Arial"/>
-              </a:rPr>
-              <a:t>ZollerQu - Qollab x IonQ Hackathon 2026</a:t>
-            </a:r>
-          </a:p>
-        </p:txBody>
-      </p:sp>
-      <p:sp>
-        <p:nvSpPr>
-          <p:cNvPr id="35" name="TextBox 34"/>
           <p:cNvSpPr txBox="1"/>
           <p:nvPr/>
         </p:nvSpPr>

</xml_diff>

<commit_message>
docs(stocks): slide 4 names the best circuit per size (CVaR-QAOA at 12 qubits, linear-ramp QAOA at 16-29)
The build now checks that the circuit sent to IonQ is still the best 12-qubit candidate; the notes state that only
linear-ramp QAOA was simulated above 12 qubits.

Co-Authored-By: Claude Opus 5.5 <noreply@anthropic.com>
</commit_message>
<xml_diff>
--- a/slides/stocks_ZollerQu.pptx
+++ b/slides/stocks_ZollerQu.pptx
@@ -583,7 +583,7 @@
           <a:lstStyle/>
           <a:p>
             <a:r>
-              <a:t>Banks and funds build portfolios every day. They want low risk and a good return. Risk comes from assets that fall together, so the choices interact. Twelve assets give 4,096 possible portfolios; twenty-nine give more than five hundred million.</a:t>
+              <a:t>Banks and funds build portfolios every day. They want low risk and a good return. Risk comes from assets that fall together, so the choices interact. Twelve assets give 4,096 portfolios; twenty-nine give over five hundred million.</a:t>
             </a:r>
           </a:p>
         </p:txBody>
@@ -653,7 +653,7 @@
           <a:lstStyle/>
           <a:p>
             <a:r>
-              <a:t>Each asset becomes one qubit: zero means buy, one means skip. Risk minus return becomes an Ising energy with one coupling for every pair of assets, 66 couplings. For twelve assets we can check every portfolio, so we know the exact best one: Apple plus long-term Treasury bonds.</a:t>
+              <a:t>Each asset becomes one qubit: zero means buy, one means skip. Risk minus return becomes an Ising energy with one coupling per pair of assets: 66 couplings. For twelve assets we can check every portfolio, so we know the exact best one: Apple plus long-term Treasury bonds.</a:t>
             </a:r>
           </a:p>
         </p:txBody>
@@ -723,7 +723,7 @@
           <a:lstStyle/>
           <a:p>
             <a:r>
-              <a:t>The circuit is QAOA: Hadamard gates, a cost layer with one ZZ gate per pair, then a mixer, repeated three times. We compared 58 circuits from seven method families, all trained offline on a classical simulator. The best one, CVaR-QAOA, went to IonQ as a single job.</a:t>
+              <a:t>The circuit is QAOA: Hadamard gates, a cost layer with one ZZ gate per pair, then a mixer. We compared 58 circuits from seven families, all trained offline. At twelve qubits the best is CVaR-QAOA, which went to IonQ as a single job. At twenty-nine qubits we use linear-ramp QAOA, with angles reused from twelve.</a:t>
             </a:r>
           </a:p>
         </p:txBody>
@@ -7343,8 +7343,8 @@
         </p:nvSpPr>
         <p:spPr>
           <a:xfrm>
-            <a:off x="731520" y="4178808"/>
-            <a:ext cx="3179978" cy="335280"/>
+            <a:off x="731520" y="4169664"/>
+            <a:ext cx="3179978" cy="274320"/>
           </a:xfrm>
           <a:prstGeom prst="rect">
             <a:avLst/>
@@ -7359,23 +7359,23 @@
           <a:p>
             <a:pPr algn="l">
               <a:lnSpc>
-                <a:spcPts val="2640"/>
-              </a:lnSpc>
-              <a:spcBef>
-                <a:spcPts val="0"/>
-              </a:spcBef>
-              <a:spcAft>
-                <a:spcPts val="0"/>
-              </a:spcAft>
-            </a:pPr>
-            <a:r>
-              <a:rPr sz="2200" b="1">
-                <a:solidFill>
-                  <a:srgbClr val="FFFFFF"/>
-                </a:solidFill>
-                <a:latin typeface="Arial"/>
-              </a:rPr>
-              <a:t>7 method families</a:t>
+                <a:spcPts val="2160"/>
+              </a:lnSpc>
+              <a:spcBef>
+                <a:spcPts val="0"/>
+              </a:spcBef>
+              <a:spcAft>
+                <a:spcPts val="0"/>
+              </a:spcAft>
+            </a:pPr>
+            <a:r>
+              <a:rPr sz="1800" b="1">
+                <a:solidFill>
+                  <a:srgbClr val="17A2B8"/>
+                </a:solidFill>
+                <a:latin typeface="Arial"/>
+              </a:rPr>
+              <a:t>COMPARED</a:t>
             </a:r>
           </a:p>
         </p:txBody>
@@ -7388,8 +7388,8 @@
         </p:nvSpPr>
         <p:spPr>
           <a:xfrm>
-            <a:off x="731520" y="4559808"/>
-            <a:ext cx="3179978" cy="822960"/>
+            <a:off x="731520" y="4471416"/>
+            <a:ext cx="3179978" cy="335280"/>
           </a:xfrm>
           <a:prstGeom prst="rect">
             <a:avLst/>
@@ -7404,6 +7404,51 @@
           <a:p>
             <a:pPr algn="l">
               <a:lnSpc>
+                <a:spcPts val="2640"/>
+              </a:lnSpc>
+              <a:spcBef>
+                <a:spcPts val="0"/>
+              </a:spcBef>
+              <a:spcAft>
+                <a:spcPts val="0"/>
+              </a:spcAft>
+            </a:pPr>
+            <a:r>
+              <a:rPr sz="2200" b="1">
+                <a:solidFill>
+                  <a:srgbClr val="FFFFFF"/>
+                </a:solidFill>
+                <a:latin typeface="Arial"/>
+              </a:rPr>
+              <a:t>7 method families</a:t>
+            </a:r>
+          </a:p>
+        </p:txBody>
+      </p:sp>
+      <p:sp>
+        <p:nvSpPr>
+          <p:cNvPr id="7" name="TextBox 6"/>
+          <p:cNvSpPr txBox="1"/>
+          <p:nvPr/>
+        </p:nvSpPr>
+        <p:spPr>
+          <a:xfrm>
+            <a:off x="731520" y="4843272"/>
+            <a:ext cx="3179978" cy="548640"/>
+          </a:xfrm>
+          <a:prstGeom prst="rect">
+            <a:avLst/>
+          </a:prstGeom>
+          <a:noFill/>
+        </p:spPr>
+        <p:txBody>
+          <a:bodyPr wrap="square" lIns="0" rIns="0" tIns="0" bIns="0" anchor="t">
+            <a:noAutofit/>
+          </a:bodyPr>
+          <a:lstStyle/>
+          <a:p>
+            <a:pPr algn="l">
+              <a:lnSpc>
                 <a:spcPts val="2160"/>
               </a:lnSpc>
               <a:spcBef>
@@ -7420,7 +7465,7 @@
                 </a:solidFill>
                 <a:latin typeface="Arial"/>
               </a:rPr>
-              <a:t>58 circuits compared, from</a:t>
+              <a:t>58 circuits, trained offline</a:t>
             </a:r>
           </a:p>
           <a:p>
@@ -7442,36 +7487,14 @@
                 </a:solidFill>
                 <a:latin typeface="Arial"/>
               </a:rPr>
-              <a:t>linear-ramp and CVaR QAOA</a:t>
-            </a:r>
-          </a:p>
-          <a:p>
-            <a:pPr algn="l">
-              <a:lnSpc>
-                <a:spcPts val="2160"/>
-              </a:lnSpc>
-              <a:spcBef>
-                <a:spcPts val="0"/>
-              </a:spcBef>
-              <a:spcAft>
-                <a:spcPts val="0"/>
-              </a:spcAft>
-            </a:pPr>
-            <a:r>
-              <a:rPr sz="1800" b="0">
-                <a:solidFill>
-                  <a:srgbClr val="A9B4C6"/>
-                </a:solidFill>
-                <a:latin typeface="Arial"/>
-              </a:rPr>
-              <a:t>to imaginary-time evolution</a:t>
-            </a:r>
-          </a:p>
-        </p:txBody>
-      </p:sp>
-      <p:sp>
-        <p:nvSpPr>
-          <p:cNvPr id="7" name="Rounded Rectangle 6"/>
+              <a:t>on a classical simulator</a:t>
+            </a:r>
+          </a:p>
+        </p:txBody>
+      </p:sp>
+      <p:sp>
+        <p:nvSpPr>
+          <p:cNvPr id="8" name="Rounded Rectangle 7"/>
           <p:cNvSpPr/>
           <p:nvPr/>
         </p:nvSpPr>
@@ -7517,14 +7540,14 @@
       </p:sp>
       <p:sp>
         <p:nvSpPr>
-          <p:cNvPr id="8" name="TextBox 7"/>
+          <p:cNvPr id="9" name="TextBox 8"/>
           <p:cNvSpPr txBox="1"/>
           <p:nvPr/>
         </p:nvSpPr>
         <p:spPr>
           <a:xfrm>
-            <a:off x="4505858" y="4178808"/>
-            <a:ext cx="3179978" cy="335280"/>
+            <a:off x="4505858" y="4169664"/>
+            <a:ext cx="3179978" cy="274320"/>
           </a:xfrm>
           <a:prstGeom prst="rect">
             <a:avLst/>
@@ -7539,37 +7562,37 @@
           <a:p>
             <a:pPr algn="l">
               <a:lnSpc>
-                <a:spcPts val="2640"/>
-              </a:lnSpc>
-              <a:spcBef>
-                <a:spcPts val="0"/>
-              </a:spcBef>
-              <a:spcAft>
-                <a:spcPts val="0"/>
-              </a:spcAft>
-            </a:pPr>
-            <a:r>
-              <a:rPr sz="2200" b="1">
-                <a:solidFill>
-                  <a:srgbClr val="FFFFFF"/>
-                </a:solidFill>
-                <a:latin typeface="Arial"/>
-              </a:rPr>
-              <a:t>Trained offline</a:t>
-            </a:r>
-          </a:p>
-        </p:txBody>
-      </p:sp>
-      <p:sp>
-        <p:nvSpPr>
-          <p:cNvPr id="9" name="TextBox 8"/>
+                <a:spcPts val="2160"/>
+              </a:lnSpc>
+              <a:spcBef>
+                <a:spcPts val="0"/>
+              </a:spcBef>
+              <a:spcAft>
+                <a:spcPts val="0"/>
+              </a:spcAft>
+            </a:pPr>
+            <a:r>
+              <a:rPr sz="1800" b="1">
+                <a:solidFill>
+                  <a:srgbClr val="17A2B8"/>
+                </a:solidFill>
+                <a:latin typeface="Arial"/>
+              </a:rPr>
+              <a:t>BEST AT 12 QUBITS</a:t>
+            </a:r>
+          </a:p>
+        </p:txBody>
+      </p:sp>
+      <p:sp>
+        <p:nvSpPr>
+          <p:cNvPr id="10" name="TextBox 9"/>
           <p:cNvSpPr txBox="1"/>
           <p:nvPr/>
         </p:nvSpPr>
         <p:spPr>
           <a:xfrm>
-            <a:off x="4505858" y="4559808"/>
-            <a:ext cx="3179978" cy="822960"/>
+            <a:off x="4505858" y="4471416"/>
+            <a:ext cx="3179978" cy="335280"/>
           </a:xfrm>
           <a:prstGeom prst="rect">
             <a:avLst/>
@@ -7584,6 +7607,51 @@
           <a:p>
             <a:pPr algn="l">
               <a:lnSpc>
+                <a:spcPts val="2640"/>
+              </a:lnSpc>
+              <a:spcBef>
+                <a:spcPts val="0"/>
+              </a:spcBef>
+              <a:spcAft>
+                <a:spcPts val="0"/>
+              </a:spcAft>
+            </a:pPr>
+            <a:r>
+              <a:rPr sz="2200" b="1">
+                <a:solidFill>
+                  <a:srgbClr val="D9791A"/>
+                </a:solidFill>
+                <a:latin typeface="Arial"/>
+              </a:rPr>
+              <a:t>CVaR-QAOA</a:t>
+            </a:r>
+          </a:p>
+        </p:txBody>
+      </p:sp>
+      <p:sp>
+        <p:nvSpPr>
+          <p:cNvPr id="11" name="TextBox 10"/>
+          <p:cNvSpPr txBox="1"/>
+          <p:nvPr/>
+        </p:nvSpPr>
+        <p:spPr>
+          <a:xfrm>
+            <a:off x="4505858" y="4843272"/>
+            <a:ext cx="3179978" cy="548640"/>
+          </a:xfrm>
+          <a:prstGeom prst="rect">
+            <a:avLst/>
+          </a:prstGeom>
+          <a:noFill/>
+        </p:spPr>
+        <p:txBody>
+          <a:bodyPr wrap="square" lIns="0" rIns="0" tIns="0" bIns="0" anchor="t">
+            <a:noAutofit/>
+          </a:bodyPr>
+          <a:lstStyle/>
+          <a:p>
+            <a:pPr algn="l">
+              <a:lnSpc>
                 <a:spcPts val="2160"/>
               </a:lnSpc>
               <a:spcBef>
@@ -7600,7 +7668,7 @@
                 </a:solidFill>
                 <a:latin typeface="Arial"/>
               </a:rPr>
-              <a:t>Angles tuned on an exact</a:t>
+              <a:t>3 layers, 198 two-qubit gates,</a:t>
             </a:r>
           </a:p>
           <a:p>
@@ -7622,36 +7690,14 @@
                 </a:solidFill>
                 <a:latin typeface="Arial"/>
               </a:rPr>
-              <a:t>classical simulator, never</a:t>
-            </a:r>
-          </a:p>
-          <a:p>
-            <a:pPr algn="l">
-              <a:lnSpc>
-                <a:spcPts val="2160"/>
-              </a:lnSpc>
-              <a:spcBef>
-                <a:spcPts val="0"/>
-              </a:spcBef>
-              <a:spcAft>
-                <a:spcPts val="0"/>
-              </a:spcAft>
-            </a:pPr>
-            <a:r>
-              <a:rPr sz="1800" b="0">
-                <a:solidFill>
-                  <a:srgbClr val="A9B4C6"/>
-                </a:solidFill>
-                <a:latin typeface="Arial"/>
-              </a:rPr>
-              <a:t>on the IonQ backend</a:t>
-            </a:r>
-          </a:p>
-        </p:txBody>
-      </p:sp>
-      <p:sp>
-        <p:nvSpPr>
-          <p:cNvPr id="10" name="Rounded Rectangle 9"/>
+              <a:t>sent to IonQ as one job</a:t>
+            </a:r>
+          </a:p>
+        </p:txBody>
+      </p:sp>
+      <p:sp>
+        <p:nvSpPr>
+          <p:cNvPr id="12" name="Rounded Rectangle 11"/>
           <p:cNvSpPr/>
           <p:nvPr/>
         </p:nvSpPr>
@@ -7697,14 +7743,14 @@
       </p:sp>
       <p:sp>
         <p:nvSpPr>
-          <p:cNvPr id="11" name="TextBox 10"/>
+          <p:cNvPr id="13" name="TextBox 12"/>
           <p:cNvSpPr txBox="1"/>
           <p:nvPr/>
         </p:nvSpPr>
         <p:spPr>
           <a:xfrm>
-            <a:off x="8280197" y="4178808"/>
-            <a:ext cx="3179978" cy="335280"/>
+            <a:off x="8280197" y="4169664"/>
+            <a:ext cx="3179978" cy="274320"/>
           </a:xfrm>
           <a:prstGeom prst="rect">
             <a:avLst/>
@@ -7719,37 +7765,37 @@
           <a:p>
             <a:pPr algn="l">
               <a:lnSpc>
-                <a:spcPts val="2640"/>
-              </a:lnSpc>
-              <a:spcBef>
-                <a:spcPts val="0"/>
-              </a:spcBef>
-              <a:spcAft>
-                <a:spcPts val="0"/>
-              </a:spcAft>
-            </a:pPr>
-            <a:r>
-              <a:rPr sz="2200" b="1">
-                <a:solidFill>
-                  <a:srgbClr val="D9791A"/>
-                </a:solidFill>
-                <a:latin typeface="Arial"/>
-              </a:rPr>
-              <a:t>One circuit per job</a:t>
-            </a:r>
-          </a:p>
-        </p:txBody>
-      </p:sp>
-      <p:sp>
-        <p:nvSpPr>
-          <p:cNvPr id="12" name="TextBox 11"/>
+                <a:spcPts val="2160"/>
+              </a:lnSpc>
+              <a:spcBef>
+                <a:spcPts val="0"/>
+              </a:spcBef>
+              <a:spcAft>
+                <a:spcPts val="0"/>
+              </a:spcAft>
+            </a:pPr>
+            <a:r>
+              <a:rPr sz="1800" b="1">
+                <a:solidFill>
+                  <a:srgbClr val="17A2B8"/>
+                </a:solidFill>
+                <a:latin typeface="Arial"/>
+              </a:rPr>
+              <a:t>AT 16, 20, 29 QUBITS</a:t>
+            </a:r>
+          </a:p>
+        </p:txBody>
+      </p:sp>
+      <p:sp>
+        <p:nvSpPr>
+          <p:cNvPr id="14" name="TextBox 13"/>
           <p:cNvSpPr txBox="1"/>
           <p:nvPr/>
         </p:nvSpPr>
         <p:spPr>
           <a:xfrm>
-            <a:off x="8280197" y="4559808"/>
-            <a:ext cx="3179978" cy="822960"/>
+            <a:off x="8280197" y="4471416"/>
+            <a:ext cx="3179978" cy="335280"/>
           </a:xfrm>
           <a:prstGeom prst="rect">
             <a:avLst/>
@@ -7764,81 +7810,37 @@
           <a:p>
             <a:pPr algn="l">
               <a:lnSpc>
-                <a:spcPts val="2160"/>
-              </a:lnSpc>
-              <a:spcBef>
-                <a:spcPts val="0"/>
-              </a:spcBef>
-              <a:spcAft>
-                <a:spcPts val="0"/>
-              </a:spcAft>
-            </a:pPr>
-            <a:r>
-              <a:rPr sz="1800" b="0">
-                <a:solidFill>
-                  <a:srgbClr val="A9B4C6"/>
-                </a:solidFill>
-                <a:latin typeface="Arial"/>
-              </a:rPr>
-              <a:t>CVaR-QAOA, 3 layers:</a:t>
-            </a:r>
-          </a:p>
-          <a:p>
-            <a:pPr algn="l">
-              <a:lnSpc>
-                <a:spcPts val="2160"/>
-              </a:lnSpc>
-              <a:spcBef>
-                <a:spcPts val="0"/>
-              </a:spcBef>
-              <a:spcAft>
-                <a:spcPts val="0"/>
-              </a:spcAft>
-            </a:pPr>
-            <a:r>
-              <a:rPr sz="1800" b="0">
-                <a:solidFill>
-                  <a:srgbClr val="A9B4C6"/>
-                </a:solidFill>
-                <a:latin typeface="Arial"/>
-              </a:rPr>
-              <a:t>12 qubits, 198 two-qubit</a:t>
-            </a:r>
-          </a:p>
-          <a:p>
-            <a:pPr algn="l">
-              <a:lnSpc>
-                <a:spcPts val="2160"/>
-              </a:lnSpc>
-              <a:spcBef>
-                <a:spcPts val="0"/>
-              </a:spcBef>
-              <a:spcAft>
-                <a:spcPts val="0"/>
-              </a:spcAft>
-            </a:pPr>
-            <a:r>
-              <a:rPr sz="1800" b="0">
-                <a:solidFill>
-                  <a:srgbClr val="A9B4C6"/>
-                </a:solidFill>
-                <a:latin typeface="Arial"/>
-              </a:rPr>
-              <a:t>gates, 1,000 shots</a:t>
-            </a:r>
-          </a:p>
-        </p:txBody>
-      </p:sp>
-      <p:sp>
-        <p:nvSpPr>
-          <p:cNvPr id="13" name="TextBox 12"/>
+                <a:spcPts val="2640"/>
+              </a:lnSpc>
+              <a:spcBef>
+                <a:spcPts val="0"/>
+              </a:spcBef>
+              <a:spcAft>
+                <a:spcPts val="0"/>
+              </a:spcAft>
+            </a:pPr>
+            <a:r>
+              <a:rPr sz="2200" b="1">
+                <a:solidFill>
+                  <a:srgbClr val="FFFFFF"/>
+                </a:solidFill>
+                <a:latin typeface="Arial"/>
+              </a:rPr>
+              <a:t>Linear-ramp QAOA</a:t>
+            </a:r>
+          </a:p>
+        </p:txBody>
+      </p:sp>
+      <p:sp>
+        <p:nvSpPr>
+          <p:cNvPr id="15" name="TextBox 14"/>
           <p:cNvSpPr txBox="1"/>
           <p:nvPr/>
         </p:nvSpPr>
         <p:spPr>
           <a:xfrm>
-            <a:off x="548640" y="384048"/>
-            <a:ext cx="11094415" cy="274320"/>
+            <a:off x="8280197" y="4843272"/>
+            <a:ext cx="3179978" cy="548640"/>
           </a:xfrm>
           <a:prstGeom prst="rect">
             <a:avLst/>
@@ -7863,26 +7865,48 @@
               </a:spcAft>
             </a:pPr>
             <a:r>
-              <a:rPr sz="1800" b="1">
-                <a:solidFill>
-                  <a:srgbClr val="17A2B8"/>
-                </a:solidFill>
-                <a:latin typeface="Arial"/>
-              </a:rPr>
-              <a:t>QUANTUM METHOD</a:t>
-            </a:r>
-          </a:p>
-        </p:txBody>
-      </p:sp>
-      <p:sp>
-        <p:nvSpPr>
-          <p:cNvPr id="14" name="TextBox 13"/>
+              <a:rPr sz="1800" b="0">
+                <a:solidFill>
+                  <a:srgbClr val="A9B4C6"/>
+                </a:solidFill>
+                <a:latin typeface="Arial"/>
+              </a:rPr>
+              <a:t>Angles reused from 12 qubits,</a:t>
+            </a:r>
+          </a:p>
+          <a:p>
+            <a:pPr algn="l">
+              <a:lnSpc>
+                <a:spcPts val="2160"/>
+              </a:lnSpc>
+              <a:spcBef>
+                <a:spcPts val="0"/>
+              </a:spcBef>
+              <a:spcAft>
+                <a:spcPts val="0"/>
+              </a:spcAft>
+            </a:pPr>
+            <a:r>
+              <a:rPr sz="1800" b="0">
+                <a:solidFill>
+                  <a:srgbClr val="A9B4C6"/>
+                </a:solidFill>
+                <a:latin typeface="Arial"/>
+              </a:rPr>
+              <a:t>no new training</a:t>
+            </a:r>
+          </a:p>
+        </p:txBody>
+      </p:sp>
+      <p:sp>
+        <p:nvSpPr>
+          <p:cNvPr id="16" name="TextBox 15"/>
           <p:cNvSpPr txBox="1"/>
           <p:nvPr/>
         </p:nvSpPr>
         <p:spPr>
           <a:xfrm>
-            <a:off x="548640" y="5788152"/>
+            <a:off x="548640" y="384048"/>
             <a:ext cx="11094415" cy="274320"/>
           </a:xfrm>
           <a:prstGeom prst="rect">
@@ -7908,27 +7932,27 @@
               </a:spcAft>
             </a:pPr>
             <a:r>
-              <a:rPr sz="1800" b="0">
-                <a:solidFill>
-                  <a:srgbClr val="A9B4C6"/>
-                </a:solidFill>
-                <a:latin typeface="Arial"/>
-              </a:rPr>
-              <a:t>58 circuits and a random-guess control scored by noiseless simulation (server), 12 qubits</a:t>
-            </a:r>
-          </a:p>
-        </p:txBody>
-      </p:sp>
-      <p:sp>
-        <p:nvSpPr>
-          <p:cNvPr id="15" name="TextBox 14"/>
+              <a:rPr sz="1800" b="1">
+                <a:solidFill>
+                  <a:srgbClr val="17A2B8"/>
+                </a:solidFill>
+                <a:latin typeface="Arial"/>
+              </a:rPr>
+              <a:t>QUANTUM METHOD</a:t>
+            </a:r>
+          </a:p>
+        </p:txBody>
+      </p:sp>
+      <p:sp>
+        <p:nvSpPr>
+          <p:cNvPr id="17" name="TextBox 16"/>
           <p:cNvSpPr txBox="1"/>
           <p:nvPr/>
         </p:nvSpPr>
         <p:spPr>
           <a:xfrm>
-            <a:off x="548640" y="6327648"/>
-            <a:ext cx="7315200" cy="274320"/>
+            <a:off x="548640" y="5788152"/>
+            <a:ext cx="11094415" cy="274320"/>
           </a:xfrm>
           <a:prstGeom prst="rect">
             <a:avLst/>
@@ -7959,6 +7983,51 @@
                 </a:solidFill>
                 <a:latin typeface="Arial"/>
               </a:rPr>
+              <a:t>12 qubits: 58 circuits + a random-guess control, noiseless simulation · 16-29 qubits: server simulation</a:t>
+            </a:r>
+          </a:p>
+        </p:txBody>
+      </p:sp>
+      <p:sp>
+        <p:nvSpPr>
+          <p:cNvPr id="18" name="TextBox 17"/>
+          <p:cNvSpPr txBox="1"/>
+          <p:nvPr/>
+        </p:nvSpPr>
+        <p:spPr>
+          <a:xfrm>
+            <a:off x="548640" y="6327648"/>
+            <a:ext cx="7315200" cy="274320"/>
+          </a:xfrm>
+          <a:prstGeom prst="rect">
+            <a:avLst/>
+          </a:prstGeom>
+          <a:noFill/>
+        </p:spPr>
+        <p:txBody>
+          <a:bodyPr wrap="square" lIns="0" rIns="0" tIns="0" bIns="0" anchor="t">
+            <a:noAutofit/>
+          </a:bodyPr>
+          <a:lstStyle/>
+          <a:p>
+            <a:pPr algn="l">
+              <a:lnSpc>
+                <a:spcPts val="2160"/>
+              </a:lnSpc>
+              <a:spcBef>
+                <a:spcPts val="0"/>
+              </a:spcBef>
+              <a:spcAft>
+                <a:spcPts val="0"/>
+              </a:spcAft>
+            </a:pPr>
+            <a:r>
+              <a:rPr sz="1800" b="0">
+                <a:solidFill>
+                  <a:srgbClr val="A9B4C6"/>
+                </a:solidFill>
+                <a:latin typeface="Arial"/>
+              </a:rPr>
               <a:t>ZollerQu - Qollab x IonQ Hackathon 2026</a:t>
             </a:r>
           </a:p>
@@ -7966,7 +8035,7 @@
       </p:sp>
       <p:sp>
         <p:nvSpPr>
-          <p:cNvPr id="16" name="TextBox 15"/>
+          <p:cNvPr id="19" name="TextBox 18"/>
           <p:cNvSpPr txBox="1"/>
           <p:nvPr/>
         </p:nvSpPr>

</xml_diff>

<commit_message>
docs(stocks): 29-asset depth experiment in the notebook (4.15), deck slide 7 and the paper
Notebook 4.15 reads the saved results: full table, depth chart for both problems, the 3-layer changes,
and a same-budget table. Deck slide 7 now shows the 29-asset depth result (noiseless only) and slide 8's
last next step is the depth the noise allows (spoken script 380 words). Paper: new Sec. 9 (figure, table and
text generated from results/stocks_exp29_summary.json), new Sec. 10 with the recorded IonQ Forte 1
noise-model run, updated abstract, gate-count note and limitations (7 pages).

Co-Authored-By: Claude Opus 5.5 <noreply@anthropic.com>
</commit_message>
<xml_diff>
--- a/slides/stocks_ZollerQu.pptx
+++ b/slides/stocks_ZollerQu.pptx
@@ -933,7 +933,7 @@
           <a:lstStyle/>
           <a:p>
             <a:r>
-              <a:t>In noiseless simulation up to twenty-nine qubits the circuit stays far above random guessing, but classical heuristics win: they find the best portfolio in 61 percent of runs, the circuit in 7 percent. And our circuit first needed about 4,900 training circuits. We claim no quantum advantage.</a:t>
+              <a:t>At twenty-nine assets the three-layer circuit finds the best portfolio in 7 percent of runs, classical methods in 61. With more layers, the noiseless circuit reaches 90 percent at sixteen. But that is six and a half thousand two-qubit gates, far beyond today's noise. No advantage is claimed.</a:t>
             </a:r>
           </a:p>
         </p:txBody>
@@ -1003,7 +1003,7 @@
           <a:lstStyle/>
           <a:p>
             <a:r>
-              <a:t>[CUT TO LIVE QOLLAB DEMO] Here is the project on Qollab, with the code in main.py. We press Run, select the IonQ Forte 1 noise model, and one job returns counts and plots. [BACK TO SLIDE] Our limits: a noisy simulator, one job, and strong classical baselines. Next: the other selected circuits, shorter circuits, and twenty-nine assets.</a:t>
+              <a:t>[CUT TO LIVE QOLLAB DEMO] Here is the project on Qollab, with the code in main.py. We press Run, select the IonQ Forte 1 noise model, and one job returns counts and plots. [BACK TO SLIDE] Our limits: a noisy simulator, one job, and strong classical baselines. Next: other circuits, shorter circuits, and the depth noise allows.</a:t>
             </a:r>
           </a:p>
         </p:txBody>
@@ -9318,14 +9318,14 @@
                 </a:solidFill>
                 <a:latin typeface="Arial"/>
               </a:rPr>
-              <a:t>Up to 29 qubits, classical heuristics win</a:t>
+              <a:t>29 qubits: more layers help, only without noise</a:t>
             </a:r>
           </a:p>
         </p:txBody>
       </p:sp>
       <p:pic>
         <p:nvPicPr>
-          <p:cNvPr id="3" name="Picture 2" descr="Line chart: share of runs that find the best portfolio within 1,000 evaluations, against the number of assets. QAOA in noiseless simulation: 100 % at 12, 89 % at 16, 66 % at 20 and 6.6 % at 29 qubits. Classical methods: 100 % at 12 and 61 % at 29. Random guessing: 22 % at 12 and about 0 % from 20 on."/>
+          <p:cNvPr id="3" name="Picture 2" descr="Line chart for 29 assets: share of 1,000-shot runs that contain the exact best portfolio, against the number of layers, in noiseless simulation. With the ramp tuned on a wider grid: 6.6 % at 3 layers, 62 % at 12, 90 % at 16, 99.6 % at 24 and 100 % at 32. With the ramp as in the paper: 45 % at 16 layers. Classical methods with 1,000 evaluations: 61 %."/>
           <p:cNvPicPr>
             <a:picLocks noChangeAspect="1"/>
           </p:cNvPicPr>
@@ -9445,7 +9445,7 @@
         <p:spPr>
           <a:xfrm>
             <a:off x="7863840" y="2072640"/>
-            <a:ext cx="3776472" cy="548640"/>
+            <a:ext cx="3776472" cy="274320"/>
           </a:xfrm>
           <a:prstGeom prst="rect">
             <a:avLst/>
@@ -9476,29 +9476,7 @@
                 </a:solidFill>
                 <a:latin typeface="Arial"/>
               </a:rPr>
-              <a:t>Training came first: 4,860</a:t>
-            </a:r>
-          </a:p>
-          <a:p>
-            <a:pPr algn="l">
-              <a:lnSpc>
-                <a:spcPts val="2160"/>
-              </a:lnSpc>
-              <a:spcBef>
-                <a:spcPts val="0"/>
-              </a:spcBef>
-              <a:spcAft>
-                <a:spcPts val="0"/>
-              </a:spcAft>
-            </a:pPr>
-            <a:r>
-              <a:rPr sz="1800" b="0">
-                <a:solidFill>
-                  <a:srgbClr val="FFFFFF"/>
-                </a:solidFill>
-                <a:latin typeface="Arial"/>
-              </a:rPr>
-              <a:t>simulated circuits</a:t>
+              <a:t>Noiseless simulation only</a:t>
             </a:r>
           </a:p>
         </p:txBody>
@@ -9511,7 +9489,7 @@
         </p:nvSpPr>
         <p:spPr>
           <a:xfrm>
-            <a:off x="7589520" y="2863596"/>
+            <a:off x="7589520" y="2589276"/>
             <a:ext cx="100584" cy="100584"/>
           </a:xfrm>
           <a:prstGeom prst="ellipse">
@@ -9555,8 +9533,8 @@
         </p:nvSpPr>
         <p:spPr>
           <a:xfrm>
-            <a:off x="7863840" y="2776728"/>
-            <a:ext cx="3776472" cy="548640"/>
+            <a:off x="7863840" y="2502408"/>
+            <a:ext cx="3776472" cy="822960"/>
           </a:xfrm>
           <a:prstGeom prst="rect">
             <a:avLst/>
@@ -9587,7 +9565,7 @@
                 </a:solidFill>
                 <a:latin typeface="Arial"/>
               </a:rPr>
-              <a:t>A shot is not the same work</a:t>
+              <a:t>16 layers = 6,496 two-qubit</a:t>
             </a:r>
           </a:p>
           <a:p>
@@ -9609,7 +9587,29 @@
                 </a:solidFill>
                 <a:latin typeface="Arial"/>
               </a:rPr>
-              <a:t>as a classical evaluation</a:t>
+              <a:t>gates; our 198-gate IonQ run</a:t>
+            </a:r>
+          </a:p>
+          <a:p>
+            <a:pPr algn="l">
+              <a:lnSpc>
+                <a:spcPts val="2160"/>
+              </a:lnSpc>
+              <a:spcBef>
+                <a:spcPts val="0"/>
+              </a:spcBef>
+              <a:spcAft>
+                <a:spcPts val="0"/>
+              </a:spcAft>
+            </a:pPr>
+            <a:r>
+              <a:rPr sz="1800" b="0">
+                <a:solidFill>
+                  <a:srgbClr val="FFFFFF"/>
+                </a:solidFill>
+                <a:latin typeface="Arial"/>
+              </a:rPr>
+              <a:t>lost a factor 8 to noise</a:t>
             </a:r>
           </a:p>
         </p:txBody>
@@ -9698,7 +9698,7 @@
                 </a:solidFill>
                 <a:latin typeface="Arial"/>
               </a:rPr>
-              <a:t>12 assets: greedy needs 73</a:t>
+              <a:t>Classical: 100 % with 10,000</a:t>
             </a:r>
           </a:p>
           <a:p>
@@ -9720,7 +9720,7 @@
                 </a:solidFill>
                 <a:latin typeface="Arial"/>
               </a:rPr>
-              <a:t>evaluations, our noisy run 99</a:t>
+              <a:t>evaluations</a:t>
             </a:r>
           </a:p>
         </p:txBody>
@@ -9809,7 +9809,7 @@
                 </a:solidFill>
                 <a:latin typeface="Arial"/>
               </a:rPr>
-              <a:t>29 qubits: noiseless simulation</a:t>
+              <a:t>A shot is not the same work</a:t>
             </a:r>
           </a:p>
           <a:p>
@@ -9831,7 +9831,7 @@
                 </a:solidFill>
                 <a:latin typeface="Arial"/>
               </a:rPr>
-              <a:t>only, angles reused from 12</a:t>
+              <a:t>as a classical evaluation</a:t>
             </a:r>
           </a:p>
         </p:txBody>
@@ -9921,7 +9921,7 @@
                 </a:solidFill>
                 <a:latin typeface="Arial"/>
               </a:rPr>
-              <a:t>12-20 qubits: server simulation, 10 Oct 2026 · 29 qubits: server simulation of all 536,870,912 states,</a:t>
+              <a:t>Server simulation of all 536,870,912 states, 11 Oct 2026; ramp tuned at 12 assets, no tuning at 29</a:t>
             </a:r>
           </a:p>
           <a:p>
@@ -9943,7 +9943,7 @@
                 </a:solidFill>
                 <a:latin typeface="Arial"/>
               </a:rPr>
-              <a:t>11 Oct 2026 · classical: 200 runs · the same 1,000 evaluations for every method</a:t>
+              <a:t>Classical: greedy descent and annealing, 200 runs, the same 1,000 evaluations</a:t>
             </a:r>
           </a:p>
         </p:txBody>
@@ -11287,7 +11287,7 @@
                 </a:solidFill>
                 <a:latin typeface="Arial"/>
               </a:rPr>
-              <a:t>29 assets on the IonQ Forte 1 noise model</a:t>
+              <a:t>Find how many layers the noise allows</a:t>
             </a:r>
           </a:p>
         </p:txBody>

</xml_diff>

<commit_message>
docs(stocks): Iceberg slide (fault coverage, cost, Qollab IonQ-simulator check) and the recorded sweep summaries
New slide 9: share of single faults caught or harmless (exact injection, 5,904 faults), 17 qubits and +58 % two-qubit
gates at 3 layers, and the 12 Qollab jobs in which every check passed (the noise model was not applied to them; recorded
as such in results/qollab_iceberg_sweeps_20261011.json). Spoken script 380 words, 11 slides.

Co-Authored-By: Claude Opus 5.5 <noreply@anthropic.com>
</commit_message>
<xml_diff>
--- a/slides/stocks_ZollerQu.pptx
+++ b/slides/stocks_ZollerQu.pptx
@@ -18,6 +18,7 @@
     <p:sldId id="263" r:id="rId15"/>
     <p:sldId id="264" r:id="rId16"/>
     <p:sldId id="265" r:id="rId17"/>
+    <p:sldId id="266" r:id="rId18"/>
   </p:sldIdLst>
   <p:sldSz cx="12191695" cy="6858000" type="screen4x3"/>
   <p:notesSz cx="6858000" cy="9144000"/>
@@ -584,6 +585,76 @@
           <a:lstStyle/>
           <a:p>
             <a:r>
+              <a:t>[CUT TO LIVE QOLLAB DEMO] Here is our Qollab project; the code is in main.py. We press Run, choose the IonQ Forte 1 noise model, and get counts and plots. [BACK TO SLIDE] Limits: a noisy simulator and strong classical baselines. Next: Iceberg under real noise, and shorter circuits.</a:t>
+            </a:r>
+          </a:p>
+        </p:txBody>
+      </p:sp>
+      <p:sp>
+        <p:nvSpPr>
+          <p:cNvPr id="4" name="Slide Number Placeholder 3"/>
+          <p:cNvSpPr>
+            <a:spLocks noGrp="1"/>
+          </p:cNvSpPr>
+          <p:nvPr>
+            <p:ph type="sldNum" idx="5" sz="quarter"/>
+          </p:nvPr>
+        </p:nvSpPr>
+        <p:spPr/>
+      </p:sp>
+    </p:spTree>
+  </p:cSld>
+  <p:clrMapOvr>
+    <a:masterClrMapping/>
+  </p:clrMapOvr>
+</p:notes>
+</file>
+
+<file path=ppt/notesSlides/notesSlide11.xml><?xml version="1.0" encoding="utf-8"?>
+<p:notes xmlns:a="http://schemas.openxmlformats.org/drawingml/2006/main" xmlns:p="http://schemas.openxmlformats.org/presentationml/2006/main" xmlns:r="http://schemas.openxmlformats.org/officeDocument/2006/relationships">
+  <p:cSld>
+    <p:spTree>
+      <p:nvGrpSpPr>
+        <p:cNvPr id="1" name=""/>
+        <p:cNvGrpSpPr/>
+        <p:nvPr/>
+      </p:nvGrpSpPr>
+      <p:grpSpPr>
+        <a:xfrm>
+          <a:off x="0" y="0"/>
+          <a:ext cx="0" cy="0"/>
+          <a:chOff x="0" y="0"/>
+          <a:chExt cx="0" cy="0"/>
+        </a:xfrm>
+      </p:grpSpPr>
+      <p:sp>
+        <p:nvSpPr>
+          <p:cNvPr id="2" name="Slide Image Placeholder 1"/>
+          <p:cNvSpPr>
+            <a:spLocks noGrp="1"/>
+          </p:cNvSpPr>
+          <p:nvPr>
+            <p:ph type="sldImg" idx="2"/>
+          </p:nvPr>
+        </p:nvSpPr>
+        <p:spPr/>
+      </p:sp>
+      <p:sp>
+        <p:nvSpPr>
+          <p:cNvPr id="3" name="Notes Placeholder 2"/>
+          <p:cNvSpPr>
+            <a:spLocks noGrp="1"/>
+          </p:cNvSpPr>
+          <p:nvPr>
+            <p:ph type="body" idx="3" sz="quarter"/>
+          </p:nvPr>
+        </p:nvSpPr>
+        <p:spPr/>
+        <p:txBody>
+          <a:bodyPr/>
+          <a:lstStyle/>
+          <a:p>
+            <a:r>
               <a:t>Thank you for your attention. This effort is supported by Qollab and IonQ.</a:t>
             </a:r>
           </a:p>
@@ -724,7 +795,7 @@
           <a:lstStyle/>
           <a:p>
             <a:r>
-              <a:t>Each asset becomes one qubit: zero means buy, one means skip. Risk minus return becomes an Ising energy with one coupling per pair of assets: 66 couplings. For twelve assets we check every portfolio: the best is Apple plus long-term Treasury bonds.</a:t>
+              <a:t>Each asset is one qubit: zero means buy, one means skip. Risk minus return becomes an Ising energy with one coupling per pair. Checking every portfolio, the best is Apple plus Treasury bonds.</a:t>
             </a:r>
           </a:p>
         </p:txBody>
@@ -794,7 +865,7 @@
           <a:lstStyle/>
           <a:p>
             <a:r>
-              <a:t>The circuit is QAOA: Hadamard gates, a cost layer with one ZZ gate per pair, then a mixer. At twelve qubits the best is CVaR-QAOA, sent to IonQ as one job; at twenty-nine we use linear-ramp QAOA with angles from twelve.</a:t>
+              <a:t>The circuit is QAOA: Hadamards, a cost layer with one ZZ gate per pair, then a mixer. At twelve qubits the best is CVaR-QAOA; at twenty-nine, linear-ramp QAOA with angles from twelve.</a:t>
             </a:r>
           </a:p>
         </p:txBody>
@@ -934,7 +1005,7 @@
           <a:lstStyle/>
           <a:p>
             <a:r>
-              <a:t>Every pair of assets is coupled, and trapped ions link every pair of qubits directly. One layer needs 66 two-qubit gates; on a heavy-hex grid it needs 285: 4.3 times more, and 6.5 times at twenty-nine qubits.</a:t>
+              <a:t>Trapped ions link every pair of qubits directly. One layer needs 66 two-qubit gates; on a heavy-hex grid it needs 285: 4.3 times more, and 6.5 times at twenty-nine qubits.</a:t>
             </a:r>
           </a:p>
         </p:txBody>
@@ -1004,7 +1075,7 @@
           <a:lstStyle/>
           <a:p>
             <a:r>
-              <a:t>The main result, on the IonQ Forte 1 noise model: 7 of 1,000 shots were the exact best portfolio, 29 times more than random guessing. The noiseless simulation gives 58, so noise costs a factor of 8. Classical greedy search is in the same range.</a:t>
+              <a:t>On the IonQ Forte 1 noise model, 7 of 1,000 shots were the exact best portfolio, 29 times more than random guessing. The noiseless simulation gives 58, so noise costs a factor of 8. Greedy search is in the same range.</a:t>
             </a:r>
           </a:p>
         </p:txBody>
@@ -1074,7 +1145,7 @@
           <a:lstStyle/>
           <a:p>
             <a:r>
-              <a:t>At twenty-nine assets the three-layer circuit finds the best portfolio in 7 percent of runs, classical methods in 61. With more layers, the noiseless circuit reaches 90 percent at sixteen. But that is six and a half thousand two-qubit gates, far beyond today's noise. No advantage is claimed.</a:t>
+              <a:t>At twenty-nine assets the three-layer circuit finds the best portfolio in 7 percent of runs, classical methods in 61. With more layers, the noiseless circuit reaches 90 percent at sixteen. That needs six and a half thousand two-qubit gates, far beyond today's noise. No advantage is claimed.</a:t>
             </a:r>
           </a:p>
         </p:txBody>
@@ -1144,7 +1215,7 @@
           <a:lstStyle/>
           <a:p>
             <a:r>
-              <a:t>[CUT TO LIVE QOLLAB DEMO] Here is the project on Qollab, with the code in main.py. We press Run, select the IonQ Forte 1 noise model, and one job returns counts and plots. [BACK TO SLIDE] Our limits: a noisy simulator, one job, and strong classical baselines. Next: other circuits, shorter circuits, and the depth noise allows.</a:t>
+              <a:t>We also protected the circuit with the Iceberg error-detection code: twelve logical qubits on 17. Every state-preparation, check and readout fault is caught, and four in five gate faults. On Qollab's IonQ simulator every shot passed; the price is more gates.</a:t>
             </a:r>
           </a:p>
         </p:txBody>
@@ -4627,8 +4698,8 @@
         </p:nvSpPr>
         <p:spPr>
           <a:xfrm>
-            <a:off x="548640" y="1572768"/>
-            <a:ext cx="6309360" cy="1518920"/>
+            <a:off x="548640" y="731520"/>
+            <a:ext cx="11094415" cy="467360"/>
           </a:xfrm>
         </p:spPr>
         <p:txBody>
@@ -4639,162 +4710,48 @@
           <a:p>
             <a:pPr algn="l">
               <a:lnSpc>
-                <a:spcPts val="5980"/>
-              </a:lnSpc>
-              <a:spcBef>
-                <a:spcPts val="0"/>
-              </a:spcBef>
-              <a:spcAft>
-                <a:spcPts val="0"/>
-              </a:spcAft>
-            </a:pPr>
-            <a:r>
-              <a:rPr sz="5200" b="1">
+                <a:spcPts val="3679"/>
+              </a:lnSpc>
+              <a:spcBef>
+                <a:spcPts val="0"/>
+              </a:spcBef>
+              <a:spcAft>
+                <a:spcPts val="0"/>
+              </a:spcAft>
+            </a:pPr>
+            <a:r>
+              <a:rPr sz="3200" b="1">
                 <a:solidFill>
                   <a:srgbClr val="FFFFFF"/>
                 </a:solidFill>
                 <a:latin typeface="Arial"/>
               </a:rPr>
-              <a:t>Thank you for</a:t>
-            </a:r>
-          </a:p>
-          <a:p>
-            <a:pPr algn="l">
-              <a:lnSpc>
-                <a:spcPts val="5980"/>
-              </a:lnSpc>
-              <a:spcBef>
-                <a:spcPts val="0"/>
-              </a:spcBef>
-              <a:spcAft>
-                <a:spcPts val="0"/>
-              </a:spcAft>
-            </a:pPr>
-            <a:r>
-              <a:rPr sz="5200" b="1">
-                <a:solidFill>
-                  <a:srgbClr val="FFFFFF"/>
-                </a:solidFill>
-                <a:latin typeface="Arial"/>
-              </a:rPr>
-              <a:t>your attention</a:t>
-            </a:r>
-          </a:p>
-        </p:txBody>
-      </p:sp>
-      <p:sp>
-        <p:nvSpPr>
-          <p:cNvPr id="3" name="TextBox 2"/>
-          <p:cNvSpPr txBox="1"/>
-          <p:nvPr/>
-        </p:nvSpPr>
-        <p:spPr>
-          <a:xfrm>
-            <a:off x="548640" y="3611880"/>
-            <a:ext cx="6309360" cy="335280"/>
-          </a:xfrm>
-          <a:prstGeom prst="rect">
-            <a:avLst/>
-          </a:prstGeom>
-          <a:noFill/>
-        </p:spPr>
-        <p:txBody>
-          <a:bodyPr wrap="square" lIns="0" rIns="0" tIns="0" bIns="0" anchor="t">
-            <a:noAutofit/>
-          </a:bodyPr>
-          <a:lstStyle/>
-          <a:p>
-            <a:pPr algn="l">
-              <a:lnSpc>
-                <a:spcPts val="2640"/>
-              </a:lnSpc>
-              <a:spcBef>
-                <a:spcPts val="0"/>
-              </a:spcBef>
-              <a:spcAft>
-                <a:spcPts val="0"/>
-              </a:spcAft>
-            </a:pPr>
-            <a:r>
-              <a:rPr sz="2200" b="1">
-                <a:solidFill>
-                  <a:srgbClr val="FFFFFF"/>
-                </a:solidFill>
-                <a:latin typeface="Arial"/>
-              </a:rPr>
-              <a:t>Oussama Turki  ·  Tushar Pandey</a:t>
-            </a:r>
-          </a:p>
-        </p:txBody>
-      </p:sp>
-      <p:sp>
-        <p:nvSpPr>
-          <p:cNvPr id="4" name="TextBox 3"/>
-          <p:cNvSpPr txBox="1"/>
-          <p:nvPr/>
-        </p:nvSpPr>
-        <p:spPr>
-          <a:xfrm>
-            <a:off x="548640" y="4130040"/>
-            <a:ext cx="6309360" cy="304800"/>
-          </a:xfrm>
-          <a:prstGeom prst="rect">
-            <a:avLst/>
-          </a:prstGeom>
-          <a:noFill/>
-        </p:spPr>
-        <p:txBody>
-          <a:bodyPr wrap="square" lIns="0" rIns="0" tIns="0" bIns="0" anchor="t">
-            <a:noAutofit/>
-          </a:bodyPr>
-          <a:lstStyle/>
-          <a:p>
-            <a:pPr algn="l">
-              <a:lnSpc>
-                <a:spcPts val="2400"/>
-              </a:lnSpc>
-              <a:spcBef>
-                <a:spcPts val="0"/>
-              </a:spcBef>
-              <a:spcAft>
-                <a:spcPts val="0"/>
-              </a:spcAft>
-            </a:pPr>
-            <a:r>
-              <a:rPr sz="2000" b="0">
-                <a:solidFill>
-                  <a:srgbClr val="A9B4C6"/>
-                </a:solidFill>
-                <a:latin typeface="Arial"/>
-              </a:rPr>
-              <a:t>Portfolio Selection with QAOA</a:t>
-            </a:r>
-          </a:p>
-        </p:txBody>
-      </p:sp>
-      <p:sp>
-        <p:nvSpPr>
-          <p:cNvPr id="5" name="Rounded Rectangle 4"/>
+              <a:t>Try it on Qollab: one click runs it all</a:t>
+            </a:r>
+          </a:p>
+        </p:txBody>
+      </p:sp>
+      <p:sp>
+        <p:nvSpPr>
+          <p:cNvPr id="3" name="Rounded Rectangle 2"/>
           <p:cNvSpPr/>
           <p:nvPr/>
         </p:nvSpPr>
         <p:spPr>
           <a:xfrm>
-            <a:off x="548640" y="5257800"/>
-            <a:ext cx="5120640" cy="566928"/>
+            <a:off x="548640" y="1554480"/>
+            <a:ext cx="5120640" cy="3794760"/>
           </a:xfrm>
           <a:prstGeom prst="roundRect">
             <a:avLst>
-              <a:gd name="adj" fmla="val 50000"/>
+              <a:gd name="adj" fmla="val 2891"/>
             </a:avLst>
           </a:prstGeom>
           <a:solidFill>
             <a:srgbClr val="131B2E"/>
           </a:solidFill>
-          <a:ln w="15875">
-            <a:solidFill>
-              <a:srgbClr val="17A2B8"/>
-            </a:solidFill>
+          <a:ln>
+            <a:noFill/>
           </a:ln>
           <a:effectLst/>
         </p:spPr>
@@ -4822,6 +4779,1509 @@
       </p:sp>
       <p:sp>
         <p:nvSpPr>
+          <p:cNvPr id="4" name="TextBox 3"/>
+          <p:cNvSpPr txBox="1"/>
+          <p:nvPr/>
+        </p:nvSpPr>
+        <p:spPr>
+          <a:xfrm>
+            <a:off x="822960" y="1783080"/>
+            <a:ext cx="4572000" cy="365760"/>
+          </a:xfrm>
+          <a:prstGeom prst="rect">
+            <a:avLst/>
+          </a:prstGeom>
+          <a:noFill/>
+        </p:spPr>
+        <p:txBody>
+          <a:bodyPr wrap="square" lIns="0" rIns="0" tIns="0" bIns="0" anchor="t">
+            <a:noAutofit/>
+          </a:bodyPr>
+          <a:lstStyle/>
+          <a:p>
+            <a:pPr algn="l">
+              <a:lnSpc>
+                <a:spcPts val="2879"/>
+              </a:lnSpc>
+              <a:spcBef>
+                <a:spcPts val="0"/>
+              </a:spcBef>
+              <a:spcAft>
+                <a:spcPts val="0"/>
+              </a:spcAft>
+            </a:pPr>
+            <a:r>
+              <a:rPr sz="2400" b="1">
+                <a:solidFill>
+                  <a:srgbClr val="FFFFFF"/>
+                </a:solidFill>
+                <a:latin typeface="Arial"/>
+              </a:rPr>
+              <a:t>Live demo on Qollab</a:t>
+            </a:r>
+          </a:p>
+        </p:txBody>
+      </p:sp>
+      <p:sp>
+        <p:nvSpPr>
+          <p:cNvPr id="5" name="Oval 4"/>
+          <p:cNvSpPr/>
+          <p:nvPr/>
+        </p:nvSpPr>
+        <p:spPr>
+          <a:xfrm>
+            <a:off x="822960" y="2523744"/>
+            <a:ext cx="457200" cy="457200"/>
+          </a:xfrm>
+          <a:prstGeom prst="ellipse">
+            <a:avLst/>
+          </a:prstGeom>
+          <a:solidFill>
+            <a:srgbClr val="17A2B8"/>
+          </a:solidFill>
+          <a:ln>
+            <a:noFill/>
+          </a:ln>
+          <a:effectLst/>
+        </p:spPr>
+        <p:style>
+          <a:lnRef idx="1">
+            <a:schemeClr val="accent1"/>
+          </a:lnRef>
+          <a:fillRef idx="3">
+            <a:schemeClr val="accent1"/>
+          </a:fillRef>
+          <a:effectRef idx="2">
+            <a:schemeClr val="accent1"/>
+          </a:effectRef>
+          <a:fontRef idx="minor">
+            <a:schemeClr val="lt1"/>
+          </a:fontRef>
+        </p:style>
+        <p:txBody>
+          <a:bodyPr rtlCol="0" anchor="ctr"/>
+          <a:lstStyle/>
+          <a:p>
+            <a:pPr algn="ctr"/>
+          </a:p>
+        </p:txBody>
+      </p:sp>
+      <p:sp>
+        <p:nvSpPr>
+          <p:cNvPr id="6" name="TextBox 5"/>
+          <p:cNvSpPr txBox="1"/>
+          <p:nvPr/>
+        </p:nvSpPr>
+        <p:spPr>
+          <a:xfrm>
+            <a:off x="822960" y="2606040"/>
+            <a:ext cx="457200" cy="274320"/>
+          </a:xfrm>
+          <a:prstGeom prst="rect">
+            <a:avLst/>
+          </a:prstGeom>
+          <a:noFill/>
+        </p:spPr>
+        <p:txBody>
+          <a:bodyPr wrap="square" lIns="0" rIns="0" tIns="0" bIns="0" anchor="t">
+            <a:noAutofit/>
+          </a:bodyPr>
+          <a:lstStyle/>
+          <a:p>
+            <a:pPr algn="ctr">
+              <a:lnSpc>
+                <a:spcPts val="2160"/>
+              </a:lnSpc>
+              <a:spcBef>
+                <a:spcPts val="0"/>
+              </a:spcBef>
+              <a:spcAft>
+                <a:spcPts val="0"/>
+              </a:spcAft>
+            </a:pPr>
+            <a:r>
+              <a:rPr sz="1800" b="1">
+                <a:solidFill>
+                  <a:srgbClr val="FFFFFF"/>
+                </a:solidFill>
+                <a:latin typeface="Arial"/>
+              </a:rPr>
+              <a:t>1</a:t>
+            </a:r>
+          </a:p>
+        </p:txBody>
+      </p:sp>
+      <p:sp>
+        <p:nvSpPr>
+          <p:cNvPr id="7" name="TextBox 6"/>
+          <p:cNvSpPr txBox="1"/>
+          <p:nvPr/>
+        </p:nvSpPr>
+        <p:spPr>
+          <a:xfrm>
+            <a:off x="1508760" y="2441448"/>
+            <a:ext cx="4023360" cy="609600"/>
+          </a:xfrm>
+          <a:prstGeom prst="rect">
+            <a:avLst/>
+          </a:prstGeom>
+          <a:noFill/>
+        </p:spPr>
+        <p:txBody>
+          <a:bodyPr wrap="square" lIns="0" rIns="0" tIns="0" bIns="0" anchor="t">
+            <a:noAutofit/>
+          </a:bodyPr>
+          <a:lstStyle/>
+          <a:p>
+            <a:pPr algn="l">
+              <a:lnSpc>
+                <a:spcPts val="2400"/>
+              </a:lnSpc>
+              <a:spcBef>
+                <a:spcPts val="0"/>
+              </a:spcBef>
+              <a:spcAft>
+                <a:spcPts val="0"/>
+              </a:spcAft>
+            </a:pPr>
+            <a:r>
+              <a:rPr sz="2000" b="0">
+                <a:solidFill>
+                  <a:srgbClr val="FFFFFF"/>
+                </a:solidFill>
+                <a:latin typeface="Arial"/>
+              </a:rPr>
+              <a:t>Open the project:</a:t>
+            </a:r>
+          </a:p>
+          <a:p>
+            <a:pPr algn="l">
+              <a:lnSpc>
+                <a:spcPts val="2400"/>
+              </a:lnSpc>
+              <a:spcBef>
+                <a:spcPts val="0"/>
+              </a:spcBef>
+              <a:spcAft>
+                <a:spcPts val="0"/>
+              </a:spcAft>
+            </a:pPr>
+            <a:r>
+              <a:rPr sz="2000" b="0">
+                <a:solidFill>
+                  <a:srgbClr val="FFFFFF"/>
+                </a:solidFill>
+                <a:latin typeface="Arial"/>
+              </a:rPr>
+              <a:t>the code is in main.py</a:t>
+            </a:r>
+          </a:p>
+        </p:txBody>
+      </p:sp>
+      <p:sp>
+        <p:nvSpPr>
+          <p:cNvPr id="8" name="Oval 7"/>
+          <p:cNvSpPr/>
+          <p:nvPr/>
+        </p:nvSpPr>
+        <p:spPr>
+          <a:xfrm>
+            <a:off x="822960" y="3499104"/>
+            <a:ext cx="457200" cy="457200"/>
+          </a:xfrm>
+          <a:prstGeom prst="ellipse">
+            <a:avLst/>
+          </a:prstGeom>
+          <a:solidFill>
+            <a:srgbClr val="17A2B8"/>
+          </a:solidFill>
+          <a:ln>
+            <a:noFill/>
+          </a:ln>
+          <a:effectLst/>
+        </p:spPr>
+        <p:style>
+          <a:lnRef idx="1">
+            <a:schemeClr val="accent1"/>
+          </a:lnRef>
+          <a:fillRef idx="3">
+            <a:schemeClr val="accent1"/>
+          </a:fillRef>
+          <a:effectRef idx="2">
+            <a:schemeClr val="accent1"/>
+          </a:effectRef>
+          <a:fontRef idx="minor">
+            <a:schemeClr val="lt1"/>
+          </a:fontRef>
+        </p:style>
+        <p:txBody>
+          <a:bodyPr rtlCol="0" anchor="ctr"/>
+          <a:lstStyle/>
+          <a:p>
+            <a:pPr algn="ctr"/>
+          </a:p>
+        </p:txBody>
+      </p:sp>
+      <p:sp>
+        <p:nvSpPr>
+          <p:cNvPr id="9" name="TextBox 8"/>
+          <p:cNvSpPr txBox="1"/>
+          <p:nvPr/>
+        </p:nvSpPr>
+        <p:spPr>
+          <a:xfrm>
+            <a:off x="822960" y="3581400"/>
+            <a:ext cx="457200" cy="274320"/>
+          </a:xfrm>
+          <a:prstGeom prst="rect">
+            <a:avLst/>
+          </a:prstGeom>
+          <a:noFill/>
+        </p:spPr>
+        <p:txBody>
+          <a:bodyPr wrap="square" lIns="0" rIns="0" tIns="0" bIns="0" anchor="t">
+            <a:noAutofit/>
+          </a:bodyPr>
+          <a:lstStyle/>
+          <a:p>
+            <a:pPr algn="ctr">
+              <a:lnSpc>
+                <a:spcPts val="2160"/>
+              </a:lnSpc>
+              <a:spcBef>
+                <a:spcPts val="0"/>
+              </a:spcBef>
+              <a:spcAft>
+                <a:spcPts val="0"/>
+              </a:spcAft>
+            </a:pPr>
+            <a:r>
+              <a:rPr sz="1800" b="1">
+                <a:solidFill>
+                  <a:srgbClr val="FFFFFF"/>
+                </a:solidFill>
+                <a:latin typeface="Arial"/>
+              </a:rPr>
+              <a:t>2</a:t>
+            </a:r>
+          </a:p>
+        </p:txBody>
+      </p:sp>
+      <p:sp>
+        <p:nvSpPr>
+          <p:cNvPr id="10" name="TextBox 9"/>
+          <p:cNvSpPr txBox="1"/>
+          <p:nvPr/>
+        </p:nvSpPr>
+        <p:spPr>
+          <a:xfrm>
+            <a:off x="1508760" y="3416808"/>
+            <a:ext cx="4023360" cy="609600"/>
+          </a:xfrm>
+          <a:prstGeom prst="rect">
+            <a:avLst/>
+          </a:prstGeom>
+          <a:noFill/>
+        </p:spPr>
+        <p:txBody>
+          <a:bodyPr wrap="square" lIns="0" rIns="0" tIns="0" bIns="0" anchor="t">
+            <a:noAutofit/>
+          </a:bodyPr>
+          <a:lstStyle/>
+          <a:p>
+            <a:pPr algn="l">
+              <a:lnSpc>
+                <a:spcPts val="2400"/>
+              </a:lnSpc>
+              <a:spcBef>
+                <a:spcPts val="0"/>
+              </a:spcBef>
+              <a:spcAft>
+                <a:spcPts val="0"/>
+              </a:spcAft>
+            </a:pPr>
+            <a:r>
+              <a:rPr sz="2000" b="0">
+                <a:solidFill>
+                  <a:srgbClr val="FFFFFF"/>
+                </a:solidFill>
+                <a:latin typeface="Arial"/>
+              </a:rPr>
+              <a:t>Run → Select QPU →</a:t>
+            </a:r>
+          </a:p>
+          <a:p>
+            <a:pPr algn="l">
+              <a:lnSpc>
+                <a:spcPts val="2400"/>
+              </a:lnSpc>
+              <a:spcBef>
+                <a:spcPts val="0"/>
+              </a:spcBef>
+              <a:spcAft>
+                <a:spcPts val="0"/>
+              </a:spcAft>
+            </a:pPr>
+            <a:r>
+              <a:rPr sz="2000" b="0">
+                <a:solidFill>
+                  <a:srgbClr val="FFFFFF"/>
+                </a:solidFill>
+                <a:latin typeface="Arial"/>
+              </a:rPr>
+              <a:t>IonQ Forte 1 (29q) noise model</a:t>
+            </a:r>
+          </a:p>
+        </p:txBody>
+      </p:sp>
+      <p:sp>
+        <p:nvSpPr>
+          <p:cNvPr id="11" name="Oval 10"/>
+          <p:cNvSpPr/>
+          <p:nvPr/>
+        </p:nvSpPr>
+        <p:spPr>
+          <a:xfrm>
+            <a:off x="822960" y="4474464"/>
+            <a:ext cx="457200" cy="457200"/>
+          </a:xfrm>
+          <a:prstGeom prst="ellipse">
+            <a:avLst/>
+          </a:prstGeom>
+          <a:solidFill>
+            <a:srgbClr val="17A2B8"/>
+          </a:solidFill>
+          <a:ln>
+            <a:noFill/>
+          </a:ln>
+          <a:effectLst/>
+        </p:spPr>
+        <p:style>
+          <a:lnRef idx="1">
+            <a:schemeClr val="accent1"/>
+          </a:lnRef>
+          <a:fillRef idx="3">
+            <a:schemeClr val="accent1"/>
+          </a:fillRef>
+          <a:effectRef idx="2">
+            <a:schemeClr val="accent1"/>
+          </a:effectRef>
+          <a:fontRef idx="minor">
+            <a:schemeClr val="lt1"/>
+          </a:fontRef>
+        </p:style>
+        <p:txBody>
+          <a:bodyPr rtlCol="0" anchor="ctr"/>
+          <a:lstStyle/>
+          <a:p>
+            <a:pPr algn="ctr"/>
+          </a:p>
+        </p:txBody>
+      </p:sp>
+      <p:sp>
+        <p:nvSpPr>
+          <p:cNvPr id="12" name="TextBox 11"/>
+          <p:cNvSpPr txBox="1"/>
+          <p:nvPr/>
+        </p:nvSpPr>
+        <p:spPr>
+          <a:xfrm>
+            <a:off x="822960" y="4556760"/>
+            <a:ext cx="457200" cy="274320"/>
+          </a:xfrm>
+          <a:prstGeom prst="rect">
+            <a:avLst/>
+          </a:prstGeom>
+          <a:noFill/>
+        </p:spPr>
+        <p:txBody>
+          <a:bodyPr wrap="square" lIns="0" rIns="0" tIns="0" bIns="0" anchor="t">
+            <a:noAutofit/>
+          </a:bodyPr>
+          <a:lstStyle/>
+          <a:p>
+            <a:pPr algn="ctr">
+              <a:lnSpc>
+                <a:spcPts val="2160"/>
+              </a:lnSpc>
+              <a:spcBef>
+                <a:spcPts val="0"/>
+              </a:spcBef>
+              <a:spcAft>
+                <a:spcPts val="0"/>
+              </a:spcAft>
+            </a:pPr>
+            <a:r>
+              <a:rPr sz="1800" b="1">
+                <a:solidFill>
+                  <a:srgbClr val="FFFFFF"/>
+                </a:solidFill>
+                <a:latin typeface="Arial"/>
+              </a:rPr>
+              <a:t>3</a:t>
+            </a:r>
+          </a:p>
+        </p:txBody>
+      </p:sp>
+      <p:sp>
+        <p:nvSpPr>
+          <p:cNvPr id="13" name="TextBox 12"/>
+          <p:cNvSpPr txBox="1"/>
+          <p:nvPr/>
+        </p:nvSpPr>
+        <p:spPr>
+          <a:xfrm>
+            <a:off x="1508760" y="4392168"/>
+            <a:ext cx="4023360" cy="609600"/>
+          </a:xfrm>
+          <a:prstGeom prst="rect">
+            <a:avLst/>
+          </a:prstGeom>
+          <a:noFill/>
+        </p:spPr>
+        <p:txBody>
+          <a:bodyPr wrap="square" lIns="0" rIns="0" tIns="0" bIns="0" anchor="t">
+            <a:noAutofit/>
+          </a:bodyPr>
+          <a:lstStyle/>
+          <a:p>
+            <a:pPr algn="l">
+              <a:lnSpc>
+                <a:spcPts val="2400"/>
+              </a:lnSpc>
+              <a:spcBef>
+                <a:spcPts val="0"/>
+              </a:spcBef>
+              <a:spcAft>
+                <a:spcPts val="0"/>
+              </a:spcAft>
+            </a:pPr>
+            <a:r>
+              <a:rPr sz="2000" b="0">
+                <a:solidFill>
+                  <a:srgbClr val="FFFFFF"/>
+                </a:solidFill>
+                <a:latin typeface="Arial"/>
+              </a:rPr>
+              <a:t>Each job returns counts,</a:t>
+            </a:r>
+          </a:p>
+          <a:p>
+            <a:pPr algn="l">
+              <a:lnSpc>
+                <a:spcPts val="2400"/>
+              </a:lnSpc>
+              <a:spcBef>
+                <a:spcPts val="0"/>
+              </a:spcBef>
+              <a:spcAft>
+                <a:spcPts val="0"/>
+              </a:spcAft>
+            </a:pPr>
+            <a:r>
+              <a:rPr sz="2000" b="0">
+                <a:solidFill>
+                  <a:srgbClr val="FFFFFF"/>
+                </a:solidFill>
+                <a:latin typeface="Arial"/>
+              </a:rPr>
+              <a:t>a table and plots</a:t>
+            </a:r>
+          </a:p>
+        </p:txBody>
+      </p:sp>
+      <p:sp>
+        <p:nvSpPr>
+          <p:cNvPr id="14" name="TextBox 13"/>
+          <p:cNvSpPr txBox="1"/>
+          <p:nvPr/>
+        </p:nvSpPr>
+        <p:spPr>
+          <a:xfrm>
+            <a:off x="6172200" y="1554480"/>
+            <a:ext cx="5468112" cy="335280"/>
+          </a:xfrm>
+          <a:prstGeom prst="rect">
+            <a:avLst/>
+          </a:prstGeom>
+          <a:noFill/>
+        </p:spPr>
+        <p:txBody>
+          <a:bodyPr wrap="square" lIns="0" rIns="0" tIns="0" bIns="0" anchor="t">
+            <a:noAutofit/>
+          </a:bodyPr>
+          <a:lstStyle/>
+          <a:p>
+            <a:pPr algn="l">
+              <a:lnSpc>
+                <a:spcPts val="2640"/>
+              </a:lnSpc>
+              <a:spcBef>
+                <a:spcPts val="0"/>
+              </a:spcBef>
+              <a:spcAft>
+                <a:spcPts val="0"/>
+              </a:spcAft>
+            </a:pPr>
+            <a:r>
+              <a:rPr sz="2200" b="1">
+                <a:solidFill>
+                  <a:srgbClr val="FFFFFF"/>
+                </a:solidFill>
+                <a:latin typeface="Arial"/>
+              </a:rPr>
+              <a:t>Honest limits</a:t>
+            </a:r>
+          </a:p>
+        </p:txBody>
+      </p:sp>
+      <p:sp>
+        <p:nvSpPr>
+          <p:cNvPr id="15" name="Oval 14"/>
+          <p:cNvSpPr/>
+          <p:nvPr/>
+        </p:nvSpPr>
+        <p:spPr>
+          <a:xfrm>
+            <a:off x="6172200" y="2122932"/>
+            <a:ext cx="100584" cy="100584"/>
+          </a:xfrm>
+          <a:prstGeom prst="ellipse">
+            <a:avLst/>
+          </a:prstGeom>
+          <a:solidFill>
+            <a:srgbClr val="17A2B8"/>
+          </a:solidFill>
+          <a:ln>
+            <a:noFill/>
+          </a:ln>
+          <a:effectLst/>
+        </p:spPr>
+        <p:style>
+          <a:lnRef idx="1">
+            <a:schemeClr val="accent1"/>
+          </a:lnRef>
+          <a:fillRef idx="3">
+            <a:schemeClr val="accent1"/>
+          </a:fillRef>
+          <a:effectRef idx="2">
+            <a:schemeClr val="accent1"/>
+          </a:effectRef>
+          <a:fontRef idx="minor">
+            <a:schemeClr val="lt1"/>
+          </a:fontRef>
+        </p:style>
+        <p:txBody>
+          <a:bodyPr rtlCol="0" anchor="ctr"/>
+          <a:lstStyle/>
+          <a:p>
+            <a:pPr algn="ctr"/>
+          </a:p>
+        </p:txBody>
+      </p:sp>
+      <p:sp>
+        <p:nvSpPr>
+          <p:cNvPr id="16" name="TextBox 15"/>
+          <p:cNvSpPr txBox="1"/>
+          <p:nvPr/>
+        </p:nvSpPr>
+        <p:spPr>
+          <a:xfrm>
+            <a:off x="6446520" y="2036064"/>
+            <a:ext cx="5193792" cy="274320"/>
+          </a:xfrm>
+          <a:prstGeom prst="rect">
+            <a:avLst/>
+          </a:prstGeom>
+          <a:noFill/>
+        </p:spPr>
+        <p:txBody>
+          <a:bodyPr wrap="square" lIns="0" rIns="0" tIns="0" bIns="0" anchor="t">
+            <a:noAutofit/>
+          </a:bodyPr>
+          <a:lstStyle/>
+          <a:p>
+            <a:pPr algn="l">
+              <a:lnSpc>
+                <a:spcPts val="2160"/>
+              </a:lnSpc>
+              <a:spcBef>
+                <a:spcPts val="0"/>
+              </a:spcBef>
+              <a:spcAft>
+                <a:spcPts val="0"/>
+              </a:spcAft>
+            </a:pPr>
+            <a:r>
+              <a:rPr sz="1800" b="0">
+                <a:solidFill>
+                  <a:srgbClr val="FFFFFF"/>
+                </a:solidFill>
+                <a:latin typeface="Arial"/>
+              </a:rPr>
+              <a:t>A noisy simulator: one job of 1,000 shots</a:t>
+            </a:r>
+          </a:p>
+        </p:txBody>
+      </p:sp>
+      <p:sp>
+        <p:nvSpPr>
+          <p:cNvPr id="17" name="Oval 16"/>
+          <p:cNvSpPr/>
+          <p:nvPr/>
+        </p:nvSpPr>
+        <p:spPr>
+          <a:xfrm>
+            <a:off x="6172200" y="2525268"/>
+            <a:ext cx="100584" cy="100584"/>
+          </a:xfrm>
+          <a:prstGeom prst="ellipse">
+            <a:avLst/>
+          </a:prstGeom>
+          <a:solidFill>
+            <a:srgbClr val="17A2B8"/>
+          </a:solidFill>
+          <a:ln>
+            <a:noFill/>
+          </a:ln>
+          <a:effectLst/>
+        </p:spPr>
+        <p:style>
+          <a:lnRef idx="1">
+            <a:schemeClr val="accent1"/>
+          </a:lnRef>
+          <a:fillRef idx="3">
+            <a:schemeClr val="accent1"/>
+          </a:fillRef>
+          <a:effectRef idx="2">
+            <a:schemeClr val="accent1"/>
+          </a:effectRef>
+          <a:fontRef idx="minor">
+            <a:schemeClr val="lt1"/>
+          </a:fontRef>
+        </p:style>
+        <p:txBody>
+          <a:bodyPr rtlCol="0" anchor="ctr"/>
+          <a:lstStyle/>
+          <a:p>
+            <a:pPr algn="ctr"/>
+          </a:p>
+        </p:txBody>
+      </p:sp>
+      <p:sp>
+        <p:nvSpPr>
+          <p:cNvPr id="18" name="TextBox 17"/>
+          <p:cNvSpPr txBox="1"/>
+          <p:nvPr/>
+        </p:nvSpPr>
+        <p:spPr>
+          <a:xfrm>
+            <a:off x="6446520" y="2438400"/>
+            <a:ext cx="5193792" cy="274320"/>
+          </a:xfrm>
+          <a:prstGeom prst="rect">
+            <a:avLst/>
+          </a:prstGeom>
+          <a:noFill/>
+        </p:spPr>
+        <p:txBody>
+          <a:bodyPr wrap="square" lIns="0" rIns="0" tIns="0" bIns="0" anchor="t">
+            <a:noAutofit/>
+          </a:bodyPr>
+          <a:lstStyle/>
+          <a:p>
+            <a:pPr algn="l">
+              <a:lnSpc>
+                <a:spcPts val="2160"/>
+              </a:lnSpc>
+              <a:spcBef>
+                <a:spcPts val="0"/>
+              </a:spcBef>
+              <a:spcAft>
+                <a:spcPts val="0"/>
+              </a:spcAft>
+            </a:pPr>
+            <a:r>
+              <a:rPr sz="1800" b="0">
+                <a:solidFill>
+                  <a:srgbClr val="FFFFFF"/>
+                </a:solidFill>
+                <a:latin typeface="Arial"/>
+              </a:rPr>
+              <a:t>Noise cuts the hits from 58 to 7 per 1,000</a:t>
+            </a:r>
+          </a:p>
+        </p:txBody>
+      </p:sp>
+      <p:sp>
+        <p:nvSpPr>
+          <p:cNvPr id="19" name="Oval 18"/>
+          <p:cNvSpPr/>
+          <p:nvPr/>
+        </p:nvSpPr>
+        <p:spPr>
+          <a:xfrm>
+            <a:off x="6172200" y="2927604"/>
+            <a:ext cx="100584" cy="100584"/>
+          </a:xfrm>
+          <a:prstGeom prst="ellipse">
+            <a:avLst/>
+          </a:prstGeom>
+          <a:solidFill>
+            <a:srgbClr val="17A2B8"/>
+          </a:solidFill>
+          <a:ln>
+            <a:noFill/>
+          </a:ln>
+          <a:effectLst/>
+        </p:spPr>
+        <p:style>
+          <a:lnRef idx="1">
+            <a:schemeClr val="accent1"/>
+          </a:lnRef>
+          <a:fillRef idx="3">
+            <a:schemeClr val="accent1"/>
+          </a:fillRef>
+          <a:effectRef idx="2">
+            <a:schemeClr val="accent1"/>
+          </a:effectRef>
+          <a:fontRef idx="minor">
+            <a:schemeClr val="lt1"/>
+          </a:fontRef>
+        </p:style>
+        <p:txBody>
+          <a:bodyPr rtlCol="0" anchor="ctr"/>
+          <a:lstStyle/>
+          <a:p>
+            <a:pPr algn="ctr"/>
+          </a:p>
+        </p:txBody>
+      </p:sp>
+      <p:sp>
+        <p:nvSpPr>
+          <p:cNvPr id="20" name="TextBox 19"/>
+          <p:cNvSpPr txBox="1"/>
+          <p:nvPr/>
+        </p:nvSpPr>
+        <p:spPr>
+          <a:xfrm>
+            <a:off x="6446520" y="2840736"/>
+            <a:ext cx="5193792" cy="274320"/>
+          </a:xfrm>
+          <a:prstGeom prst="rect">
+            <a:avLst/>
+          </a:prstGeom>
+          <a:noFill/>
+        </p:spPr>
+        <p:txBody>
+          <a:bodyPr wrap="square" lIns="0" rIns="0" tIns="0" bIns="0" anchor="t">
+            <a:noAutofit/>
+          </a:bodyPr>
+          <a:lstStyle/>
+          <a:p>
+            <a:pPr algn="l">
+              <a:lnSpc>
+                <a:spcPts val="2160"/>
+              </a:lnSpc>
+              <a:spcBef>
+                <a:spcPts val="0"/>
+              </a:spcBef>
+              <a:spcAft>
+                <a:spcPts val="0"/>
+              </a:spcAft>
+            </a:pPr>
+            <a:r>
+              <a:rPr sz="1800" b="0">
+                <a:solidFill>
+                  <a:srgbClr val="FFFFFF"/>
+                </a:solidFill>
+                <a:latin typeface="Arial"/>
+              </a:rPr>
+              <a:t>Classical heuristics match or beat it</a:t>
+            </a:r>
+          </a:p>
+        </p:txBody>
+      </p:sp>
+      <p:sp>
+        <p:nvSpPr>
+          <p:cNvPr id="21" name="TextBox 20"/>
+          <p:cNvSpPr txBox="1"/>
+          <p:nvPr/>
+        </p:nvSpPr>
+        <p:spPr>
+          <a:xfrm>
+            <a:off x="6172200" y="3499104"/>
+            <a:ext cx="5468112" cy="335280"/>
+          </a:xfrm>
+          <a:prstGeom prst="rect">
+            <a:avLst/>
+          </a:prstGeom>
+          <a:noFill/>
+        </p:spPr>
+        <p:txBody>
+          <a:bodyPr wrap="square" lIns="0" rIns="0" tIns="0" bIns="0" anchor="t">
+            <a:noAutofit/>
+          </a:bodyPr>
+          <a:lstStyle/>
+          <a:p>
+            <a:pPr algn="l">
+              <a:lnSpc>
+                <a:spcPts val="2640"/>
+              </a:lnSpc>
+              <a:spcBef>
+                <a:spcPts val="0"/>
+              </a:spcBef>
+              <a:spcAft>
+                <a:spcPts val="0"/>
+              </a:spcAft>
+            </a:pPr>
+            <a:r>
+              <a:rPr sz="2200" b="1">
+                <a:solidFill>
+                  <a:srgbClr val="FFFFFF"/>
+                </a:solidFill>
+                <a:latin typeface="Arial"/>
+              </a:rPr>
+              <a:t>Next steps</a:t>
+            </a:r>
+          </a:p>
+        </p:txBody>
+      </p:sp>
+      <p:sp>
+        <p:nvSpPr>
+          <p:cNvPr id="22" name="Oval 21"/>
+          <p:cNvSpPr/>
+          <p:nvPr/>
+        </p:nvSpPr>
+        <p:spPr>
+          <a:xfrm>
+            <a:off x="6172200" y="4067556"/>
+            <a:ext cx="100584" cy="100584"/>
+          </a:xfrm>
+          <a:prstGeom prst="ellipse">
+            <a:avLst/>
+          </a:prstGeom>
+          <a:solidFill>
+            <a:srgbClr val="17A2B8"/>
+          </a:solidFill>
+          <a:ln>
+            <a:noFill/>
+          </a:ln>
+          <a:effectLst/>
+        </p:spPr>
+        <p:style>
+          <a:lnRef idx="1">
+            <a:schemeClr val="accent1"/>
+          </a:lnRef>
+          <a:fillRef idx="3">
+            <a:schemeClr val="accent1"/>
+          </a:fillRef>
+          <a:effectRef idx="2">
+            <a:schemeClr val="accent1"/>
+          </a:effectRef>
+          <a:fontRef idx="minor">
+            <a:schemeClr val="lt1"/>
+          </a:fontRef>
+        </p:style>
+        <p:txBody>
+          <a:bodyPr rtlCol="0" anchor="ctr"/>
+          <a:lstStyle/>
+          <a:p>
+            <a:pPr algn="ctr"/>
+          </a:p>
+        </p:txBody>
+      </p:sp>
+      <p:sp>
+        <p:nvSpPr>
+          <p:cNvPr id="23" name="TextBox 22"/>
+          <p:cNvSpPr txBox="1"/>
+          <p:nvPr/>
+        </p:nvSpPr>
+        <p:spPr>
+          <a:xfrm>
+            <a:off x="6446520" y="3980688"/>
+            <a:ext cx="5193792" cy="274320"/>
+          </a:xfrm>
+          <a:prstGeom prst="rect">
+            <a:avLst/>
+          </a:prstGeom>
+          <a:noFill/>
+        </p:spPr>
+        <p:txBody>
+          <a:bodyPr wrap="square" lIns="0" rIns="0" tIns="0" bIns="0" anchor="t">
+            <a:noAutofit/>
+          </a:bodyPr>
+          <a:lstStyle/>
+          <a:p>
+            <a:pPr algn="l">
+              <a:lnSpc>
+                <a:spcPts val="2160"/>
+              </a:lnSpc>
+              <a:spcBef>
+                <a:spcPts val="0"/>
+              </a:spcBef>
+              <a:spcAft>
+                <a:spcPts val="0"/>
+              </a:spcAft>
+            </a:pPr>
+            <a:r>
+              <a:rPr sz="1800" b="0">
+                <a:solidFill>
+                  <a:srgbClr val="FFFFFF"/>
+                </a:solidFill>
+                <a:latin typeface="Arial"/>
+              </a:rPr>
+              <a:t>Iceberg on the Forte 1 noise model</a:t>
+            </a:r>
+          </a:p>
+        </p:txBody>
+      </p:sp>
+      <p:sp>
+        <p:nvSpPr>
+          <p:cNvPr id="24" name="Oval 23"/>
+          <p:cNvSpPr/>
+          <p:nvPr/>
+        </p:nvSpPr>
+        <p:spPr>
+          <a:xfrm>
+            <a:off x="6172200" y="4469892"/>
+            <a:ext cx="100584" cy="100584"/>
+          </a:xfrm>
+          <a:prstGeom prst="ellipse">
+            <a:avLst/>
+          </a:prstGeom>
+          <a:solidFill>
+            <a:srgbClr val="17A2B8"/>
+          </a:solidFill>
+          <a:ln>
+            <a:noFill/>
+          </a:ln>
+          <a:effectLst/>
+        </p:spPr>
+        <p:style>
+          <a:lnRef idx="1">
+            <a:schemeClr val="accent1"/>
+          </a:lnRef>
+          <a:fillRef idx="3">
+            <a:schemeClr val="accent1"/>
+          </a:fillRef>
+          <a:effectRef idx="2">
+            <a:schemeClr val="accent1"/>
+          </a:effectRef>
+          <a:fontRef idx="minor">
+            <a:schemeClr val="lt1"/>
+          </a:fontRef>
+        </p:style>
+        <p:txBody>
+          <a:bodyPr rtlCol="0" anchor="ctr"/>
+          <a:lstStyle/>
+          <a:p>
+            <a:pPr algn="ctr"/>
+          </a:p>
+        </p:txBody>
+      </p:sp>
+      <p:sp>
+        <p:nvSpPr>
+          <p:cNvPr id="25" name="TextBox 24"/>
+          <p:cNvSpPr txBox="1"/>
+          <p:nvPr/>
+        </p:nvSpPr>
+        <p:spPr>
+          <a:xfrm>
+            <a:off x="6446520" y="4383024"/>
+            <a:ext cx="5193792" cy="274320"/>
+          </a:xfrm>
+          <a:prstGeom prst="rect">
+            <a:avLst/>
+          </a:prstGeom>
+          <a:noFill/>
+        </p:spPr>
+        <p:txBody>
+          <a:bodyPr wrap="square" lIns="0" rIns="0" tIns="0" bIns="0" anchor="t">
+            <a:noAutofit/>
+          </a:bodyPr>
+          <a:lstStyle/>
+          <a:p>
+            <a:pPr algn="l">
+              <a:lnSpc>
+                <a:spcPts val="2160"/>
+              </a:lnSpc>
+              <a:spcBef>
+                <a:spcPts val="0"/>
+              </a:spcBef>
+              <a:spcAft>
+                <a:spcPts val="0"/>
+              </a:spcAft>
+            </a:pPr>
+            <a:r>
+              <a:rPr sz="1800" b="0">
+                <a:solidFill>
+                  <a:srgbClr val="FFFFFF"/>
+                </a:solidFill>
+                <a:latin typeface="Arial"/>
+              </a:rPr>
+              <a:t>Shorter circuits: 66 instead of 198 gates</a:t>
+            </a:r>
+          </a:p>
+        </p:txBody>
+      </p:sp>
+      <p:sp>
+        <p:nvSpPr>
+          <p:cNvPr id="26" name="Oval 25"/>
+          <p:cNvSpPr/>
+          <p:nvPr/>
+        </p:nvSpPr>
+        <p:spPr>
+          <a:xfrm>
+            <a:off x="6172200" y="4872228"/>
+            <a:ext cx="100584" cy="100584"/>
+          </a:xfrm>
+          <a:prstGeom prst="ellipse">
+            <a:avLst/>
+          </a:prstGeom>
+          <a:solidFill>
+            <a:srgbClr val="17A2B8"/>
+          </a:solidFill>
+          <a:ln>
+            <a:noFill/>
+          </a:ln>
+          <a:effectLst/>
+        </p:spPr>
+        <p:style>
+          <a:lnRef idx="1">
+            <a:schemeClr val="accent1"/>
+          </a:lnRef>
+          <a:fillRef idx="3">
+            <a:schemeClr val="accent1"/>
+          </a:fillRef>
+          <a:effectRef idx="2">
+            <a:schemeClr val="accent1"/>
+          </a:effectRef>
+          <a:fontRef idx="minor">
+            <a:schemeClr val="lt1"/>
+          </a:fontRef>
+        </p:style>
+        <p:txBody>
+          <a:bodyPr rtlCol="0" anchor="ctr"/>
+          <a:lstStyle/>
+          <a:p>
+            <a:pPr algn="ctr"/>
+          </a:p>
+        </p:txBody>
+      </p:sp>
+      <p:sp>
+        <p:nvSpPr>
+          <p:cNvPr id="27" name="TextBox 26"/>
+          <p:cNvSpPr txBox="1"/>
+          <p:nvPr/>
+        </p:nvSpPr>
+        <p:spPr>
+          <a:xfrm>
+            <a:off x="6446520" y="4785360"/>
+            <a:ext cx="5193792" cy="274320"/>
+          </a:xfrm>
+          <a:prstGeom prst="rect">
+            <a:avLst/>
+          </a:prstGeom>
+          <a:noFill/>
+        </p:spPr>
+        <p:txBody>
+          <a:bodyPr wrap="square" lIns="0" rIns="0" tIns="0" bIns="0" anchor="t">
+            <a:noAutofit/>
+          </a:bodyPr>
+          <a:lstStyle/>
+          <a:p>
+            <a:pPr algn="l">
+              <a:lnSpc>
+                <a:spcPts val="2160"/>
+              </a:lnSpc>
+              <a:spcBef>
+                <a:spcPts val="0"/>
+              </a:spcBef>
+              <a:spcAft>
+                <a:spcPts val="0"/>
+              </a:spcAft>
+            </a:pPr>
+            <a:r>
+              <a:rPr sz="1800" b="0">
+                <a:solidFill>
+                  <a:srgbClr val="FFFFFF"/>
+                </a:solidFill>
+                <a:latin typeface="Arial"/>
+              </a:rPr>
+              <a:t>Find how many layers the noise allows</a:t>
+            </a:r>
+          </a:p>
+        </p:txBody>
+      </p:sp>
+      <p:sp>
+        <p:nvSpPr>
+          <p:cNvPr id="28" name="TextBox 27"/>
+          <p:cNvSpPr txBox="1"/>
+          <p:nvPr/>
+        </p:nvSpPr>
+        <p:spPr>
+          <a:xfrm>
+            <a:off x="548640" y="384048"/>
+            <a:ext cx="11094415" cy="274320"/>
+          </a:xfrm>
+          <a:prstGeom prst="rect">
+            <a:avLst/>
+          </a:prstGeom>
+          <a:noFill/>
+        </p:spPr>
+        <p:txBody>
+          <a:bodyPr wrap="square" lIns="0" rIns="0" tIns="0" bIns="0" anchor="t">
+            <a:noAutofit/>
+          </a:bodyPr>
+          <a:lstStyle/>
+          <a:p>
+            <a:pPr algn="l">
+              <a:lnSpc>
+                <a:spcPts val="2160"/>
+              </a:lnSpc>
+              <a:spcBef>
+                <a:spcPts val="0"/>
+              </a:spcBef>
+              <a:spcAft>
+                <a:spcPts val="0"/>
+              </a:spcAft>
+            </a:pPr>
+            <a:r>
+              <a:rPr sz="1800" b="1">
+                <a:solidFill>
+                  <a:srgbClr val="17A2B8"/>
+                </a:solidFill>
+                <a:latin typeface="Arial"/>
+              </a:rPr>
+              <a:t>DEMO, LIMITS, NEXT STEPS</a:t>
+            </a:r>
+          </a:p>
+        </p:txBody>
+      </p:sp>
+      <p:sp>
+        <p:nvSpPr>
+          <p:cNvPr id="29" name="TextBox 28"/>
+          <p:cNvSpPr txBox="1"/>
+          <p:nvPr/>
+        </p:nvSpPr>
+        <p:spPr>
+          <a:xfrm>
+            <a:off x="548640" y="6327648"/>
+            <a:ext cx="7315200" cy="274320"/>
+          </a:xfrm>
+          <a:prstGeom prst="rect">
+            <a:avLst/>
+          </a:prstGeom>
+          <a:noFill/>
+        </p:spPr>
+        <p:txBody>
+          <a:bodyPr wrap="square" lIns="0" rIns="0" tIns="0" bIns="0" anchor="t">
+            <a:noAutofit/>
+          </a:bodyPr>
+          <a:lstStyle/>
+          <a:p>
+            <a:pPr algn="l">
+              <a:lnSpc>
+                <a:spcPts val="2160"/>
+              </a:lnSpc>
+              <a:spcBef>
+                <a:spcPts val="0"/>
+              </a:spcBef>
+              <a:spcAft>
+                <a:spcPts val="0"/>
+              </a:spcAft>
+            </a:pPr>
+            <a:r>
+              <a:rPr sz="1800" b="0">
+                <a:solidFill>
+                  <a:srgbClr val="A9B4C6"/>
+                </a:solidFill>
+                <a:latin typeface="Arial"/>
+              </a:rPr>
+              <a:t>ZollerQu - Qollab x IonQ Hackathon 2026</a:t>
+            </a:r>
+          </a:p>
+        </p:txBody>
+      </p:sp>
+      <p:sp>
+        <p:nvSpPr>
+          <p:cNvPr id="30" name="TextBox 29"/>
+          <p:cNvSpPr txBox="1"/>
+          <p:nvPr/>
+        </p:nvSpPr>
+        <p:spPr>
+          <a:xfrm>
+            <a:off x="10271455" y="6327648"/>
+            <a:ext cx="1371600" cy="274320"/>
+          </a:xfrm>
+          <a:prstGeom prst="rect">
+            <a:avLst/>
+          </a:prstGeom>
+          <a:noFill/>
+        </p:spPr>
+        <p:txBody>
+          <a:bodyPr wrap="square" lIns="0" rIns="0" tIns="0" bIns="0" anchor="t">
+            <a:noAutofit/>
+          </a:bodyPr>
+          <a:lstStyle/>
+          <a:p>
+            <a:pPr algn="r">
+              <a:lnSpc>
+                <a:spcPts val="2160"/>
+              </a:lnSpc>
+              <a:spcBef>
+                <a:spcPts val="0"/>
+              </a:spcBef>
+              <a:spcAft>
+                <a:spcPts val="0"/>
+              </a:spcAft>
+            </a:pPr>
+            <a:r>
+              <a:rPr sz="1800" b="0">
+                <a:solidFill>
+                  <a:srgbClr val="A9B4C6"/>
+                </a:solidFill>
+                <a:latin typeface="Arial"/>
+              </a:rPr>
+              <a:t>10</a:t>
+            </a:r>
+          </a:p>
+        </p:txBody>
+      </p:sp>
+    </p:spTree>
+  </p:cSld>
+  <p:clrMapOvr>
+    <a:masterClrMapping/>
+  </p:clrMapOvr>
+</p:sld>
+</file>
+
+<file path=ppt/slides/slide11.xml><?xml version="1.0" encoding="utf-8"?>
+<p:sld xmlns:a="http://schemas.openxmlformats.org/drawingml/2006/main" xmlns:p="http://schemas.openxmlformats.org/presentationml/2006/main" xmlns:r="http://schemas.openxmlformats.org/officeDocument/2006/relationships">
+  <p:cSld>
+    <p:bg>
+      <p:bgPr>
+        <a:solidFill>
+          <a:srgbClr val="0A1020"/>
+        </a:solidFill>
+        <a:effectLst/>
+      </p:bgPr>
+    </p:bg>
+    <p:spTree>
+      <p:nvGrpSpPr>
+        <p:cNvPr id="1" name=""/>
+        <p:cNvGrpSpPr/>
+        <p:nvPr/>
+      </p:nvGrpSpPr>
+      <p:grpSpPr/>
+      <p:sp>
+        <p:nvSpPr>
+          <p:cNvPr id="2" name="Title 1"/>
+          <p:cNvSpPr>
+            <a:spLocks noGrp="1"/>
+          </p:cNvSpPr>
+          <p:nvPr>
+            <p:ph type="title"/>
+          </p:nvPr>
+        </p:nvSpPr>
+        <p:spPr>
+          <a:xfrm>
+            <a:off x="548640" y="1572768"/>
+            <a:ext cx="6309360" cy="1518920"/>
+          </a:xfrm>
+        </p:spPr>
+        <p:txBody>
+          <a:bodyPr lIns="0" rIns="0" tIns="0" bIns="0" wrap="square" anchor="t">
+            <a:noAutofit/>
+          </a:bodyPr>
+          <a:lstStyle/>
+          <a:p>
+            <a:pPr algn="l">
+              <a:lnSpc>
+                <a:spcPts val="5980"/>
+              </a:lnSpc>
+              <a:spcBef>
+                <a:spcPts val="0"/>
+              </a:spcBef>
+              <a:spcAft>
+                <a:spcPts val="0"/>
+              </a:spcAft>
+            </a:pPr>
+            <a:r>
+              <a:rPr sz="5200" b="1">
+                <a:solidFill>
+                  <a:srgbClr val="FFFFFF"/>
+                </a:solidFill>
+                <a:latin typeface="Arial"/>
+              </a:rPr>
+              <a:t>Thank you for</a:t>
+            </a:r>
+          </a:p>
+          <a:p>
+            <a:pPr algn="l">
+              <a:lnSpc>
+                <a:spcPts val="5980"/>
+              </a:lnSpc>
+              <a:spcBef>
+                <a:spcPts val="0"/>
+              </a:spcBef>
+              <a:spcAft>
+                <a:spcPts val="0"/>
+              </a:spcAft>
+            </a:pPr>
+            <a:r>
+              <a:rPr sz="5200" b="1">
+                <a:solidFill>
+                  <a:srgbClr val="FFFFFF"/>
+                </a:solidFill>
+                <a:latin typeface="Arial"/>
+              </a:rPr>
+              <a:t>your attention</a:t>
+            </a:r>
+          </a:p>
+        </p:txBody>
+      </p:sp>
+      <p:sp>
+        <p:nvSpPr>
+          <p:cNvPr id="3" name="TextBox 2"/>
+          <p:cNvSpPr txBox="1"/>
+          <p:nvPr/>
+        </p:nvSpPr>
+        <p:spPr>
+          <a:xfrm>
+            <a:off x="548640" y="3611880"/>
+            <a:ext cx="6309360" cy="335280"/>
+          </a:xfrm>
+          <a:prstGeom prst="rect">
+            <a:avLst/>
+          </a:prstGeom>
+          <a:noFill/>
+        </p:spPr>
+        <p:txBody>
+          <a:bodyPr wrap="square" lIns="0" rIns="0" tIns="0" bIns="0" anchor="t">
+            <a:noAutofit/>
+          </a:bodyPr>
+          <a:lstStyle/>
+          <a:p>
+            <a:pPr algn="l">
+              <a:lnSpc>
+                <a:spcPts val="2640"/>
+              </a:lnSpc>
+              <a:spcBef>
+                <a:spcPts val="0"/>
+              </a:spcBef>
+              <a:spcAft>
+                <a:spcPts val="0"/>
+              </a:spcAft>
+            </a:pPr>
+            <a:r>
+              <a:rPr sz="2200" b="1">
+                <a:solidFill>
+                  <a:srgbClr val="FFFFFF"/>
+                </a:solidFill>
+                <a:latin typeface="Arial"/>
+              </a:rPr>
+              <a:t>Oussama Turki  ·  Tushar Pandey</a:t>
+            </a:r>
+          </a:p>
+        </p:txBody>
+      </p:sp>
+      <p:sp>
+        <p:nvSpPr>
+          <p:cNvPr id="4" name="TextBox 3"/>
+          <p:cNvSpPr txBox="1"/>
+          <p:nvPr/>
+        </p:nvSpPr>
+        <p:spPr>
+          <a:xfrm>
+            <a:off x="548640" y="4130040"/>
+            <a:ext cx="6309360" cy="304800"/>
+          </a:xfrm>
+          <a:prstGeom prst="rect">
+            <a:avLst/>
+          </a:prstGeom>
+          <a:noFill/>
+        </p:spPr>
+        <p:txBody>
+          <a:bodyPr wrap="square" lIns="0" rIns="0" tIns="0" bIns="0" anchor="t">
+            <a:noAutofit/>
+          </a:bodyPr>
+          <a:lstStyle/>
+          <a:p>
+            <a:pPr algn="l">
+              <a:lnSpc>
+                <a:spcPts val="2400"/>
+              </a:lnSpc>
+              <a:spcBef>
+                <a:spcPts val="0"/>
+              </a:spcBef>
+              <a:spcAft>
+                <a:spcPts val="0"/>
+              </a:spcAft>
+            </a:pPr>
+            <a:r>
+              <a:rPr sz="2000" b="0">
+                <a:solidFill>
+                  <a:srgbClr val="A9B4C6"/>
+                </a:solidFill>
+                <a:latin typeface="Arial"/>
+              </a:rPr>
+              <a:t>Portfolio Selection with QAOA</a:t>
+            </a:r>
+          </a:p>
+        </p:txBody>
+      </p:sp>
+      <p:sp>
+        <p:nvSpPr>
+          <p:cNvPr id="5" name="Rounded Rectangle 4"/>
+          <p:cNvSpPr/>
+          <p:nvPr/>
+        </p:nvSpPr>
+        <p:spPr>
+          <a:xfrm>
+            <a:off x="548640" y="5257800"/>
+            <a:ext cx="5120640" cy="566928"/>
+          </a:xfrm>
+          <a:prstGeom prst="roundRect">
+            <a:avLst>
+              <a:gd name="adj" fmla="val 50000"/>
+            </a:avLst>
+          </a:prstGeom>
+          <a:solidFill>
+            <a:srgbClr val="131B2E"/>
+          </a:solidFill>
+          <a:ln w="15875">
+            <a:solidFill>
+              <a:srgbClr val="17A2B8"/>
+            </a:solidFill>
+          </a:ln>
+          <a:effectLst/>
+        </p:spPr>
+        <p:style>
+          <a:lnRef idx="1">
+            <a:schemeClr val="accent1"/>
+          </a:lnRef>
+          <a:fillRef idx="3">
+            <a:schemeClr val="accent1"/>
+          </a:fillRef>
+          <a:effectRef idx="2">
+            <a:schemeClr val="accent1"/>
+          </a:effectRef>
+          <a:fontRef idx="minor">
+            <a:schemeClr val="lt1"/>
+          </a:fontRef>
+        </p:style>
+        <p:txBody>
+          <a:bodyPr rtlCol="0" anchor="ctr"/>
+          <a:lstStyle/>
+          <a:p>
+            <a:pPr algn="ctr"/>
+          </a:p>
+        </p:txBody>
+      </p:sp>
+      <p:sp>
+        <p:nvSpPr>
           <p:cNvPr id="6" name="TextBox 5"/>
           <p:cNvSpPr txBox="1"/>
           <p:nvPr/>
@@ -5019,7 +6479,7 @@
                 </a:solidFill>
                 <a:latin typeface="Arial"/>
               </a:rPr>
-              <a:t>10</a:t>
+              <a:t>11</a:t>
             </a:r>
           </a:p>
         </p:txBody>
@@ -12386,29 +13846,275 @@
                 </a:solidFill>
                 <a:latin typeface="Arial"/>
               </a:rPr>
-              <a:t>Try it on Qollab: one click, one IonQ job</a:t>
-            </a:r>
-          </a:p>
-        </p:txBody>
-      </p:sp>
-      <p:sp>
-        <p:nvSpPr>
-          <p:cNvPr id="3" name="Rounded Rectangle 2"/>
+              <a:t>Iceberg code: verified, but it costs gates</a:t>
+            </a:r>
+          </a:p>
+        </p:txBody>
+      </p:sp>
+      <p:pic>
+        <p:nvPicPr>
+          <p:cNvPr id="3" name="Picture 2" descr="Bar chart: share of single faults that are caught or harmless, from injecting every single fault (5,904) in exact simulation. Start state and flag 100 %, syndrome checks 100 %, readout bit flips 100 %, QAOA gates 80 %; the rest are XX, YY and ZZ errors on a gate's own pair, which a distance-2 code cannot see."/>
+          <p:cNvPicPr>
+            <a:picLocks noChangeAspect="1"/>
+          </p:cNvPicPr>
+          <p:nvPr/>
+        </p:nvPicPr>
+        <p:blipFill>
+          <a:blip r:embed="rId2"/>
+          <a:stretch>
+            <a:fillRect/>
+          </a:stretch>
+        </p:blipFill>
+        <p:spPr>
+          <a:xfrm>
+            <a:off x="548640" y="1508760"/>
+            <a:ext cx="6675120" cy="3840480"/>
+          </a:xfrm>
+          <a:prstGeom prst="rect">
+            <a:avLst/>
+          </a:prstGeom>
+        </p:spPr>
+      </p:pic>
+      <p:sp>
+        <p:nvSpPr>
+          <p:cNvPr id="4" name="TextBox 3"/>
+          <p:cNvSpPr txBox="1"/>
+          <p:nvPr/>
+        </p:nvSpPr>
+        <p:spPr>
+          <a:xfrm>
+            <a:off x="7589520" y="1554480"/>
+            <a:ext cx="4050792" cy="625856"/>
+          </a:xfrm>
+          <a:prstGeom prst="rect">
+            <a:avLst/>
+          </a:prstGeom>
+          <a:noFill/>
+        </p:spPr>
+        <p:txBody>
+          <a:bodyPr wrap="square" lIns="0" rIns="0" tIns="0" bIns="0" anchor="t">
+            <a:noAutofit/>
+          </a:bodyPr>
+          <a:lstStyle/>
+          <a:p>
+            <a:pPr algn="l">
+              <a:lnSpc>
+                <a:spcPts val="4928"/>
+              </a:lnSpc>
+              <a:spcBef>
+                <a:spcPts val="0"/>
+              </a:spcBef>
+              <a:spcAft>
+                <a:spcPts val="0"/>
+              </a:spcAft>
+            </a:pPr>
+            <a:r>
+              <a:rPr sz="4400" b="1">
+                <a:solidFill>
+                  <a:srgbClr val="17A2B8"/>
+                </a:solidFill>
+                <a:latin typeface="Arial"/>
+              </a:rPr>
+              <a:t>17 qubits</a:t>
+            </a:r>
+          </a:p>
+        </p:txBody>
+      </p:sp>
+      <p:sp>
+        <p:nvSpPr>
+          <p:cNvPr id="5" name="TextBox 4"/>
+          <p:cNvSpPr txBox="1"/>
+          <p:nvPr/>
+        </p:nvSpPr>
+        <p:spPr>
+          <a:xfrm>
+            <a:off x="7589520" y="2198624"/>
+            <a:ext cx="4050792" cy="609600"/>
+          </a:xfrm>
+          <a:prstGeom prst="rect">
+            <a:avLst/>
+          </a:prstGeom>
+          <a:noFill/>
+        </p:spPr>
+        <p:txBody>
+          <a:bodyPr wrap="square" lIns="0" rIns="0" tIns="0" bIns="0" anchor="t">
+            <a:noAutofit/>
+          </a:bodyPr>
+          <a:lstStyle/>
+          <a:p>
+            <a:pPr algn="l">
+              <a:lnSpc>
+                <a:spcPts val="2400"/>
+              </a:lnSpc>
+              <a:spcBef>
+                <a:spcPts val="0"/>
+              </a:spcBef>
+              <a:spcAft>
+                <a:spcPts val="0"/>
+              </a:spcAft>
+            </a:pPr>
+            <a:r>
+              <a:rPr sz="2000" b="0">
+                <a:solidFill>
+                  <a:srgbClr val="FFFFFF"/>
+                </a:solidFill>
+                <a:latin typeface="Arial"/>
+              </a:rPr>
+              <a:t>12 logical on 14, + 1 flag</a:t>
+            </a:r>
+          </a:p>
+          <a:p>
+            <a:pPr algn="l">
+              <a:lnSpc>
+                <a:spcPts val="2400"/>
+              </a:lnSpc>
+              <a:spcBef>
+                <a:spcPts val="0"/>
+              </a:spcBef>
+              <a:spcAft>
+                <a:spcPts val="0"/>
+              </a:spcAft>
+            </a:pPr>
+            <a:r>
+              <a:rPr sz="2000" b="0">
+                <a:solidFill>
+                  <a:srgbClr val="FFFFFF"/>
+                </a:solidFill>
+                <a:latin typeface="Arial"/>
+              </a:rPr>
+              <a:t>+ 2 helpers per check</a:t>
+            </a:r>
+          </a:p>
+        </p:txBody>
+      </p:sp>
+      <p:sp>
+        <p:nvSpPr>
+          <p:cNvPr id="6" name="TextBox 5"/>
+          <p:cNvSpPr txBox="1"/>
+          <p:nvPr/>
+        </p:nvSpPr>
+        <p:spPr>
+          <a:xfrm>
+            <a:off x="7589520" y="2991104"/>
+            <a:ext cx="4050792" cy="625856"/>
+          </a:xfrm>
+          <a:prstGeom prst="rect">
+            <a:avLst/>
+          </a:prstGeom>
+          <a:noFill/>
+        </p:spPr>
+        <p:txBody>
+          <a:bodyPr wrap="square" lIns="0" rIns="0" tIns="0" bIns="0" anchor="t">
+            <a:noAutofit/>
+          </a:bodyPr>
+          <a:lstStyle/>
+          <a:p>
+            <a:pPr algn="l">
+              <a:lnSpc>
+                <a:spcPts val="4928"/>
+              </a:lnSpc>
+              <a:spcBef>
+                <a:spcPts val="0"/>
+              </a:spcBef>
+              <a:spcAft>
+                <a:spcPts val="0"/>
+              </a:spcAft>
+            </a:pPr>
+            <a:r>
+              <a:rPr sz="4400" b="1">
+                <a:solidFill>
+                  <a:srgbClr val="17A2B8"/>
+                </a:solidFill>
+                <a:latin typeface="Arial"/>
+              </a:rPr>
+              <a:t>+58 %</a:t>
+            </a:r>
+          </a:p>
+        </p:txBody>
+      </p:sp>
+      <p:sp>
+        <p:nvSpPr>
+          <p:cNvPr id="7" name="TextBox 6"/>
+          <p:cNvSpPr txBox="1"/>
+          <p:nvPr/>
+        </p:nvSpPr>
+        <p:spPr>
+          <a:xfrm>
+            <a:off x="7589520" y="3635248"/>
+            <a:ext cx="4050792" cy="609600"/>
+          </a:xfrm>
+          <a:prstGeom prst="rect">
+            <a:avLst/>
+          </a:prstGeom>
+          <a:noFill/>
+        </p:spPr>
+        <p:txBody>
+          <a:bodyPr wrap="square" lIns="0" rIns="0" tIns="0" bIns="0" anchor="t">
+            <a:noAutofit/>
+          </a:bodyPr>
+          <a:lstStyle/>
+          <a:p>
+            <a:pPr algn="l">
+              <a:lnSpc>
+                <a:spcPts val="2400"/>
+              </a:lnSpc>
+              <a:spcBef>
+                <a:spcPts val="0"/>
+              </a:spcBef>
+              <a:spcAft>
+                <a:spcPts val="0"/>
+              </a:spcAft>
+            </a:pPr>
+            <a:r>
+              <a:rPr sz="2000" b="0">
+                <a:solidFill>
+                  <a:srgbClr val="FFFFFF"/>
+                </a:solidFill>
+                <a:latin typeface="Arial"/>
+              </a:rPr>
+              <a:t>two-qubit gates at 3 layers</a:t>
+            </a:r>
+          </a:p>
+          <a:p>
+            <a:pPr algn="l">
+              <a:lnSpc>
+                <a:spcPts val="2400"/>
+              </a:lnSpc>
+              <a:spcBef>
+                <a:spcPts val="0"/>
+              </a:spcBef>
+              <a:spcAft>
+                <a:spcPts val="0"/>
+              </a:spcAft>
+            </a:pPr>
+            <a:r>
+              <a:rPr sz="2000" b="0">
+                <a:solidFill>
+                  <a:srgbClr val="FFFFFF"/>
+                </a:solidFill>
+                <a:latin typeface="Arial"/>
+              </a:rPr>
+              <a:t>(313 vs 198)</a:t>
+            </a:r>
+          </a:p>
+        </p:txBody>
+      </p:sp>
+      <p:sp>
+        <p:nvSpPr>
+          <p:cNvPr id="8" name="Oval 7"/>
           <p:cNvSpPr/>
           <p:nvPr/>
         </p:nvSpPr>
         <p:spPr>
           <a:xfrm>
-            <a:off x="548640" y="1554480"/>
-            <a:ext cx="5120640" cy="3794760"/>
-          </a:xfrm>
-          <a:prstGeom prst="roundRect">
-            <a:avLst>
-              <a:gd name="adj" fmla="val 2891"/>
-            </a:avLst>
+            <a:off x="7589520" y="4532884"/>
+            <a:ext cx="100584" cy="100584"/>
+          </a:xfrm>
+          <a:prstGeom prst="ellipse">
+            <a:avLst/>
           </a:prstGeom>
           <a:solidFill>
-            <a:srgbClr val="131B2E"/>
+            <a:srgbClr val="17A2B8"/>
           </a:solidFill>
           <a:ln>
             <a:noFill/>
@@ -12439,14 +14145,14 @@
       </p:sp>
       <p:sp>
         <p:nvSpPr>
-          <p:cNvPr id="4" name="TextBox 3"/>
+          <p:cNvPr id="9" name="TextBox 8"/>
           <p:cNvSpPr txBox="1"/>
           <p:nvPr/>
         </p:nvSpPr>
         <p:spPr>
           <a:xfrm>
-            <a:off x="822960" y="1783080"/>
-            <a:ext cx="4572000" cy="365760"/>
+            <a:off x="7863840" y="4446016"/>
+            <a:ext cx="3776472" cy="822960"/>
           </a:xfrm>
           <a:prstGeom prst="rect">
             <a:avLst/>
@@ -12461,81 +14167,81 @@
           <a:p>
             <a:pPr algn="l">
               <a:lnSpc>
-                <a:spcPts val="2879"/>
-              </a:lnSpc>
-              <a:spcBef>
-                <a:spcPts val="0"/>
-              </a:spcBef>
-              <a:spcAft>
-                <a:spcPts val="0"/>
-              </a:spcAft>
-            </a:pPr>
-            <a:r>
-              <a:rPr sz="2400" b="1">
+                <a:spcPts val="2160"/>
+              </a:lnSpc>
+              <a:spcBef>
+                <a:spcPts val="0"/>
+              </a:spcBef>
+              <a:spcAft>
+                <a:spcPts val="0"/>
+              </a:spcAft>
+            </a:pPr>
+            <a:r>
+              <a:rPr sz="1800" b="0">
                 <a:solidFill>
                   <a:srgbClr val="FFFFFF"/>
                 </a:solidFill>
                 <a:latin typeface="Arial"/>
               </a:rPr>
-              <a:t>Live demo on Qollab</a:t>
-            </a:r>
-          </a:p>
-        </p:txBody>
-      </p:sp>
-      <p:sp>
-        <p:nvSpPr>
-          <p:cNvPr id="5" name="Oval 4"/>
-          <p:cNvSpPr/>
-          <p:nvPr/>
-        </p:nvSpPr>
-        <p:spPr>
-          <a:xfrm>
-            <a:off x="822960" y="2523744"/>
-            <a:ext cx="457200" cy="457200"/>
-          </a:xfrm>
-          <a:prstGeom prst="ellipse">
-            <a:avLst/>
-          </a:prstGeom>
-          <a:solidFill>
-            <a:srgbClr val="17A2B8"/>
-          </a:solidFill>
-          <a:ln>
-            <a:noFill/>
-          </a:ln>
-          <a:effectLst/>
-        </p:spPr>
-        <p:style>
-          <a:lnRef idx="1">
-            <a:schemeClr val="accent1"/>
-          </a:lnRef>
-          <a:fillRef idx="3">
-            <a:schemeClr val="accent1"/>
-          </a:fillRef>
-          <a:effectRef idx="2">
-            <a:schemeClr val="accent1"/>
-          </a:effectRef>
-          <a:fontRef idx="minor">
-            <a:schemeClr val="lt1"/>
-          </a:fontRef>
-        </p:style>
-        <p:txBody>
-          <a:bodyPr rtlCol="0" anchor="ctr"/>
-          <a:lstStyle/>
-          <a:p>
-            <a:pPr algn="ctr"/>
-          </a:p>
-        </p:txBody>
-      </p:sp>
-      <p:sp>
-        <p:nvSpPr>
-          <p:cNvPr id="6" name="TextBox 5"/>
+              <a:t>IonQ simulator via Qollab:</a:t>
+            </a:r>
+          </a:p>
+          <a:p>
+            <a:pPr algn="l">
+              <a:lnSpc>
+                <a:spcPts val="2160"/>
+              </a:lnSpc>
+              <a:spcBef>
+                <a:spcPts val="0"/>
+              </a:spcBef>
+              <a:spcAft>
+                <a:spcPts val="0"/>
+              </a:spcAft>
+            </a:pPr>
+            <a:r>
+              <a:rPr sz="1800" b="0">
+                <a:solidFill>
+                  <a:srgbClr val="FFFFFF"/>
+                </a:solidFill>
+                <a:latin typeface="Arial"/>
+              </a:rPr>
+              <a:t>every check passed, results</a:t>
+            </a:r>
+          </a:p>
+          <a:p>
+            <a:pPr algn="l">
+              <a:lnSpc>
+                <a:spcPts val="2160"/>
+              </a:lnSpc>
+              <a:spcBef>
+                <a:spcPts val="0"/>
+              </a:spcBef>
+              <a:spcAft>
+                <a:spcPts val="0"/>
+              </a:spcAft>
+            </a:pPr>
+            <a:r>
+              <a:rPr sz="1800" b="0">
+                <a:solidFill>
+                  <a:srgbClr val="FFFFFF"/>
+                </a:solidFill>
+                <a:latin typeface="Arial"/>
+              </a:rPr>
+              <a:t>match the noiseless ones</a:t>
+            </a:r>
+          </a:p>
+        </p:txBody>
+      </p:sp>
+      <p:sp>
+        <p:nvSpPr>
+          <p:cNvPr id="10" name="TextBox 9"/>
           <p:cNvSpPr txBox="1"/>
           <p:nvPr/>
         </p:nvSpPr>
         <p:spPr>
           <a:xfrm>
-            <a:off x="822960" y="2606040"/>
-            <a:ext cx="457200" cy="274320"/>
+            <a:off x="548640" y="384048"/>
+            <a:ext cx="11094415" cy="274320"/>
           </a:xfrm>
           <a:prstGeom prst="rect">
             <a:avLst/>
@@ -12548,7 +14254,7 @@
           </a:bodyPr>
           <a:lstStyle/>
           <a:p>
-            <a:pPr algn="ctr">
+            <a:pPr algn="l">
               <a:lnSpc>
                 <a:spcPts val="2160"/>
               </a:lnSpc>
@@ -12562,25 +14268,25 @@
             <a:r>
               <a:rPr sz="1800" b="1">
                 <a:solidFill>
-                  <a:srgbClr val="FFFFFF"/>
-                </a:solidFill>
-                <a:latin typeface="Arial"/>
-              </a:rPr>
-              <a:t>1</a:t>
-            </a:r>
-          </a:p>
-        </p:txBody>
-      </p:sp>
-      <p:sp>
-        <p:nvSpPr>
-          <p:cNvPr id="7" name="TextBox 6"/>
+                  <a:srgbClr val="17A2B8"/>
+                </a:solidFill>
+                <a:latin typeface="Arial"/>
+              </a:rPr>
+              <a:t>ERROR DETECTION</a:t>
+            </a:r>
+          </a:p>
+        </p:txBody>
+      </p:sp>
+      <p:sp>
+        <p:nvSpPr>
+          <p:cNvPr id="11" name="TextBox 10"/>
           <p:cNvSpPr txBox="1"/>
           <p:nvPr/>
         </p:nvSpPr>
         <p:spPr>
           <a:xfrm>
-            <a:off x="1508760" y="2441448"/>
-            <a:ext cx="4023360" cy="609600"/>
+            <a:off x="548640" y="5513832"/>
+            <a:ext cx="11094415" cy="548640"/>
           </a:xfrm>
           <a:prstGeom prst="rect">
             <a:avLst/>
@@ -12595,103 +14301,59 @@
           <a:p>
             <a:pPr algn="l">
               <a:lnSpc>
-                <a:spcPts val="2400"/>
-              </a:lnSpc>
-              <a:spcBef>
-                <a:spcPts val="0"/>
-              </a:spcBef>
-              <a:spcAft>
-                <a:spcPts val="0"/>
-              </a:spcAft>
-            </a:pPr>
-            <a:r>
-              <a:rPr sz="2000" b="0">
-                <a:solidFill>
-                  <a:srgbClr val="FFFFFF"/>
-                </a:solidFill>
-                <a:latin typeface="Arial"/>
-              </a:rPr>
-              <a:t>Open the project:</a:t>
+                <a:spcPts val="2160"/>
+              </a:lnSpc>
+              <a:spcBef>
+                <a:spcPts val="0"/>
+              </a:spcBef>
+              <a:spcAft>
+                <a:spcPts val="0"/>
+              </a:spcAft>
+            </a:pPr>
+            <a:r>
+              <a:rPr sz="1800" b="0">
+                <a:solidFill>
+                  <a:srgbClr val="A9B4C6"/>
+                </a:solidFill>
+                <a:latin typeface="Arial"/>
+              </a:rPr>
+              <a:t>Faults: exact simulation of every single fault (1, 2 layers) · Qollab IonQ simulator: 12 jobs, 11 Oct 2026</a:t>
             </a:r>
           </a:p>
           <a:p>
             <a:pPr algn="l">
               <a:lnSpc>
-                <a:spcPts val="2400"/>
-              </a:lnSpc>
-              <a:spcBef>
-                <a:spcPts val="0"/>
-              </a:spcBef>
-              <a:spcAft>
-                <a:spcPts val="0"/>
-              </a:spcAft>
-            </a:pPr>
-            <a:r>
-              <a:rPr sz="2000" b="0">
-                <a:solidFill>
-                  <a:srgbClr val="FFFFFF"/>
-                </a:solidFill>
-                <a:latin typeface="Arial"/>
-              </a:rPr>
-              <a:t>the code is in main.py</a:t>
-            </a:r>
-          </a:p>
-        </p:txBody>
-      </p:sp>
-      <p:sp>
-        <p:nvSpPr>
-          <p:cNvPr id="8" name="Oval 7"/>
-          <p:cNvSpPr/>
-          <p:nvPr/>
-        </p:nvSpPr>
-        <p:spPr>
-          <a:xfrm>
-            <a:off x="822960" y="3499104"/>
-            <a:ext cx="457200" cy="457200"/>
-          </a:xfrm>
-          <a:prstGeom prst="ellipse">
-            <a:avLst/>
-          </a:prstGeom>
-          <a:solidFill>
-            <a:srgbClr val="17A2B8"/>
-          </a:solidFill>
-          <a:ln>
-            <a:noFill/>
-          </a:ln>
-          <a:effectLst/>
-        </p:spPr>
-        <p:style>
-          <a:lnRef idx="1">
-            <a:schemeClr val="accent1"/>
-          </a:lnRef>
-          <a:fillRef idx="3">
-            <a:schemeClr val="accent1"/>
-          </a:fillRef>
-          <a:effectRef idx="2">
-            <a:schemeClr val="accent1"/>
-          </a:effectRef>
-          <a:fontRef idx="minor">
-            <a:schemeClr val="lt1"/>
-          </a:fontRef>
-        </p:style>
-        <p:txBody>
-          <a:bodyPr rtlCol="0" anchor="ctr"/>
-          <a:lstStyle/>
-          <a:p>
-            <a:pPr algn="ctr"/>
-          </a:p>
-        </p:txBody>
-      </p:sp>
-      <p:sp>
-        <p:nvSpPr>
-          <p:cNvPr id="9" name="TextBox 8"/>
+                <a:spcPts val="2160"/>
+              </a:lnSpc>
+              <a:spcBef>
+                <a:spcPts val="0"/>
+              </a:spcBef>
+              <a:spcAft>
+                <a:spcPts val="0"/>
+              </a:spcAft>
+            </a:pPr>
+            <a:r>
+              <a:rPr sz="1800" b="0">
+                <a:solidFill>
+                  <a:srgbClr val="A9B4C6"/>
+                </a:solidFill>
+                <a:latin typeface="Arial"/>
+              </a:rPr>
+              <a:t>Detection, not correction: shots that fail a check are discarded</a:t>
+            </a:r>
+          </a:p>
+        </p:txBody>
+      </p:sp>
+      <p:sp>
+        <p:nvSpPr>
+          <p:cNvPr id="12" name="TextBox 11"/>
           <p:cNvSpPr txBox="1"/>
           <p:nvPr/>
         </p:nvSpPr>
         <p:spPr>
           <a:xfrm>
-            <a:off x="822960" y="3581400"/>
-            <a:ext cx="457200" cy="274320"/>
+            <a:off x="548640" y="6327648"/>
+            <a:ext cx="7315200" cy="274320"/>
           </a:xfrm>
           <a:prstGeom prst="rect">
             <a:avLst/>
@@ -12704,7 +14366,7 @@
           </a:bodyPr>
           <a:lstStyle/>
           <a:p>
-            <a:pPr algn="ctr">
+            <a:pPr algn="l">
               <a:lnSpc>
                 <a:spcPts val="2160"/>
               </a:lnSpc>
@@ -12716,169 +14378,13 @@
               </a:spcAft>
             </a:pPr>
             <a:r>
-              <a:rPr sz="1800" b="1">
-                <a:solidFill>
-                  <a:srgbClr val="FFFFFF"/>
-                </a:solidFill>
-                <a:latin typeface="Arial"/>
-              </a:rPr>
-              <a:t>2</a:t>
-            </a:r>
-          </a:p>
-        </p:txBody>
-      </p:sp>
-      <p:sp>
-        <p:nvSpPr>
-          <p:cNvPr id="10" name="TextBox 9"/>
-          <p:cNvSpPr txBox="1"/>
-          <p:nvPr/>
-        </p:nvSpPr>
-        <p:spPr>
-          <a:xfrm>
-            <a:off x="1508760" y="3416808"/>
-            <a:ext cx="4023360" cy="609600"/>
-          </a:xfrm>
-          <a:prstGeom prst="rect">
-            <a:avLst/>
-          </a:prstGeom>
-          <a:noFill/>
-        </p:spPr>
-        <p:txBody>
-          <a:bodyPr wrap="square" lIns="0" rIns="0" tIns="0" bIns="0" anchor="t">
-            <a:noAutofit/>
-          </a:bodyPr>
-          <a:lstStyle/>
-          <a:p>
-            <a:pPr algn="l">
-              <a:lnSpc>
-                <a:spcPts val="2400"/>
-              </a:lnSpc>
-              <a:spcBef>
-                <a:spcPts val="0"/>
-              </a:spcBef>
-              <a:spcAft>
-                <a:spcPts val="0"/>
-              </a:spcAft>
-            </a:pPr>
-            <a:r>
-              <a:rPr sz="2000" b="0">
-                <a:solidFill>
-                  <a:srgbClr val="FFFFFF"/>
-                </a:solidFill>
-                <a:latin typeface="Arial"/>
-              </a:rPr>
-              <a:t>Run → Select QPU →</a:t>
-            </a:r>
-          </a:p>
-          <a:p>
-            <a:pPr algn="l">
-              <a:lnSpc>
-                <a:spcPts val="2400"/>
-              </a:lnSpc>
-              <a:spcBef>
-                <a:spcPts val="0"/>
-              </a:spcBef>
-              <a:spcAft>
-                <a:spcPts val="0"/>
-              </a:spcAft>
-            </a:pPr>
-            <a:r>
-              <a:rPr sz="2000" b="0">
-                <a:solidFill>
-                  <a:srgbClr val="FFFFFF"/>
-                </a:solidFill>
-                <a:latin typeface="Arial"/>
-              </a:rPr>
-              <a:t>IonQ Forte 1 (29q) noise model</a:t>
-            </a:r>
-          </a:p>
-        </p:txBody>
-      </p:sp>
-      <p:sp>
-        <p:nvSpPr>
-          <p:cNvPr id="11" name="Oval 10"/>
-          <p:cNvSpPr/>
-          <p:nvPr/>
-        </p:nvSpPr>
-        <p:spPr>
-          <a:xfrm>
-            <a:off x="822960" y="4474464"/>
-            <a:ext cx="457200" cy="457200"/>
-          </a:xfrm>
-          <a:prstGeom prst="ellipse">
-            <a:avLst/>
-          </a:prstGeom>
-          <a:solidFill>
-            <a:srgbClr val="17A2B8"/>
-          </a:solidFill>
-          <a:ln>
-            <a:noFill/>
-          </a:ln>
-          <a:effectLst/>
-        </p:spPr>
-        <p:style>
-          <a:lnRef idx="1">
-            <a:schemeClr val="accent1"/>
-          </a:lnRef>
-          <a:fillRef idx="3">
-            <a:schemeClr val="accent1"/>
-          </a:fillRef>
-          <a:effectRef idx="2">
-            <a:schemeClr val="accent1"/>
-          </a:effectRef>
-          <a:fontRef idx="minor">
-            <a:schemeClr val="lt1"/>
-          </a:fontRef>
-        </p:style>
-        <p:txBody>
-          <a:bodyPr rtlCol="0" anchor="ctr"/>
-          <a:lstStyle/>
-          <a:p>
-            <a:pPr algn="ctr"/>
-          </a:p>
-        </p:txBody>
-      </p:sp>
-      <p:sp>
-        <p:nvSpPr>
-          <p:cNvPr id="12" name="TextBox 11"/>
-          <p:cNvSpPr txBox="1"/>
-          <p:nvPr/>
-        </p:nvSpPr>
-        <p:spPr>
-          <a:xfrm>
-            <a:off x="822960" y="4556760"/>
-            <a:ext cx="457200" cy="274320"/>
-          </a:xfrm>
-          <a:prstGeom prst="rect">
-            <a:avLst/>
-          </a:prstGeom>
-          <a:noFill/>
-        </p:spPr>
-        <p:txBody>
-          <a:bodyPr wrap="square" lIns="0" rIns="0" tIns="0" bIns="0" anchor="t">
-            <a:noAutofit/>
-          </a:bodyPr>
-          <a:lstStyle/>
-          <a:p>
-            <a:pPr algn="ctr">
-              <a:lnSpc>
-                <a:spcPts val="2160"/>
-              </a:lnSpc>
-              <a:spcBef>
-                <a:spcPts val="0"/>
-              </a:spcBef>
-              <a:spcAft>
-                <a:spcPts val="0"/>
-              </a:spcAft>
-            </a:pPr>
-            <a:r>
-              <a:rPr sz="1800" b="1">
-                <a:solidFill>
-                  <a:srgbClr val="FFFFFF"/>
-                </a:solidFill>
-                <a:latin typeface="Arial"/>
-              </a:rPr>
-              <a:t>3</a:t>
+              <a:rPr sz="1800" b="0">
+                <a:solidFill>
+                  <a:srgbClr val="A9B4C6"/>
+                </a:solidFill>
+                <a:latin typeface="Arial"/>
+              </a:rPr>
+              <a:t>ZollerQu - Qollab x IonQ Hackathon 2026</a:t>
             </a:r>
           </a:p>
         </p:txBody>
@@ -12886,787 +14392,6 @@
       <p:sp>
         <p:nvSpPr>
           <p:cNvPr id="13" name="TextBox 12"/>
-          <p:cNvSpPr txBox="1"/>
-          <p:nvPr/>
-        </p:nvSpPr>
-        <p:spPr>
-          <a:xfrm>
-            <a:off x="1508760" y="4392168"/>
-            <a:ext cx="4023360" cy="609600"/>
-          </a:xfrm>
-          <a:prstGeom prst="rect">
-            <a:avLst/>
-          </a:prstGeom>
-          <a:noFill/>
-        </p:spPr>
-        <p:txBody>
-          <a:bodyPr wrap="square" lIns="0" rIns="0" tIns="0" bIns="0" anchor="t">
-            <a:noAutofit/>
-          </a:bodyPr>
-          <a:lstStyle/>
-          <a:p>
-            <a:pPr algn="l">
-              <a:lnSpc>
-                <a:spcPts val="2400"/>
-              </a:lnSpc>
-              <a:spcBef>
-                <a:spcPts val="0"/>
-              </a:spcBef>
-              <a:spcAft>
-                <a:spcPts val="0"/>
-              </a:spcAft>
-            </a:pPr>
-            <a:r>
-              <a:rPr sz="2000" b="0">
-                <a:solidFill>
-                  <a:srgbClr val="FFFFFF"/>
-                </a:solidFill>
-                <a:latin typeface="Arial"/>
-              </a:rPr>
-              <a:t>One job returns the counts,</a:t>
-            </a:r>
-          </a:p>
-          <a:p>
-            <a:pPr algn="l">
-              <a:lnSpc>
-                <a:spcPts val="2400"/>
-              </a:lnSpc>
-              <a:spcBef>
-                <a:spcPts val="0"/>
-              </a:spcBef>
-              <a:spcAft>
-                <a:spcPts val="0"/>
-              </a:spcAft>
-            </a:pPr>
-            <a:r>
-              <a:rPr sz="2000" b="0">
-                <a:solidFill>
-                  <a:srgbClr val="FFFFFF"/>
-                </a:solidFill>
-                <a:latin typeface="Arial"/>
-              </a:rPr>
-              <a:t>the table and the plots</a:t>
-            </a:r>
-          </a:p>
-        </p:txBody>
-      </p:sp>
-      <p:sp>
-        <p:nvSpPr>
-          <p:cNvPr id="14" name="TextBox 13"/>
-          <p:cNvSpPr txBox="1"/>
-          <p:nvPr/>
-        </p:nvSpPr>
-        <p:spPr>
-          <a:xfrm>
-            <a:off x="6172200" y="1554480"/>
-            <a:ext cx="5468112" cy="335280"/>
-          </a:xfrm>
-          <a:prstGeom prst="rect">
-            <a:avLst/>
-          </a:prstGeom>
-          <a:noFill/>
-        </p:spPr>
-        <p:txBody>
-          <a:bodyPr wrap="square" lIns="0" rIns="0" tIns="0" bIns="0" anchor="t">
-            <a:noAutofit/>
-          </a:bodyPr>
-          <a:lstStyle/>
-          <a:p>
-            <a:pPr algn="l">
-              <a:lnSpc>
-                <a:spcPts val="2640"/>
-              </a:lnSpc>
-              <a:spcBef>
-                <a:spcPts val="0"/>
-              </a:spcBef>
-              <a:spcAft>
-                <a:spcPts val="0"/>
-              </a:spcAft>
-            </a:pPr>
-            <a:r>
-              <a:rPr sz="2200" b="1">
-                <a:solidFill>
-                  <a:srgbClr val="FFFFFF"/>
-                </a:solidFill>
-                <a:latin typeface="Arial"/>
-              </a:rPr>
-              <a:t>Honest limits</a:t>
-            </a:r>
-          </a:p>
-        </p:txBody>
-      </p:sp>
-      <p:sp>
-        <p:nvSpPr>
-          <p:cNvPr id="15" name="Oval 14"/>
-          <p:cNvSpPr/>
-          <p:nvPr/>
-        </p:nvSpPr>
-        <p:spPr>
-          <a:xfrm>
-            <a:off x="6172200" y="2122932"/>
-            <a:ext cx="100584" cy="100584"/>
-          </a:xfrm>
-          <a:prstGeom prst="ellipse">
-            <a:avLst/>
-          </a:prstGeom>
-          <a:solidFill>
-            <a:srgbClr val="17A2B8"/>
-          </a:solidFill>
-          <a:ln>
-            <a:noFill/>
-          </a:ln>
-          <a:effectLst/>
-        </p:spPr>
-        <p:style>
-          <a:lnRef idx="1">
-            <a:schemeClr val="accent1"/>
-          </a:lnRef>
-          <a:fillRef idx="3">
-            <a:schemeClr val="accent1"/>
-          </a:fillRef>
-          <a:effectRef idx="2">
-            <a:schemeClr val="accent1"/>
-          </a:effectRef>
-          <a:fontRef idx="minor">
-            <a:schemeClr val="lt1"/>
-          </a:fontRef>
-        </p:style>
-        <p:txBody>
-          <a:bodyPr rtlCol="0" anchor="ctr"/>
-          <a:lstStyle/>
-          <a:p>
-            <a:pPr algn="ctr"/>
-          </a:p>
-        </p:txBody>
-      </p:sp>
-      <p:sp>
-        <p:nvSpPr>
-          <p:cNvPr id="16" name="TextBox 15"/>
-          <p:cNvSpPr txBox="1"/>
-          <p:nvPr/>
-        </p:nvSpPr>
-        <p:spPr>
-          <a:xfrm>
-            <a:off x="6446520" y="2036064"/>
-            <a:ext cx="5193792" cy="274320"/>
-          </a:xfrm>
-          <a:prstGeom prst="rect">
-            <a:avLst/>
-          </a:prstGeom>
-          <a:noFill/>
-        </p:spPr>
-        <p:txBody>
-          <a:bodyPr wrap="square" lIns="0" rIns="0" tIns="0" bIns="0" anchor="t">
-            <a:noAutofit/>
-          </a:bodyPr>
-          <a:lstStyle/>
-          <a:p>
-            <a:pPr algn="l">
-              <a:lnSpc>
-                <a:spcPts val="2160"/>
-              </a:lnSpc>
-              <a:spcBef>
-                <a:spcPts val="0"/>
-              </a:spcBef>
-              <a:spcAft>
-                <a:spcPts val="0"/>
-              </a:spcAft>
-            </a:pPr>
-            <a:r>
-              <a:rPr sz="1800" b="0">
-                <a:solidFill>
-                  <a:srgbClr val="FFFFFF"/>
-                </a:solidFill>
-                <a:latin typeface="Arial"/>
-              </a:rPr>
-              <a:t>A noisy simulator: one job of 1,000 shots</a:t>
-            </a:r>
-          </a:p>
-        </p:txBody>
-      </p:sp>
-      <p:sp>
-        <p:nvSpPr>
-          <p:cNvPr id="17" name="Oval 16"/>
-          <p:cNvSpPr/>
-          <p:nvPr/>
-        </p:nvSpPr>
-        <p:spPr>
-          <a:xfrm>
-            <a:off x="6172200" y="2525268"/>
-            <a:ext cx="100584" cy="100584"/>
-          </a:xfrm>
-          <a:prstGeom prst="ellipse">
-            <a:avLst/>
-          </a:prstGeom>
-          <a:solidFill>
-            <a:srgbClr val="17A2B8"/>
-          </a:solidFill>
-          <a:ln>
-            <a:noFill/>
-          </a:ln>
-          <a:effectLst/>
-        </p:spPr>
-        <p:style>
-          <a:lnRef idx="1">
-            <a:schemeClr val="accent1"/>
-          </a:lnRef>
-          <a:fillRef idx="3">
-            <a:schemeClr val="accent1"/>
-          </a:fillRef>
-          <a:effectRef idx="2">
-            <a:schemeClr val="accent1"/>
-          </a:effectRef>
-          <a:fontRef idx="minor">
-            <a:schemeClr val="lt1"/>
-          </a:fontRef>
-        </p:style>
-        <p:txBody>
-          <a:bodyPr rtlCol="0" anchor="ctr"/>
-          <a:lstStyle/>
-          <a:p>
-            <a:pPr algn="ctr"/>
-          </a:p>
-        </p:txBody>
-      </p:sp>
-      <p:sp>
-        <p:nvSpPr>
-          <p:cNvPr id="18" name="TextBox 17"/>
-          <p:cNvSpPr txBox="1"/>
-          <p:nvPr/>
-        </p:nvSpPr>
-        <p:spPr>
-          <a:xfrm>
-            <a:off x="6446520" y="2438400"/>
-            <a:ext cx="5193792" cy="274320"/>
-          </a:xfrm>
-          <a:prstGeom prst="rect">
-            <a:avLst/>
-          </a:prstGeom>
-          <a:noFill/>
-        </p:spPr>
-        <p:txBody>
-          <a:bodyPr wrap="square" lIns="0" rIns="0" tIns="0" bIns="0" anchor="t">
-            <a:noAutofit/>
-          </a:bodyPr>
-          <a:lstStyle/>
-          <a:p>
-            <a:pPr algn="l">
-              <a:lnSpc>
-                <a:spcPts val="2160"/>
-              </a:lnSpc>
-              <a:spcBef>
-                <a:spcPts val="0"/>
-              </a:spcBef>
-              <a:spcAft>
-                <a:spcPts val="0"/>
-              </a:spcAft>
-            </a:pPr>
-            <a:r>
-              <a:rPr sz="1800" b="0">
-                <a:solidFill>
-                  <a:srgbClr val="FFFFFF"/>
-                </a:solidFill>
-                <a:latin typeface="Arial"/>
-              </a:rPr>
-              <a:t>Noise cuts the hits from 58 to 7 per 1,000</a:t>
-            </a:r>
-          </a:p>
-        </p:txBody>
-      </p:sp>
-      <p:sp>
-        <p:nvSpPr>
-          <p:cNvPr id="19" name="Oval 18"/>
-          <p:cNvSpPr/>
-          <p:nvPr/>
-        </p:nvSpPr>
-        <p:spPr>
-          <a:xfrm>
-            <a:off x="6172200" y="2927604"/>
-            <a:ext cx="100584" cy="100584"/>
-          </a:xfrm>
-          <a:prstGeom prst="ellipse">
-            <a:avLst/>
-          </a:prstGeom>
-          <a:solidFill>
-            <a:srgbClr val="17A2B8"/>
-          </a:solidFill>
-          <a:ln>
-            <a:noFill/>
-          </a:ln>
-          <a:effectLst/>
-        </p:spPr>
-        <p:style>
-          <a:lnRef idx="1">
-            <a:schemeClr val="accent1"/>
-          </a:lnRef>
-          <a:fillRef idx="3">
-            <a:schemeClr val="accent1"/>
-          </a:fillRef>
-          <a:effectRef idx="2">
-            <a:schemeClr val="accent1"/>
-          </a:effectRef>
-          <a:fontRef idx="minor">
-            <a:schemeClr val="lt1"/>
-          </a:fontRef>
-        </p:style>
-        <p:txBody>
-          <a:bodyPr rtlCol="0" anchor="ctr"/>
-          <a:lstStyle/>
-          <a:p>
-            <a:pPr algn="ctr"/>
-          </a:p>
-        </p:txBody>
-      </p:sp>
-      <p:sp>
-        <p:nvSpPr>
-          <p:cNvPr id="20" name="TextBox 19"/>
-          <p:cNvSpPr txBox="1"/>
-          <p:nvPr/>
-        </p:nvSpPr>
-        <p:spPr>
-          <a:xfrm>
-            <a:off x="6446520" y="2840736"/>
-            <a:ext cx="5193792" cy="274320"/>
-          </a:xfrm>
-          <a:prstGeom prst="rect">
-            <a:avLst/>
-          </a:prstGeom>
-          <a:noFill/>
-        </p:spPr>
-        <p:txBody>
-          <a:bodyPr wrap="square" lIns="0" rIns="0" tIns="0" bIns="0" anchor="t">
-            <a:noAutofit/>
-          </a:bodyPr>
-          <a:lstStyle/>
-          <a:p>
-            <a:pPr algn="l">
-              <a:lnSpc>
-                <a:spcPts val="2160"/>
-              </a:lnSpc>
-              <a:spcBef>
-                <a:spcPts val="0"/>
-              </a:spcBef>
-              <a:spcAft>
-                <a:spcPts val="0"/>
-              </a:spcAft>
-            </a:pPr>
-            <a:r>
-              <a:rPr sz="1800" b="0">
-                <a:solidFill>
-                  <a:srgbClr val="FFFFFF"/>
-                </a:solidFill>
-                <a:latin typeface="Arial"/>
-              </a:rPr>
-              <a:t>Classical heuristics match or beat it</a:t>
-            </a:r>
-          </a:p>
-        </p:txBody>
-      </p:sp>
-      <p:sp>
-        <p:nvSpPr>
-          <p:cNvPr id="21" name="TextBox 20"/>
-          <p:cNvSpPr txBox="1"/>
-          <p:nvPr/>
-        </p:nvSpPr>
-        <p:spPr>
-          <a:xfrm>
-            <a:off x="6172200" y="3499104"/>
-            <a:ext cx="5468112" cy="335280"/>
-          </a:xfrm>
-          <a:prstGeom prst="rect">
-            <a:avLst/>
-          </a:prstGeom>
-          <a:noFill/>
-        </p:spPr>
-        <p:txBody>
-          <a:bodyPr wrap="square" lIns="0" rIns="0" tIns="0" bIns="0" anchor="t">
-            <a:noAutofit/>
-          </a:bodyPr>
-          <a:lstStyle/>
-          <a:p>
-            <a:pPr algn="l">
-              <a:lnSpc>
-                <a:spcPts val="2640"/>
-              </a:lnSpc>
-              <a:spcBef>
-                <a:spcPts val="0"/>
-              </a:spcBef>
-              <a:spcAft>
-                <a:spcPts val="0"/>
-              </a:spcAft>
-            </a:pPr>
-            <a:r>
-              <a:rPr sz="2200" b="1">
-                <a:solidFill>
-                  <a:srgbClr val="FFFFFF"/>
-                </a:solidFill>
-                <a:latin typeface="Arial"/>
-              </a:rPr>
-              <a:t>Next steps</a:t>
-            </a:r>
-          </a:p>
-        </p:txBody>
-      </p:sp>
-      <p:sp>
-        <p:nvSpPr>
-          <p:cNvPr id="22" name="Oval 21"/>
-          <p:cNvSpPr/>
-          <p:nvPr/>
-        </p:nvSpPr>
-        <p:spPr>
-          <a:xfrm>
-            <a:off x="6172200" y="4067556"/>
-            <a:ext cx="100584" cy="100584"/>
-          </a:xfrm>
-          <a:prstGeom prst="ellipse">
-            <a:avLst/>
-          </a:prstGeom>
-          <a:solidFill>
-            <a:srgbClr val="17A2B8"/>
-          </a:solidFill>
-          <a:ln>
-            <a:noFill/>
-          </a:ln>
-          <a:effectLst/>
-        </p:spPr>
-        <p:style>
-          <a:lnRef idx="1">
-            <a:schemeClr val="accent1"/>
-          </a:lnRef>
-          <a:fillRef idx="3">
-            <a:schemeClr val="accent1"/>
-          </a:fillRef>
-          <a:effectRef idx="2">
-            <a:schemeClr val="accent1"/>
-          </a:effectRef>
-          <a:fontRef idx="minor">
-            <a:schemeClr val="lt1"/>
-          </a:fontRef>
-        </p:style>
-        <p:txBody>
-          <a:bodyPr rtlCol="0" anchor="ctr"/>
-          <a:lstStyle/>
-          <a:p>
-            <a:pPr algn="ctr"/>
-          </a:p>
-        </p:txBody>
-      </p:sp>
-      <p:sp>
-        <p:nvSpPr>
-          <p:cNvPr id="23" name="TextBox 22"/>
-          <p:cNvSpPr txBox="1"/>
-          <p:nvPr/>
-        </p:nvSpPr>
-        <p:spPr>
-          <a:xfrm>
-            <a:off x="6446520" y="3980688"/>
-            <a:ext cx="5193792" cy="274320"/>
-          </a:xfrm>
-          <a:prstGeom prst="rect">
-            <a:avLst/>
-          </a:prstGeom>
-          <a:noFill/>
-        </p:spPr>
-        <p:txBody>
-          <a:bodyPr wrap="square" lIns="0" rIns="0" tIns="0" bIns="0" anchor="t">
-            <a:noAutofit/>
-          </a:bodyPr>
-          <a:lstStyle/>
-          <a:p>
-            <a:pPr algn="l">
-              <a:lnSpc>
-                <a:spcPts val="2160"/>
-              </a:lnSpc>
-              <a:spcBef>
-                <a:spcPts val="0"/>
-              </a:spcBef>
-              <a:spcAft>
-                <a:spcPts val="0"/>
-              </a:spcAft>
-            </a:pPr>
-            <a:r>
-              <a:rPr sz="1800" b="0">
-                <a:solidFill>
-                  <a:srgbClr val="FFFFFF"/>
-                </a:solidFill>
-                <a:latin typeface="Arial"/>
-              </a:rPr>
-              <a:t>Run the other 4 selected circuits</a:t>
-            </a:r>
-          </a:p>
-        </p:txBody>
-      </p:sp>
-      <p:sp>
-        <p:nvSpPr>
-          <p:cNvPr id="24" name="Oval 23"/>
-          <p:cNvSpPr/>
-          <p:nvPr/>
-        </p:nvSpPr>
-        <p:spPr>
-          <a:xfrm>
-            <a:off x="6172200" y="4469892"/>
-            <a:ext cx="100584" cy="100584"/>
-          </a:xfrm>
-          <a:prstGeom prst="ellipse">
-            <a:avLst/>
-          </a:prstGeom>
-          <a:solidFill>
-            <a:srgbClr val="17A2B8"/>
-          </a:solidFill>
-          <a:ln>
-            <a:noFill/>
-          </a:ln>
-          <a:effectLst/>
-        </p:spPr>
-        <p:style>
-          <a:lnRef idx="1">
-            <a:schemeClr val="accent1"/>
-          </a:lnRef>
-          <a:fillRef idx="3">
-            <a:schemeClr val="accent1"/>
-          </a:fillRef>
-          <a:effectRef idx="2">
-            <a:schemeClr val="accent1"/>
-          </a:effectRef>
-          <a:fontRef idx="minor">
-            <a:schemeClr val="lt1"/>
-          </a:fontRef>
-        </p:style>
-        <p:txBody>
-          <a:bodyPr rtlCol="0" anchor="ctr"/>
-          <a:lstStyle/>
-          <a:p>
-            <a:pPr algn="ctr"/>
-          </a:p>
-        </p:txBody>
-      </p:sp>
-      <p:sp>
-        <p:nvSpPr>
-          <p:cNvPr id="25" name="TextBox 24"/>
-          <p:cNvSpPr txBox="1"/>
-          <p:nvPr/>
-        </p:nvSpPr>
-        <p:spPr>
-          <a:xfrm>
-            <a:off x="6446520" y="4383024"/>
-            <a:ext cx="5193792" cy="274320"/>
-          </a:xfrm>
-          <a:prstGeom prst="rect">
-            <a:avLst/>
-          </a:prstGeom>
-          <a:noFill/>
-        </p:spPr>
-        <p:txBody>
-          <a:bodyPr wrap="square" lIns="0" rIns="0" tIns="0" bIns="0" anchor="t">
-            <a:noAutofit/>
-          </a:bodyPr>
-          <a:lstStyle/>
-          <a:p>
-            <a:pPr algn="l">
-              <a:lnSpc>
-                <a:spcPts val="2160"/>
-              </a:lnSpc>
-              <a:spcBef>
-                <a:spcPts val="0"/>
-              </a:spcBef>
-              <a:spcAft>
-                <a:spcPts val="0"/>
-              </a:spcAft>
-            </a:pPr>
-            <a:r>
-              <a:rPr sz="1800" b="0">
-                <a:solidFill>
-                  <a:srgbClr val="FFFFFF"/>
-                </a:solidFill>
-                <a:latin typeface="Arial"/>
-              </a:rPr>
-              <a:t>Shorter circuits: 66 instead of 198 gates</a:t>
-            </a:r>
-          </a:p>
-        </p:txBody>
-      </p:sp>
-      <p:sp>
-        <p:nvSpPr>
-          <p:cNvPr id="26" name="Oval 25"/>
-          <p:cNvSpPr/>
-          <p:nvPr/>
-        </p:nvSpPr>
-        <p:spPr>
-          <a:xfrm>
-            <a:off x="6172200" y="4872228"/>
-            <a:ext cx="100584" cy="100584"/>
-          </a:xfrm>
-          <a:prstGeom prst="ellipse">
-            <a:avLst/>
-          </a:prstGeom>
-          <a:solidFill>
-            <a:srgbClr val="17A2B8"/>
-          </a:solidFill>
-          <a:ln>
-            <a:noFill/>
-          </a:ln>
-          <a:effectLst/>
-        </p:spPr>
-        <p:style>
-          <a:lnRef idx="1">
-            <a:schemeClr val="accent1"/>
-          </a:lnRef>
-          <a:fillRef idx="3">
-            <a:schemeClr val="accent1"/>
-          </a:fillRef>
-          <a:effectRef idx="2">
-            <a:schemeClr val="accent1"/>
-          </a:effectRef>
-          <a:fontRef idx="minor">
-            <a:schemeClr val="lt1"/>
-          </a:fontRef>
-        </p:style>
-        <p:txBody>
-          <a:bodyPr rtlCol="0" anchor="ctr"/>
-          <a:lstStyle/>
-          <a:p>
-            <a:pPr algn="ctr"/>
-          </a:p>
-        </p:txBody>
-      </p:sp>
-      <p:sp>
-        <p:nvSpPr>
-          <p:cNvPr id="27" name="TextBox 26"/>
-          <p:cNvSpPr txBox="1"/>
-          <p:nvPr/>
-        </p:nvSpPr>
-        <p:spPr>
-          <a:xfrm>
-            <a:off x="6446520" y="4785360"/>
-            <a:ext cx="5193792" cy="274320"/>
-          </a:xfrm>
-          <a:prstGeom prst="rect">
-            <a:avLst/>
-          </a:prstGeom>
-          <a:noFill/>
-        </p:spPr>
-        <p:txBody>
-          <a:bodyPr wrap="square" lIns="0" rIns="0" tIns="0" bIns="0" anchor="t">
-            <a:noAutofit/>
-          </a:bodyPr>
-          <a:lstStyle/>
-          <a:p>
-            <a:pPr algn="l">
-              <a:lnSpc>
-                <a:spcPts val="2160"/>
-              </a:lnSpc>
-              <a:spcBef>
-                <a:spcPts val="0"/>
-              </a:spcBef>
-              <a:spcAft>
-                <a:spcPts val="0"/>
-              </a:spcAft>
-            </a:pPr>
-            <a:r>
-              <a:rPr sz="1800" b="0">
-                <a:solidFill>
-                  <a:srgbClr val="FFFFFF"/>
-                </a:solidFill>
-                <a:latin typeface="Arial"/>
-              </a:rPr>
-              <a:t>Find how many layers the noise allows</a:t>
-            </a:r>
-          </a:p>
-        </p:txBody>
-      </p:sp>
-      <p:sp>
-        <p:nvSpPr>
-          <p:cNvPr id="28" name="TextBox 27"/>
-          <p:cNvSpPr txBox="1"/>
-          <p:nvPr/>
-        </p:nvSpPr>
-        <p:spPr>
-          <a:xfrm>
-            <a:off x="548640" y="384048"/>
-            <a:ext cx="11094415" cy="274320"/>
-          </a:xfrm>
-          <a:prstGeom prst="rect">
-            <a:avLst/>
-          </a:prstGeom>
-          <a:noFill/>
-        </p:spPr>
-        <p:txBody>
-          <a:bodyPr wrap="square" lIns="0" rIns="0" tIns="0" bIns="0" anchor="t">
-            <a:noAutofit/>
-          </a:bodyPr>
-          <a:lstStyle/>
-          <a:p>
-            <a:pPr algn="l">
-              <a:lnSpc>
-                <a:spcPts val="2160"/>
-              </a:lnSpc>
-              <a:spcBef>
-                <a:spcPts val="0"/>
-              </a:spcBef>
-              <a:spcAft>
-                <a:spcPts val="0"/>
-              </a:spcAft>
-            </a:pPr>
-            <a:r>
-              <a:rPr sz="1800" b="1">
-                <a:solidFill>
-                  <a:srgbClr val="17A2B8"/>
-                </a:solidFill>
-                <a:latin typeface="Arial"/>
-              </a:rPr>
-              <a:t>DEMO, LIMITS, NEXT STEPS</a:t>
-            </a:r>
-          </a:p>
-        </p:txBody>
-      </p:sp>
-      <p:sp>
-        <p:nvSpPr>
-          <p:cNvPr id="29" name="TextBox 28"/>
-          <p:cNvSpPr txBox="1"/>
-          <p:nvPr/>
-        </p:nvSpPr>
-        <p:spPr>
-          <a:xfrm>
-            <a:off x="548640" y="6327648"/>
-            <a:ext cx="7315200" cy="274320"/>
-          </a:xfrm>
-          <a:prstGeom prst="rect">
-            <a:avLst/>
-          </a:prstGeom>
-          <a:noFill/>
-        </p:spPr>
-        <p:txBody>
-          <a:bodyPr wrap="square" lIns="0" rIns="0" tIns="0" bIns="0" anchor="t">
-            <a:noAutofit/>
-          </a:bodyPr>
-          <a:lstStyle/>
-          <a:p>
-            <a:pPr algn="l">
-              <a:lnSpc>
-                <a:spcPts val="2160"/>
-              </a:lnSpc>
-              <a:spcBef>
-                <a:spcPts val="0"/>
-              </a:spcBef>
-              <a:spcAft>
-                <a:spcPts val="0"/>
-              </a:spcAft>
-            </a:pPr>
-            <a:r>
-              <a:rPr sz="1800" b="0">
-                <a:solidFill>
-                  <a:srgbClr val="A9B4C6"/>
-                </a:solidFill>
-                <a:latin typeface="Arial"/>
-              </a:rPr>
-              <a:t>ZollerQu - Qollab x IonQ Hackathon 2026</a:t>
-            </a:r>
-          </a:p>
-        </p:txBody>
-      </p:sp>
-      <p:sp>
-        <p:nvSpPr>
-          <p:cNvPr id="30" name="TextBox 29"/>
           <p:cNvSpPr txBox="1"/>
           <p:nvPr/>
         </p:nvSpPr>

</xml_diff>

<commit_message>
fix(stocks): Qollab sweeps were mostly local noiseless fallbacks; never substitute, one job per Run
Only 4 of 24 sweep jobs reached IonQ (all plain); the rest were refused
('Another job is already running') and silently replaced by a seed-2026 local
noiseless sample, which explains the 100 % kept and identical numbers.
main.py now resubmits while IonQ is busy, reports refused jobs as NOT RUN,
labels each summary row IonQ/local, and defaults to a single job.
Slide 9 no longer claims an Iceberg run on Qollab.

Co-Authored-By: Claude Opus 5.5 <noreply@anthropic.com>
</commit_message>
<xml_diff>
--- a/slides/stocks_ZollerQu.pptx
+++ b/slides/stocks_ZollerQu.pptx
@@ -1215,7 +1215,7 @@
           <a:lstStyle/>
           <a:p>
             <a:r>
-              <a:t>We also protected the circuit with the Iceberg error-detection code: twelve logical qubits on 17. Every state-preparation, check and readout fault is caught, and four in five gate faults. On Qollab's IonQ simulator every shot passed; the price is more gates.</a:t>
+              <a:t>We also protected the circuit with the Iceberg error-detection code: twelve logical qubits on 17. Every state-preparation, check and readout fault is caught, and four in five gate faults. The price is more gates; how it does under the IonQ noise model is our next run.</a:t>
             </a:r>
           </a:p>
         </p:txBody>
@@ -4726,7 +4726,7 @@
                 </a:solidFill>
                 <a:latin typeface="Arial"/>
               </a:rPr>
-              <a:t>Try it on Qollab: one click runs it all</a:t>
+              <a:t>Try it on Qollab: one click, one IonQ job</a:t>
             </a:r>
           </a:p>
         </p:txBody>
@@ -14183,7 +14183,7 @@
                 </a:solidFill>
                 <a:latin typeface="Arial"/>
               </a:rPr>
-              <a:t>IonQ simulator via Qollab:</a:t>
+              <a:t>Under the IonQ noise model:</a:t>
             </a:r>
           </a:p>
           <a:p>
@@ -14205,7 +14205,7 @@
                 </a:solidFill>
                 <a:latin typeface="Arial"/>
               </a:rPr>
-              <a:t>every check passed, results</a:t>
+              <a:t>not run yet (Qollab runs</a:t>
             </a:r>
           </a:p>
           <a:p>
@@ -14227,7 +14227,7 @@
                 </a:solidFill>
                 <a:latin typeface="Arial"/>
               </a:rPr>
-              <a:t>match the noiseless ones</a:t>
+              <a:t>one IonQ job at a time)</a:t>
             </a:r>
           </a:p>
         </p:txBody>
@@ -14317,7 +14317,7 @@
                 </a:solidFill>
                 <a:latin typeface="Arial"/>
               </a:rPr>
-              <a:t>Faults: exact simulation of every single fault (1, 2 layers) · Qollab IonQ simulator: 18 jobs, 11 Oct 2026</a:t>
+              <a:t>Faults: exact simulation of every single fault (1, 2 layers), 11 Oct 2026</a:t>
             </a:r>
           </a:p>
           <a:p>

</xml_diff>

<commit_message>
results(stocks): first Iceberg job on the IonQ Forte 1 noise model; slide 9 shows it
Layers 1, 1,000 shots: 246 kept (flag 133, checks 684, parity 430 failed);
best portfolio in 2 of 246 kept shots (8.1 per 1,000, 95 % 2-29) vs plain
5-11 per 1,000 on the same noise model; 133 vs 66 two-qubit gates.

Co-Authored-By: Claude Opus 5.5 <noreply@anthropic.com>
</commit_message>
<xml_diff>
--- a/slides/stocks_ZollerQu.pptx
+++ b/slides/stocks_ZollerQu.pptx
@@ -1215,7 +1215,7 @@
           <a:lstStyle/>
           <a:p>
             <a:r>
-              <a:t>We also protected the circuit with the Iceberg error-detection code: twelve logical qubits on 17. Every state-preparation, check and readout fault is caught, and four in five gate faults. The price is more gates; how it does under the IonQ noise model is our next run.</a:t>
+              <a:t>We also protected the circuit with the Iceberg error-detection code: twelve logical qubits on 17. In exact simulation it catches every preparation, check and readout fault. On the IonQ noise model it flagged three in four shots. The kept shots were not clearly better than plain QAOA, because the code doubles the gates.</a:t>
             </a:r>
           </a:p>
         </p:txBody>
@@ -5731,7 +5731,7 @@
                 </a:solidFill>
                 <a:latin typeface="Arial"/>
               </a:rPr>
-              <a:t>Iceberg on the Forte 1 noise model</a:t>
+              <a:t>Iceberg at more layers and checks</a:t>
             </a:r>
           </a:p>
         </p:txBody>
@@ -13846,7 +13846,7 @@
                 </a:solidFill>
                 <a:latin typeface="Arial"/>
               </a:rPr>
-              <a:t>Iceberg code: verified, but it costs gates</a:t>
+              <a:t>Iceberg catches errors, but doubles the gates</a:t>
             </a:r>
           </a:p>
         </p:txBody>
@@ -14027,7 +14027,7 @@
                 </a:solidFill>
                 <a:latin typeface="Arial"/>
               </a:rPr>
-              <a:t>+58 %</a:t>
+              <a:t>25 % kept</a:t>
             </a:r>
           </a:p>
         </p:txBody>
@@ -14072,7 +14072,7 @@
                 </a:solidFill>
                 <a:latin typeface="Arial"/>
               </a:rPr>
-              <a:t>two-qubit gates at 3 layers</a:t>
+              <a:t>IonQ Forte 1 noise model,</a:t>
             </a:r>
           </a:p>
           <a:p>
@@ -14094,7 +14094,7 @@
                 </a:solidFill>
                 <a:latin typeface="Arial"/>
               </a:rPr>
-              <a:t>(313 vs 198)</a:t>
+              <a:t>1 layer: 3 in 4 shots flagged</a:t>
             </a:r>
           </a:p>
         </p:txBody>
@@ -14152,7 +14152,7 @@
         <p:spPr>
           <a:xfrm>
             <a:off x="7863840" y="4446016"/>
-            <a:ext cx="3776472" cy="822960"/>
+            <a:ext cx="3776472" cy="548640"/>
           </a:xfrm>
           <a:prstGeom prst="rect">
             <a:avLst/>
@@ -14183,7 +14183,7 @@
                 </a:solidFill>
                 <a:latin typeface="Arial"/>
               </a:rPr>
-              <a:t>Under the IonQ noise model:</a:t>
+              <a:t>Best portfolio: 2 of 246 kept</a:t>
             </a:r>
           </a:p>
           <a:p>
@@ -14205,43 +14205,65 @@
                 </a:solidFill>
                 <a:latin typeface="Arial"/>
               </a:rPr>
-              <a:t>not run yet (Qollab runs</a:t>
-            </a:r>
-          </a:p>
-          <a:p>
-            <a:pPr algn="l">
-              <a:lnSpc>
-                <a:spcPts val="2160"/>
-              </a:lnSpc>
-              <a:spcBef>
-                <a:spcPts val="0"/>
-              </a:spcBef>
-              <a:spcAft>
-                <a:spcPts val="0"/>
-              </a:spcAft>
-            </a:pPr>
-            <a:r>
-              <a:rPr sz="1800" b="0">
-                <a:solidFill>
-                  <a:srgbClr val="FFFFFF"/>
-                </a:solidFill>
-                <a:latin typeface="Arial"/>
-              </a:rPr>
-              <a:t>one IonQ job at a time)</a:t>
-            </a:r>
-          </a:p>
-        </p:txBody>
-      </p:sp>
-      <p:sp>
-        <p:nvSpPr>
-          <p:cNvPr id="10" name="TextBox 9"/>
+              <a:t>shots; plain 5-11 per 1,000</a:t>
+            </a:r>
+          </a:p>
+        </p:txBody>
+      </p:sp>
+      <p:sp>
+        <p:nvSpPr>
+          <p:cNvPr id="10" name="Oval 9"/>
+          <p:cNvSpPr/>
+          <p:nvPr/>
+        </p:nvSpPr>
+        <p:spPr>
+          <a:xfrm>
+            <a:off x="7589520" y="5191252"/>
+            <a:ext cx="100584" cy="100584"/>
+          </a:xfrm>
+          <a:prstGeom prst="ellipse">
+            <a:avLst/>
+          </a:prstGeom>
+          <a:solidFill>
+            <a:srgbClr val="17A2B8"/>
+          </a:solidFill>
+          <a:ln>
+            <a:noFill/>
+          </a:ln>
+          <a:effectLst/>
+        </p:spPr>
+        <p:style>
+          <a:lnRef idx="1">
+            <a:schemeClr val="accent1"/>
+          </a:lnRef>
+          <a:fillRef idx="3">
+            <a:schemeClr val="accent1"/>
+          </a:fillRef>
+          <a:effectRef idx="2">
+            <a:schemeClr val="accent1"/>
+          </a:effectRef>
+          <a:fontRef idx="minor">
+            <a:schemeClr val="lt1"/>
+          </a:fontRef>
+        </p:style>
+        <p:txBody>
+          <a:bodyPr rtlCol="0" anchor="ctr"/>
+          <a:lstStyle/>
+          <a:p>
+            <a:pPr algn="ctr"/>
+          </a:p>
+        </p:txBody>
+      </p:sp>
+      <p:sp>
+        <p:nvSpPr>
+          <p:cNvPr id="11" name="TextBox 10"/>
           <p:cNvSpPr txBox="1"/>
           <p:nvPr/>
         </p:nvSpPr>
         <p:spPr>
           <a:xfrm>
-            <a:off x="548640" y="384048"/>
-            <a:ext cx="11094415" cy="274320"/>
+            <a:off x="7863840" y="5104384"/>
+            <a:ext cx="3776472" cy="274320"/>
           </a:xfrm>
           <a:prstGeom prst="rect">
             <a:avLst/>
@@ -14266,27 +14288,27 @@
               </a:spcAft>
             </a:pPr>
             <a:r>
-              <a:rPr sz="1800" b="1">
-                <a:solidFill>
-                  <a:srgbClr val="17A2B8"/>
-                </a:solidFill>
-                <a:latin typeface="Arial"/>
-              </a:rPr>
-              <a:t>ERROR DETECTION</a:t>
-            </a:r>
-          </a:p>
-        </p:txBody>
-      </p:sp>
-      <p:sp>
-        <p:nvSpPr>
-          <p:cNvPr id="11" name="TextBox 10"/>
+              <a:rPr sz="1800" b="0">
+                <a:solidFill>
+                  <a:srgbClr val="FFFFFF"/>
+                </a:solidFill>
+                <a:latin typeface="Arial"/>
+              </a:rPr>
+              <a:t>133 vs 66 two-qubit gates</a:t>
+            </a:r>
+          </a:p>
+        </p:txBody>
+      </p:sp>
+      <p:sp>
+        <p:nvSpPr>
+          <p:cNvPr id="12" name="TextBox 11"/>
           <p:cNvSpPr txBox="1"/>
           <p:nvPr/>
         </p:nvSpPr>
         <p:spPr>
           <a:xfrm>
-            <a:off x="548640" y="5513832"/>
-            <a:ext cx="11094415" cy="548640"/>
+            <a:off x="548640" y="384048"/>
+            <a:ext cx="11094415" cy="274320"/>
           </a:xfrm>
           <a:prstGeom prst="rect">
             <a:avLst/>
@@ -14311,49 +14333,27 @@
               </a:spcAft>
             </a:pPr>
             <a:r>
-              <a:rPr sz="1800" b="0">
-                <a:solidFill>
-                  <a:srgbClr val="A9B4C6"/>
-                </a:solidFill>
-                <a:latin typeface="Arial"/>
-              </a:rPr>
-              <a:t>Faults: exact simulation of every single fault (1, 2 layers), 11 Oct 2026</a:t>
-            </a:r>
-          </a:p>
-          <a:p>
-            <a:pPr algn="l">
-              <a:lnSpc>
-                <a:spcPts val="2160"/>
-              </a:lnSpc>
-              <a:spcBef>
-                <a:spcPts val="0"/>
-              </a:spcBef>
-              <a:spcAft>
-                <a:spcPts val="0"/>
-              </a:spcAft>
-            </a:pPr>
-            <a:r>
-              <a:rPr sz="1800" b="0">
-                <a:solidFill>
-                  <a:srgbClr val="A9B4C6"/>
-                </a:solidFill>
-                <a:latin typeface="Arial"/>
-              </a:rPr>
-              <a:t>Detection, not correction: shots that fail a check are discarded</a:t>
-            </a:r>
-          </a:p>
-        </p:txBody>
-      </p:sp>
-      <p:sp>
-        <p:nvSpPr>
-          <p:cNvPr id="12" name="TextBox 11"/>
+              <a:rPr sz="1800" b="1">
+                <a:solidFill>
+                  <a:srgbClr val="17A2B8"/>
+                </a:solidFill>
+                <a:latin typeface="Arial"/>
+              </a:rPr>
+              <a:t>ERROR DETECTION</a:t>
+            </a:r>
+          </a:p>
+        </p:txBody>
+      </p:sp>
+      <p:sp>
+        <p:nvSpPr>
+          <p:cNvPr id="13" name="TextBox 12"/>
           <p:cNvSpPr txBox="1"/>
           <p:nvPr/>
         </p:nvSpPr>
         <p:spPr>
           <a:xfrm>
-            <a:off x="548640" y="6327648"/>
-            <a:ext cx="7315200" cy="274320"/>
+            <a:off x="548640" y="5513832"/>
+            <a:ext cx="11094415" cy="548640"/>
           </a:xfrm>
           <a:prstGeom prst="rect">
             <a:avLst/>
@@ -14384,6 +14384,73 @@
                 </a:solidFill>
                 <a:latin typeface="Arial"/>
               </a:rPr>
+              <a:t>Faults: exact simulation of every single fault (1, 2 layers) · Run: IonQ Forte 1 noise model, 1,000 shots</a:t>
+            </a:r>
+          </a:p>
+          <a:p>
+            <a:pPr algn="l">
+              <a:lnSpc>
+                <a:spcPts val="2160"/>
+              </a:lnSpc>
+              <a:spcBef>
+                <a:spcPts val="0"/>
+              </a:spcBef>
+              <a:spcAft>
+                <a:spcPts val="0"/>
+              </a:spcAft>
+            </a:pPr>
+            <a:r>
+              <a:rPr sz="1800" b="0">
+                <a:solidFill>
+                  <a:srgbClr val="A9B4C6"/>
+                </a:solidFill>
+                <a:latin typeface="Arial"/>
+              </a:rPr>
+              <a:t>Detection, not correction: shots that fail a check are discarded (Qollab, 11 Oct 2026)</a:t>
+            </a:r>
+          </a:p>
+        </p:txBody>
+      </p:sp>
+      <p:sp>
+        <p:nvSpPr>
+          <p:cNvPr id="14" name="TextBox 13"/>
+          <p:cNvSpPr txBox="1"/>
+          <p:nvPr/>
+        </p:nvSpPr>
+        <p:spPr>
+          <a:xfrm>
+            <a:off x="548640" y="6327648"/>
+            <a:ext cx="7315200" cy="274320"/>
+          </a:xfrm>
+          <a:prstGeom prst="rect">
+            <a:avLst/>
+          </a:prstGeom>
+          <a:noFill/>
+        </p:spPr>
+        <p:txBody>
+          <a:bodyPr wrap="square" lIns="0" rIns="0" tIns="0" bIns="0" anchor="t">
+            <a:noAutofit/>
+          </a:bodyPr>
+          <a:lstStyle/>
+          <a:p>
+            <a:pPr algn="l">
+              <a:lnSpc>
+                <a:spcPts val="2160"/>
+              </a:lnSpc>
+              <a:spcBef>
+                <a:spcPts val="0"/>
+              </a:spcBef>
+              <a:spcAft>
+                <a:spcPts val="0"/>
+              </a:spcAft>
+            </a:pPr>
+            <a:r>
+              <a:rPr sz="1800" b="0">
+                <a:solidFill>
+                  <a:srgbClr val="A9B4C6"/>
+                </a:solidFill>
+                <a:latin typeface="Arial"/>
+              </a:rPr>
               <a:t>ZollerQu - Qollab x IonQ Hackathon 2026</a:t>
             </a:r>
           </a:p>
@@ -14391,7 +14458,7 @@
       </p:sp>
       <p:sp>
         <p:nvSpPr>
-          <p:cNvPr id="13" name="TextBox 12"/>
+          <p:cNvPr id="15" name="TextBox 14"/>
           <p:cNvSpPr txBox="1"/>
           <p:nvPr/>
         </p:nvSpPr>

</xml_diff>

<commit_message>
slides(stocks): 3-minute video script (260 words, about 2:26) as presenter notes and slides/video_script_3min.md
Co-Authored-By: Claude Opus 5.5 <noreply@anthropic.com>
</commit_message>
<xml_diff>
--- a/slides/stocks_ZollerQu.pptx
+++ b/slides/stocks_ZollerQu.pptx
@@ -515,7 +515,7 @@
           <a:lstStyle/>
           <a:p>
             <a:r>
-              <a:t>Hi, we are team ZollerQu. Which stocks should a fund buy? We turn this into an Ising problem, one qubit per asset, and sample it with QAOA on the IonQ Forte 1 noise model.</a:t>
+              <a:t>Hi, we are team ZollerQu. We pick stocks with QAOA on the IonQ noise model.</a:t>
             </a:r>
           </a:p>
         </p:txBody>
@@ -585,7 +585,7 @@
           <a:lstStyle/>
           <a:p>
             <a:r>
-              <a:t>[CUT TO LIVE QOLLAB DEMO] Here is our Qollab project; the code is in main.py. We press Run, choose the IonQ Forte 1 noise model, and get counts and plots. [BACK TO SLIDE] Limits: a noisy simulator and strong classical baselines. Next: Iceberg under real noise, and shorter circuits.</a:t>
+              <a:t>[SWITCH TO QOLLAB] This is our project. The code is in main.py. We press Run, pick the IonQ Forte 1 noise model, and get results and plots. [BACK TO SLIDES] Classical methods still match us. Next: more Iceberg layers and shorter circuits.</a:t>
             </a:r>
           </a:p>
         </p:txBody>
@@ -725,7 +725,7 @@
           <a:lstStyle/>
           <a:p>
             <a:r>
-              <a:t>Banks and funds build portfolios every day. They want low risk and a good return. Risk comes from assets that fall together. Twelve assets give 4,096 portfolios; twenty-nine give over five hundred million.</a:t>
+              <a:t>Funds want low risk and good return. Risk comes from assets that fall together. Twelve assets give four thousand portfolios, twenty-nine give half a billion.</a:t>
             </a:r>
           </a:p>
         </p:txBody>
@@ -795,7 +795,7 @@
           <a:lstStyle/>
           <a:p>
             <a:r>
-              <a:t>Each asset is one qubit: zero means buy, one means skip. Risk minus return becomes an Ising energy with one coupling per pair. Checking every portfolio, the best is Apple plus Treasury bonds.</a:t>
+              <a:t>Each asset is one qubit: zero means buy, one means skip. Risk minus return becomes an Ising energy. The exact best: Apple plus US bonds.</a:t>
             </a:r>
           </a:p>
         </p:txBody>
@@ -865,7 +865,7 @@
           <a:lstStyle/>
           <a:p>
             <a:r>
-              <a:t>The circuit is QAOA: Hadamards, a cost layer with one ZZ gate per pair, then a mixer. At twelve qubits the best is CVaR-QAOA; at twenty-nine, linear-ramp QAOA with angles from twelve.</a:t>
+              <a:t>We trained fifty-eight circuits offline. Best at twelve qubits: CVaR-QAOA, three layers. At twenty-nine qubits: linear-ramp QAOA, with the angles reused.</a:t>
             </a:r>
           </a:p>
         </p:txBody>
@@ -935,7 +935,7 @@
           <a:lstStyle/>
           <a:p>
             <a:r>
-              <a:t>We tested eight circuit types, six kinds of QAOA and two imaginary-time methods. Five settings made the difference: the mixer sign, a CVaR objective, more layers, a wider ramp range, and choosing angles by CVaR.</a:t>
+              <a:t>We compared eight circuit types. The mixer sign, the CVaR objective and more layers mattered most.</a:t>
             </a:r>
           </a:p>
         </p:txBody>
@@ -1005,7 +1005,7 @@
           <a:lstStyle/>
           <a:p>
             <a:r>
-              <a:t>Trapped ions link every pair of qubits directly. One layer needs 66 two-qubit gates; on a heavy-hex grid it needs 285: 4.3 times more, and 6.5 times at twenty-nine qubits.</a:t>
+              <a:t>Trapped ions connect every pair of qubits, so one layer needs sixty-six two-qubit gates. A heavy-hex chip needs two hundred eighty-five.</a:t>
             </a:r>
           </a:p>
         </p:txBody>
@@ -1075,7 +1075,7 @@
           <a:lstStyle/>
           <a:p>
             <a:r>
-              <a:t>On the IonQ Forte 1 noise model, 7 of 1,000 shots were the exact best portfolio, 29 times more than random guessing. The noiseless simulation gives 58, so noise costs a factor of 8. Greedy search is in the same range.</a:t>
+              <a:t>Main result: on the IonQ noise model, seven in a thousand shots were the exact best portfolio, twenty-nine times better than random. Without noise it is fifty-eight.</a:t>
             </a:r>
           </a:p>
         </p:txBody>
@@ -1145,7 +1145,7 @@
           <a:lstStyle/>
           <a:p>
             <a:r>
-              <a:t>At twenty-nine assets the three-layer circuit finds the best portfolio in 7 percent of runs, classical methods in 61. With more layers, the noiseless circuit reaches 90 percent at sixteen. That needs six and a half thousand two-qubit gates, far beyond today's noise. No advantage is claimed.</a:t>
+              <a:t>With twenty-nine assets, three layers find the best in seven percent of runs, classical search in sixty-one. Sixteen layers reach ninety percent, but only without noise. No quantum advantage is claimed.</a:t>
             </a:r>
           </a:p>
         </p:txBody>
@@ -1215,7 +1215,7 @@
           <a:lstStyle/>
           <a:p>
             <a:r>
-              <a:t>We also protected the circuit with the Iceberg error-detection code: twelve logical qubits on 17. In exact simulation it catches every preparation, check and readout fault. On the IonQ noise model it flagged three in four shots. The kept shots were not clearly better than plain QAOA, because the code doubles the gates.</a:t>
+              <a:t>We also tried Iceberg error detection. On the IonQ noise model it flagged three in four shots. The kept shots were not clearly better, because the code doubles the gates.</a:t>
             </a:r>
           </a:p>
         </p:txBody>

</xml_diff>

<commit_message>
slides(stocks): more natural 3-minute script (275 words, about 2:33)
Co-Authored-By: Claude Opus 5.5 <noreply@anthropic.com>
</commit_message>
<xml_diff>
--- a/slides/stocks_ZollerQu.pptx
+++ b/slides/stocks_ZollerQu.pptx
@@ -515,7 +515,7 @@
           <a:lstStyle/>
           <a:p>
             <a:r>
-              <a:t>Hi, we are team ZollerQu. We pick stocks with QAOA on the IonQ noise model.</a:t>
+              <a:t>Hi, we're team ZollerQu. Which stocks should you buy? We answer that with QAOA, on IonQ's noise model.</a:t>
             </a:r>
           </a:p>
         </p:txBody>
@@ -585,7 +585,7 @@
           <a:lstStyle/>
           <a:p>
             <a:r>
-              <a:t>[SWITCH TO QOLLAB] This is our project. The code is in main.py. We press Run, pick the IonQ Forte 1 noise model, and get results and plots. [BACK TO SLIDES] Classical methods still match us. Next: more Iceberg layers and shorter circuits.</a:t>
+              <a:t>[SWITCH TO QOLLAB] Here's our project; the code is in main.py. We press Run, pick the Forte 1 noise model, and get results and plots. [BACK TO SLIDES] Honestly, classical methods still keep up. Next: Iceberg on deeper circuits.</a:t>
             </a:r>
           </a:p>
         </p:txBody>
@@ -655,7 +655,7 @@
           <a:lstStyle/>
           <a:p>
             <a:r>
-              <a:t>Thank you for your attention. This effort is supported by Qollab and IonQ.</a:t>
+              <a:t>Thank you for your attention! This effort is supported by Qollab and IonQ.</a:t>
             </a:r>
           </a:p>
         </p:txBody>
@@ -725,7 +725,7 @@
           <a:lstStyle/>
           <a:p>
             <a:r>
-              <a:t>Funds want low risk and good return. Risk comes from assets that fall together. Twelve assets give four thousand portfolios, twenty-nine give half a billion.</a:t>
+              <a:t>Every fund wants low risk and good returns, but some assets fall together. And the choices explode: four thousand portfolios for twelve assets, half a billion for twenty-nine.</a:t>
             </a:r>
           </a:p>
         </p:txBody>
@@ -795,7 +795,7 @@
           <a:lstStyle/>
           <a:p>
             <a:r>
-              <a:t>Each asset is one qubit: zero means buy, one means skip. Risk minus return becomes an Ising energy. The exact best: Apple plus US bonds.</a:t>
+              <a:t>Each asset gets one qubit: zero means buy, one means skip. Risk minus return becomes an Ising energy, and the lowest energy wins: here, Apple plus US bonds.</a:t>
             </a:r>
           </a:p>
         </p:txBody>
@@ -865,7 +865,7 @@
           <a:lstStyle/>
           <a:p>
             <a:r>
-              <a:t>We trained fifty-eight circuits offline. Best at twelve qubits: CVaR-QAOA, three layers. At twenty-nine qubits: linear-ramp QAOA, with the angles reused.</a:t>
+              <a:t>We trained fifty-eight circuits offline. At twelve qubits, CVaR-QAOA with three layers won. At twenty-nine, we use linear-ramp QAOA with angles tuned at twelve.</a:t>
             </a:r>
           </a:p>
         </p:txBody>
@@ -935,7 +935,7 @@
           <a:lstStyle/>
           <a:p>
             <a:r>
-              <a:t>We compared eight circuit types. The mixer sign, the CVaR objective and more layers mattered most.</a:t>
+              <a:t>Out of eight circuit types, three things mattered most: the mixer sign, the CVaR objective, and more layers.</a:t>
             </a:r>
           </a:p>
         </p:txBody>
@@ -1005,7 +1005,7 @@
           <a:lstStyle/>
           <a:p>
             <a:r>
-              <a:t>Trapped ions connect every pair of qubits, so one layer needs sixty-six two-qubit gates. A heavy-hex chip needs two hundred eighty-five.</a:t>
+              <a:t>Why IonQ? Trapped ions connect any two qubits directly, so one layer needs just sixty-six two-qubit gates, versus two hundred eighty-five on a heavy-hex chip.</a:t>
             </a:r>
           </a:p>
         </p:txBody>
@@ -1075,7 +1075,7 @@
           <a:lstStyle/>
           <a:p>
             <a:r>
-              <a:t>Main result: on the IonQ noise model, seven in a thousand shots were the exact best portfolio, twenty-nine times better than random. Without noise it is fifty-eight.</a:t>
+              <a:t>Our main result: on the IonQ noise model, seven in a thousand shots hit the exact best portfolio. That's twenty-nine times more often than random. Without noise, it's fifty-eight.</a:t>
             </a:r>
           </a:p>
         </p:txBody>
@@ -1145,7 +1145,7 @@
           <a:lstStyle/>
           <a:p>
             <a:r>
-              <a:t>With twenty-nine assets, three layers find the best in seven percent of runs, classical search in sixty-one. Sixteen layers reach ninety percent, but only without noise. No quantum advantage is claimed.</a:t>
+              <a:t>At twenty-nine assets, three layers find the best in seven percent of runs; classical search gets sixty-one. Sixteen layers reach ninety percent, but only without noise. So no quantum advantage here.</a:t>
             </a:r>
           </a:p>
         </p:txBody>
@@ -1215,7 +1215,7 @@
           <a:lstStyle/>
           <a:p>
             <a:r>
-              <a:t>We also tried Iceberg error detection. On the IonQ noise model it flagged three in four shots. The kept shots were not clearly better, because the code doubles the gates.</a:t>
+              <a:t>We also tried Iceberg error detection. It caught errors in three out of four shots, but the kept shots weren't clearly better, because the code doubles the gates.</a:t>
             </a:r>
           </a:p>
         </p:txBody>

</xml_diff>